<commit_message>
experiments: add independent LLM retry audit and evidence deck
</commit_message>
<xml_diff>
--- a/CARE2.0_Nature_evidence_update_2026-08-23.pptx
+++ b/CARE2.0_Nature_evidence_update_2026-08-23.pptx
@@ -2,25 +2,25 @@
 <file path=ppt/presentation.xml><?xml version="1.0" encoding="utf-8"?>
 <p:presentation xmlns:p="http://schemas.openxmlformats.org/presentationml/2006/main">
   <p:sldMasterIdLst>
-    <p:sldMasterId xmlns:r="http://schemas.openxmlformats.org/officeDocument/2006/relationships" id="2147483648" r:id="R16b0536b0cd54fa0"/>
+    <p:sldMasterId xmlns:r="http://schemas.openxmlformats.org/officeDocument/2006/relationships" id="2147483648" r:id="R3876fcbdfa524855"/>
   </p:sldMasterIdLst>
   <p:notesMasterIdLst>
-    <p:notesMasterId xmlns:r="http://schemas.openxmlformats.org/officeDocument/2006/relationships" r:id="R305ea2cecec74a9b"/>
+    <p:notesMasterId xmlns:r="http://schemas.openxmlformats.org/officeDocument/2006/relationships" r:id="R9dd850850c3c4314"/>
   </p:notesMasterIdLst>
   <p:sldIdLst>
-    <p:sldId xmlns:r="http://schemas.openxmlformats.org/officeDocument/2006/relationships" id="256" r:id="R6c719ed21b484c81"/>
-    <p:sldId xmlns:r="http://schemas.openxmlformats.org/officeDocument/2006/relationships" id="257" r:id="R4e74c093084f4883"/>
-    <p:sldId xmlns:r="http://schemas.openxmlformats.org/officeDocument/2006/relationships" id="258" r:id="Rf84d45b9b8764561"/>
-    <p:sldId xmlns:r="http://schemas.openxmlformats.org/officeDocument/2006/relationships" id="259" r:id="R18cce46c39504826"/>
-    <p:sldId xmlns:r="http://schemas.openxmlformats.org/officeDocument/2006/relationships" id="260" r:id="R24cea8aa59d6448f"/>
-    <p:sldId xmlns:r="http://schemas.openxmlformats.org/officeDocument/2006/relationships" id="261" r:id="R762dec46ee874d61"/>
-    <p:sldId xmlns:r="http://schemas.openxmlformats.org/officeDocument/2006/relationships" id="262" r:id="Rfea691b139d74b64"/>
-    <p:sldId xmlns:r="http://schemas.openxmlformats.org/officeDocument/2006/relationships" id="263" r:id="R8b9c0c1597d54ad5"/>
-    <p:sldId xmlns:r="http://schemas.openxmlformats.org/officeDocument/2006/relationships" id="264" r:id="Raee01e3dcaf84784"/>
-    <p:sldId xmlns:r="http://schemas.openxmlformats.org/officeDocument/2006/relationships" id="265" r:id="R7de72b27350f40a5"/>
-    <p:sldId xmlns:r="http://schemas.openxmlformats.org/officeDocument/2006/relationships" id="266" r:id="Rb9996bd44eb14243"/>
-    <p:sldId xmlns:r="http://schemas.openxmlformats.org/officeDocument/2006/relationships" id="267" r:id="Re5152419f534458d"/>
-    <p:sldId xmlns:r="http://schemas.openxmlformats.org/officeDocument/2006/relationships" id="268" r:id="R3d50da6eda9b44de"/>
+    <p:sldId xmlns:r="http://schemas.openxmlformats.org/officeDocument/2006/relationships" id="256" r:id="R1ec7f072d1ed4058"/>
+    <p:sldId xmlns:r="http://schemas.openxmlformats.org/officeDocument/2006/relationships" id="257" r:id="R960c9cd426f14d54"/>
+    <p:sldId xmlns:r="http://schemas.openxmlformats.org/officeDocument/2006/relationships" id="258" r:id="Re7e65f49156d422d"/>
+    <p:sldId xmlns:r="http://schemas.openxmlformats.org/officeDocument/2006/relationships" id="259" r:id="Rcd7fc01b84aa41c4"/>
+    <p:sldId xmlns:r="http://schemas.openxmlformats.org/officeDocument/2006/relationships" id="260" r:id="R042f1477e9bc4ece"/>
+    <p:sldId xmlns:r="http://schemas.openxmlformats.org/officeDocument/2006/relationships" id="261" r:id="R3806ea6ba16e4c02"/>
+    <p:sldId xmlns:r="http://schemas.openxmlformats.org/officeDocument/2006/relationships" id="262" r:id="Raf94e6de04ba4062"/>
+    <p:sldId xmlns:r="http://schemas.openxmlformats.org/officeDocument/2006/relationships" id="263" r:id="R008879d003da4d98"/>
+    <p:sldId xmlns:r="http://schemas.openxmlformats.org/officeDocument/2006/relationships" id="264" r:id="R088c8a29649e4244"/>
+    <p:sldId xmlns:r="http://schemas.openxmlformats.org/officeDocument/2006/relationships" id="265" r:id="R9b62d7396fa447bd"/>
+    <p:sldId xmlns:r="http://schemas.openxmlformats.org/officeDocument/2006/relationships" id="266" r:id="Rc92f9694ba334342"/>
+    <p:sldId xmlns:r="http://schemas.openxmlformats.org/officeDocument/2006/relationships" id="267" r:id="R8e244d1ecb8049c9"/>
+    <p:sldId xmlns:r="http://schemas.openxmlformats.org/officeDocument/2006/relationships" id="268" r:id="Rd8282e320ca8404c"/>
   </p:sldIdLst>
   <p:sldSz cx="12192000" cy="6858000"/>
   <p:notesSz cx="6858000" cy="9144000"/>
@@ -679,7 +679,7 @@
           </a:p>
           <a:p xmlns:a="http://schemas.openxmlformats.org/drawingml/2006/main">
             <a:r>
-              <a:t>整体均值为正，但现有区间不足以支持 confirmatory claim。</a:t>
+              <a:t>第一次重复调用仍是 6 正、2 平、3 负，但路线正负号并不稳定。</a:t>
             </a:r>
           </a:p>
           <a:p xmlns:a="http://schemas.openxmlformats.org/drawingml/2006/main">
@@ -694,7 +694,7 @@
           </a:p>
           <a:p xmlns:a="http://schemas.openxmlformats.org/drawingml/2006/main">
             <a:r>
-              <a:t>所有路线平均 +1.01，route-level bootstrap 95% CI 为 [-0.44,+2.78]。开发路线平均 +1.84，但区间更宽；冻结后化学扩展 5 条路线平均只有 +0.02，3 胜、1 平、1 负。这里的 bootstrap 是对 source-target route 重采样，不能替代同一路线的多次独立 LLM trajectory，也不能替代前瞻湿实验。因此论文里应写“descriptive, route-specific positive signal”，不能写“universal cross-domain transfer”。</a:t>
+              <a:t>v1 冻结协议已经为 11 条路线各完成 1 条独立轨迹，equal-route mean AUC 为 +1.7532。materials expt gap→mp gap 从原来的 -2.4464 翻为 +2.4464；aniline→phenethylamine/AlPhos 从 +0.6286 翻为 -0.7101。独立 v2 的首条 Suzuki 轨迹仍为正，但 AUC 从上一条 +1.38 变为 +0.32，final delta 从 +5.7 变为 +0.4。这说明单条随机 LLM trajectory 不能定义某条路线是否可迁移。当前完成数不足以估计可信区间，confirmatory inference 仍然关闭。</a:t>
             </a:r>
           </a:p>
           <a:p xmlns:a="http://schemas.openxmlformats.org/drawingml/2006/main">
@@ -709,12 +709,17 @@
           </a:p>
           <a:p xmlns:a="http://schemas.openxmlformats.org/drawingml/2006/main">
             <a:r>
-              <a:t>- /Users/rentamac/Documents/Codex/2026-05-12/app-llm-a5labs-tools/care2-opus/experiments/care_replay/results/2026-08-22-submission-evidence-audit/phase_statistics.csv</a:t>
-            </a:r>
-          </a:p>
-          <a:p xmlns:a="http://schemas.openxmlformats.org/drawingml/2006/main">
-            <a:r>
-              <a:t>- /Users/rentamac/Documents/Codex/2026-05-12/app-llm-a5labs-tools/care2-opus/experiments/care_replay/results/2026-08-22-submission-evidence-audit/phase_evidence_summary.svg</a:t>
+              <a:t>- /Users/rentamac/Documents/Codex/2026-05-12/app-llm-a5labs-tools/care2-opus/experiments/care_replay/results/2026-08-23-online-llm-repeated-confirmation-v1/aggregate/repeated_confirmation.json</a:t>
+            </a:r>
+          </a:p>
+          <a:p xmlns:a="http://schemas.openxmlformats.org/drawingml/2006/main">
+            <a:r>
+              <a:t>- /Users/rentamac/Documents/Codex/2026-05-12/app-llm-a5labs-tools/care2-opus/experiments/care_replay/results/2026-08-23-online-llm-repeated-confirmation-v1/aggregate/repeated_route_effects.svg</a:t>
+            </a:r>
+          </a:p>
+          <a:p xmlns:a="http://schemas.openxmlformats.org/drawingml/2006/main">
+            <a:r>
+              <a:t>- /Users/rentamac/Documents/Codex/2026-05-12/app-llm-a5labs-tools/care2-opus/experiments/care_replay/results/2026-08-23-online-llm-repeated-confirmation-v2/reizman_cases_123_to_case4/trajectory_2000/summary.json</a:t>
             </a:r>
           </a:p>
         </p:txBody>
@@ -899,7 +904,7 @@
           </a:p>
           <a:p xmlns:a="http://schemas.openxmlformats.org/drawingml/2006/main">
             <a:r>
-              <a:t>下一步不再追求更多漂亮开发结果，而是补齐能经受审稿的确认性证据。</a:t>
+              <a:t>重复协议已经真正启动，但完成前不能把 pilot 当成统计确认。</a:t>
             </a:r>
           </a:p>
           <a:p xmlns:a="http://schemas.openxmlformats.org/drawingml/2006/main">
@@ -914,7 +919,7 @@
           </a:p>
           <a:p xmlns:a="http://schemas.openxmlformats.org/drawingml/2006/main">
             <a:r>
-              <a:t>第一，锁定 prompt、模型、预算和主要指标，在关键路线上做 30–50 条独立 trajectory。第二，保留一批从未参与调参的新 source-target pair，事先登记分析。第三，完成至少一条真实前瞻实验，直接比较单位实验成本下的发现速度。第四，用消融分解 source evidence、critic、gate 和 LLM authority 的贡献。最后，开放代码、数据版本、模型与 trace 哈希、精确统计和负结果。</a:t>
+              <a:t>v1 已完成 11/330 条轨迹，v2 独立确认已完成 1/330。v2 还把 API 限额、超时、模型格式错误和科学结果差明确分开：只有基础设施故障能按冻结规则重试，所有尝试都保存；模型验证失败是终止事件；结果差绝不会触发重跑。下一步是在资金和端点稳定后完成全部轨迹，同时保留全新任务家族和至少一条前瞻湿实验。消融仍需要分别移除 source evidence、critic、gate 和 LLM authority。</a:t>
             </a:r>
           </a:p>
           <a:p xmlns:a="http://schemas.openxmlformats.org/drawingml/2006/main">
@@ -930,6 +935,16 @@
           <a:p xmlns:a="http://schemas.openxmlformats.org/drawingml/2006/main">
             <a:r>
               <a:t>- /Users/rentamac/Documents/Codex/2026-05-12/app-llm-a5labs-tools/care2-opus/docs/NATURE_SUBMISSION_READINESS.md</a:t>
+            </a:r>
+          </a:p>
+          <a:p xmlns:a="http://schemas.openxmlformats.org/drawingml/2006/main">
+            <a:r>
+              <a:t>- /Users/rentamac/Documents/Codex/2026-05-12/app-llm-a5labs-tools/care2-opus/experiments/care_replay/configs/online_llm_repeated_confirmation_v2.json</a:t>
+            </a:r>
+          </a:p>
+          <a:p xmlns:a="http://schemas.openxmlformats.org/drawingml/2006/main">
+            <a:r>
+              <a:t>- /Users/rentamac/Documents/Codex/2026-05-12/app-llm-a5labs-tools/care2-opus/experiments/care_replay/scripts/run_repeated_online_llm_confirmation_v2.py</a:t>
             </a:r>
           </a:p>
           <a:p xmlns:a="http://schemas.openxmlformats.org/drawingml/2006/main">
@@ -1887,7 +1902,7 @@
   </p:cSld>
   <p:clrMap bg1="lt1" tx1="dk1" bg2="lt2" tx2="dk2" accent1="accent1" accent2="accent2" accent3="accent3" accent4="accent4" accent5="accent5" accent6="accent6" hlink="hlink" folHlink="folHlink"/>
   <p:sldLayoutIdLst>
-    <p:sldLayoutId xmlns:r="http://schemas.openxmlformats.org/officeDocument/2006/relationships" id="2147483649" r:id="R0cb14fdae9444bf8"/>
+    <p:sldLayoutId xmlns:r="http://schemas.openxmlformats.org/officeDocument/2006/relationships" id="2147483649" r:id="R60adce59a24246e5"/>
   </p:sldLayoutIdLst>
   <p:txStyles>
     <p:titleStyle>
@@ -3459,7 +3474,7 @@
           <p:nvPr/>
         </p:nvPicPr>
         <p:blipFill>
-          <a:blip xmlns:r="http://schemas.openxmlformats.org/officeDocument/2006/relationships" xmlns:a="http://schemas.openxmlformats.org/drawingml/2006/main" r:embed="R8b5c22dd49d546a5"/>
+          <a:blip xmlns:r="http://schemas.openxmlformats.org/officeDocument/2006/relationships" xmlns:a="http://schemas.openxmlformats.org/drawingml/2006/main" r:embed="R9d8c629981f640d2"/>
           <a:srcRect xmlns:a="http://schemas.openxmlformats.org/drawingml/2006/main" l="0" t="0" r="0" b="43396"/>
           <a:stretch xmlns:a="http://schemas.openxmlformats.org/drawingml/2006/main"/>
         </p:blipFill>
@@ -3745,7 +3760,7 @@
                 <a:ea typeface="Arial Unicode MS"/>
                 <a:cs typeface="Arial Unicode MS"/>
               </a:rPr>
-              <a:t>平均 +1.01，但 95% bootstrap 区间仍跨过 0</a:t>
+              <a:t>第一次重复调用仍是 6 / 2 / 3，但部分路线改变了正负号</a:t>
             </a:r>
           </a:p>
         </p:txBody>
@@ -3790,8 +3805,8 @@
           <p:nvPr/>
         </p:nvPicPr>
         <p:blipFill>
-          <a:blip xmlns:r="http://schemas.openxmlformats.org/officeDocument/2006/relationships" xmlns:a="http://schemas.openxmlformats.org/drawingml/2006/main" r:embed="R46c868bd98ca4d63"/>
-          <a:srcRect xmlns:a="http://schemas.openxmlformats.org/drawingml/2006/main" l="0" t="56604" r="0" b="0"/>
+          <a:blip xmlns:r="http://schemas.openxmlformats.org/officeDocument/2006/relationships" xmlns:a="http://schemas.openxmlformats.org/drawingml/2006/main" r:embed="R1e928dc4fab34298"/>
+          <a:srcRect xmlns:a="http://schemas.openxmlformats.org/drawingml/2006/main" l="0" t="0" r="0" b="0"/>
           <a:stretch xmlns:a="http://schemas.openxmlformats.org/drawingml/2006/main"/>
         </p:blipFill>
         <p:spPr>
@@ -4498,7 +4513,7 @@
                 <a:ea typeface="Arial Unicode MS"/>
                 <a:cs typeface="Arial Unicode MS"/>
               </a:rPr>
-              <a:t>• 每条路线的重复 LLM 轨迹</a:t>
+              <a:t>• 每条路线足量、独立的 LLM 重复</a:t>
             </a:r>
           </a:p>
           <a:p xmlns:a="http://schemas.openxmlformats.org/drawingml/2006/main">
@@ -5212,7 +5227,7 @@
                 <a:ea typeface="Arial Unicode MS"/>
                 <a:cs typeface="Arial Unicode MS"/>
               </a:rPr>
-              <a:t>下一轮只做能改变论文结论的实验</a:t>
+              <a:t>独立重复已经启动，下一步完成冻结确认</a:t>
             </a:r>
           </a:p>
         </p:txBody>
@@ -5429,7 +5444,7 @@
                 <a:ea typeface="Arial Unicode MS"/>
                 <a:cs typeface="Arial Unicode MS"/>
               </a:rPr>
-              <a:t>每条关键路线运行 30–50 条独立 LLM trajectory；锁定 prompt、模型和预算。</a:t>
+              <a:t>v1 已完成 11 / 330；v2 已完成 1 / 330。全部完成前不做确认性推断。</a:t>
             </a:r>
           </a:p>
         </p:txBody>
@@ -5646,7 +5661,7 @@
                 <a:ea typeface="Arial Unicode MS"/>
                 <a:cs typeface="Arial Unicode MS"/>
               </a:rPr>
-              <a:t>保留未参与任何调参的新 source-target pair，并预注册主要指标和分析。</a:t>
+              <a:t>保留未参与任何调参的新 source-target pair，并预注册主要指标、失败处理和分析。</a:t>
             </a:r>
           </a:p>
         </p:txBody>
@@ -6605,7 +6620,7 @@
                 <a:ea typeface="Arial Unicode MS"/>
                 <a:cs typeface="Arial Unicode MS"/>
               </a:rPr>
-              <a:t>LLM 全程参与了 11 条真实数据迁移路线</a:t>
+              <a:t>LLM 全程参与 11 条真实路线，独立重复已经启动</a:t>
             </a:r>
           </a:p>
         </p:txBody>

</xml_diff>

<commit_message>
experiments: add matched transfer baselines and audited LLM evidence
</commit_message>
<xml_diff>
--- a/CARE2.0_Nature_evidence_update_2026-08-23.pptx
+++ b/CARE2.0_Nature_evidence_update_2026-08-23.pptx
@@ -2,25 +2,26 @@
 <file path=ppt/presentation.xml><?xml version="1.0" encoding="utf-8"?>
 <p:presentation xmlns:p="http://schemas.openxmlformats.org/presentationml/2006/main">
   <p:sldMasterIdLst>
-    <p:sldMasterId xmlns:r="http://schemas.openxmlformats.org/officeDocument/2006/relationships" id="2147483648" r:id="R3876fcbdfa524855"/>
+    <p:sldMasterId xmlns:r="http://schemas.openxmlformats.org/officeDocument/2006/relationships" id="2147483648" r:id="Rf55fde6a86394190"/>
   </p:sldMasterIdLst>
   <p:notesMasterIdLst>
-    <p:notesMasterId xmlns:r="http://schemas.openxmlformats.org/officeDocument/2006/relationships" r:id="R9dd850850c3c4314"/>
+    <p:notesMasterId xmlns:r="http://schemas.openxmlformats.org/officeDocument/2006/relationships" r:id="R372e691b6a684f7c"/>
   </p:notesMasterIdLst>
   <p:sldIdLst>
-    <p:sldId xmlns:r="http://schemas.openxmlformats.org/officeDocument/2006/relationships" id="256" r:id="R1ec7f072d1ed4058"/>
-    <p:sldId xmlns:r="http://schemas.openxmlformats.org/officeDocument/2006/relationships" id="257" r:id="R960c9cd426f14d54"/>
-    <p:sldId xmlns:r="http://schemas.openxmlformats.org/officeDocument/2006/relationships" id="258" r:id="Re7e65f49156d422d"/>
-    <p:sldId xmlns:r="http://schemas.openxmlformats.org/officeDocument/2006/relationships" id="259" r:id="Rcd7fc01b84aa41c4"/>
-    <p:sldId xmlns:r="http://schemas.openxmlformats.org/officeDocument/2006/relationships" id="260" r:id="R042f1477e9bc4ece"/>
-    <p:sldId xmlns:r="http://schemas.openxmlformats.org/officeDocument/2006/relationships" id="261" r:id="R3806ea6ba16e4c02"/>
-    <p:sldId xmlns:r="http://schemas.openxmlformats.org/officeDocument/2006/relationships" id="262" r:id="Raf94e6de04ba4062"/>
-    <p:sldId xmlns:r="http://schemas.openxmlformats.org/officeDocument/2006/relationships" id="263" r:id="R008879d003da4d98"/>
-    <p:sldId xmlns:r="http://schemas.openxmlformats.org/officeDocument/2006/relationships" id="264" r:id="R088c8a29649e4244"/>
-    <p:sldId xmlns:r="http://schemas.openxmlformats.org/officeDocument/2006/relationships" id="265" r:id="R9b62d7396fa447bd"/>
-    <p:sldId xmlns:r="http://schemas.openxmlformats.org/officeDocument/2006/relationships" id="266" r:id="Rc92f9694ba334342"/>
-    <p:sldId xmlns:r="http://schemas.openxmlformats.org/officeDocument/2006/relationships" id="267" r:id="R8e244d1ecb8049c9"/>
-    <p:sldId xmlns:r="http://schemas.openxmlformats.org/officeDocument/2006/relationships" id="268" r:id="Rd8282e320ca8404c"/>
+    <p:sldId xmlns:r="http://schemas.openxmlformats.org/officeDocument/2006/relationships" id="256" r:id="R9f82da3149464481"/>
+    <p:sldId xmlns:r="http://schemas.openxmlformats.org/officeDocument/2006/relationships" id="257" r:id="Rb9c382a4e2184730"/>
+    <p:sldId xmlns:r="http://schemas.openxmlformats.org/officeDocument/2006/relationships" id="258" r:id="R447fd42427ec4d93"/>
+    <p:sldId xmlns:r="http://schemas.openxmlformats.org/officeDocument/2006/relationships" id="259" r:id="Raac42eeaec7346e7"/>
+    <p:sldId xmlns:r="http://schemas.openxmlformats.org/officeDocument/2006/relationships" id="260" r:id="R84e48c17e5064842"/>
+    <p:sldId xmlns:r="http://schemas.openxmlformats.org/officeDocument/2006/relationships" id="261" r:id="Rdfbe113b226f47c0"/>
+    <p:sldId xmlns:r="http://schemas.openxmlformats.org/officeDocument/2006/relationships" id="262" r:id="R2f79a5881c444b43"/>
+    <p:sldId xmlns:r="http://schemas.openxmlformats.org/officeDocument/2006/relationships" id="263" r:id="R32705afeb31d4fb4"/>
+    <p:sldId xmlns:r="http://schemas.openxmlformats.org/officeDocument/2006/relationships" id="264" r:id="R8467e1d973c14162"/>
+    <p:sldId xmlns:r="http://schemas.openxmlformats.org/officeDocument/2006/relationships" id="265" r:id="Rad58a4d7baa04682"/>
+    <p:sldId xmlns:r="http://schemas.openxmlformats.org/officeDocument/2006/relationships" id="266" r:id="Ra6b076d7d771451f"/>
+    <p:sldId xmlns:r="http://schemas.openxmlformats.org/officeDocument/2006/relationships" id="267" r:id="Rf5799cb0bc7c435b"/>
+    <p:sldId xmlns:r="http://schemas.openxmlformats.org/officeDocument/2006/relationships" id="268" r:id="R442c462d768d47a7"/>
+    <p:sldId xmlns:r="http://schemas.openxmlformats.org/officeDocument/2006/relationships" id="269" r:id="R2a35a5ec02ec4051"/>
   </p:sldIdLst>
   <p:sldSz cx="12192000" cy="6858000"/>
   <p:notesSz cx="6858000" cy="9144000"/>
@@ -679,7 +680,7 @@
           </a:p>
           <a:p xmlns:a="http://schemas.openxmlformats.org/drawingml/2006/main">
             <a:r>
-              <a:t>第一次重复调用仍是 6 正、2 平、3 负，但路线正负号并不稳定。</a:t>
+              <a:t>两批调用的总体胜平负都为 6 / 2 / 3，但 11 条配对路线中有 4 条严格翻转正负号。</a:t>
             </a:r>
           </a:p>
           <a:p xmlns:a="http://schemas.openxmlformats.org/drawingml/2006/main">
@@ -694,7 +695,7 @@
           </a:p>
           <a:p xmlns:a="http://schemas.openxmlformats.org/drawingml/2006/main">
             <a:r>
-              <a:t>v1 冻结协议已经为 11 条路线各完成 1 条独立轨迹，equal-route mean AUC 为 +1.7532。materials expt gap→mp gap 从原来的 -2.4464 翻为 +2.4464；aniline→phenethylamine/AlPhos 从 +0.6286 翻为 -0.7101。独立 v2 的首条 Suzuki 轨迹仍为正，但 AUC 从上一条 +1.38 变为 +0.32，final delta 从 +5.7 变为 +0.4。这说明单条随机 LLM trajectory 不能定义某条路线是否可迁移。当前完成数不足以估计可信区间，confirmatory inference 仍然关闭。</a:t>
+              <a:t>空心点是早期审计调用，蓝绿色点是第一次冻结重复，橙色菱形是 Suzuki 的第二次冻结重复。材料 expt gap→mp gap、两条 phenethylamine 路线和 aniline→benzamide 路线发生了严格符号翻转。Suzuki 三次观察为 +0.28、+1.38 和 +0.32，方向一致但幅度仍有波动。早期调用发生在确认协议冻结前，因此本页只是 stochasticity audit，不是正式重复检验；它证明了为什么不能用单次 LLM 结果给路线贴上“可迁移/不可迁移”的稳定标签。</a:t>
             </a:r>
           </a:p>
           <a:p xmlns:a="http://schemas.openxmlformats.org/drawingml/2006/main">
@@ -709,17 +710,22 @@
           </a:p>
           <a:p xmlns:a="http://schemas.openxmlformats.org/drawingml/2006/main">
             <a:r>
-              <a:t>- /Users/rentamac/Documents/Codex/2026-05-12/app-llm-a5labs-tools/care2-opus/experiments/care_replay/results/2026-08-23-online-llm-repeated-confirmation-v1/aggregate/repeated_confirmation.json</a:t>
-            </a:r>
-          </a:p>
-          <a:p xmlns:a="http://schemas.openxmlformats.org/drawingml/2006/main">
-            <a:r>
-              <a:t>- /Users/rentamac/Documents/Codex/2026-05-12/app-llm-a5labs-tools/care2-opus/experiments/care_replay/results/2026-08-23-online-llm-repeated-confirmation-v1/aggregate/repeated_route_effects.svg</a:t>
-            </a:r>
-          </a:p>
-          <a:p xmlns:a="http://schemas.openxmlformats.org/drawingml/2006/main">
-            <a:r>
-              <a:t>- /Users/rentamac/Documents/Codex/2026-05-12/app-llm-a5labs-tools/care2-opus/experiments/care_replay/results/2026-08-23-online-llm-repeated-confirmation-v2/reizman_cases_123_to_case4/trajectory_2000/summary.json</a:t>
+              <a:t>- /Users/rentamac/Documents/Codex/2026-05-12/app-llm-a5labs-tools/care2-opus/experiments/care_replay/results/2026-08-23-llm-trajectory-stability-audit/paired_route_stability.csv</a:t>
+            </a:r>
+          </a:p>
+          <a:p xmlns:a="http://schemas.openxmlformats.org/drawingml/2006/main">
+            <a:r>
+              <a:t>- /Users/rentamac/Documents/Codex/2026-05-12/app-llm-a5labs-tools/care2-opus/experiments/care_replay/results/2026-08-23-llm-trajectory-stability-audit/paired_route_stability.svg</a:t>
+            </a:r>
+          </a:p>
+          <a:p xmlns:a="http://schemas.openxmlformats.org/drawingml/2006/main">
+            <a:r>
+              <a:t>- /Users/rentamac/Documents/Codex/2026-05-12/app-llm-a5labs-tools/care2-opus/experiments/care_replay/results/2026-08-23-llm-trajectory-stability-audit/stability_audit.json</a:t>
+            </a:r>
+          </a:p>
+          <a:p xmlns:a="http://schemas.openxmlformats.org/drawingml/2006/main">
+            <a:r>
+              <a:t>- https://arxiv.org/abs/2410.03492</a:t>
             </a:r>
           </a:p>
         </p:txBody>
@@ -794,7 +800,7 @@
           </a:p>
           <a:p xmlns:a="http://schemas.openxmlformats.org/drawingml/2006/main">
             <a:r>
-              <a:t>这页把已完成的工程能力和仍缺失的科学证据分开。</a:t>
+              <a:t>材料案例说明 LLM 的价值也包括识别“不应该直接迁移”，并且 trace 能暴露和修复解释错误。</a:t>
             </a:r>
           </a:p>
           <a:p xmlns:a="http://schemas.openxmlformats.org/drawingml/2006/main">
@@ -809,7 +815,7 @@
           </a:p>
           <a:p xmlns:a="http://schemas.openxmlformats.org/drawingml/2006/main">
             <a:r>
-              <a:t>已完成部分包括无泄漏 replay、同预算主对照、三个任务家族、每轮真实 LLM 决策和完整 trace。仍缺的关键证据是：同一路线多次独立 trajectory、完全冻结的新任务家族，以及至少一条 prospective/wet-lab campaign。另一个重要边界是：当前系统会更新 run-level state 和 GP，不会训练模型参数，也没有自动把 trace 蒸馏成可复用 skill。</a:t>
+              <a:t>在 phonons→bulk modulus 路线上，LLM 十轮都关闭 direct source transfer，因为 target 证据不支持把声子峰排名直接搬到体模量。但它仍根据材料组成语义和已揭示 target 结果，在 4/10 轮选择了非 GP rank 1 候选。CARE 最终找到 normalized score 77.6127 的 O8Pt6；同开局 GP 最终为 73.2886。AUC 增益 +3.240，final 增益 +4.324。这里应讲成“负迁移识别 + target 自适应”，不能讲成 phonon outcome 正向迁移。早期 trace 有 5 次把无量纲 replay score 写成 GPa；加入 outcome-scale contract 后，新轨迹 20 个 proposer/critic 响应中该错误为 0。新轨迹的 AUC 增益为 +3.083，但它与旧轨迹不是配对调用，因此只用于验证语义修复，不用于声称性能提升。</a:t>
             </a:r>
           </a:p>
           <a:p xmlns:a="http://schemas.openxmlformats.org/drawingml/2006/main">
@@ -824,12 +830,27 @@
           </a:p>
           <a:p xmlns:a="http://schemas.openxmlformats.org/drawingml/2006/main">
             <a:r>
-              <a:t>- /Users/rentamac/Documents/Codex/2026-05-12/app-llm-a5labs-tools/care2-opus/docs/NATURE_SUBMISSION_READINESS.md</a:t>
-            </a:r>
-          </a:p>
-          <a:p xmlns:a="http://schemas.openxmlformats.org/drawingml/2006/main">
-            <a:r>
-              <a:t>- /Users/rentamac/Documents/Codex/2026-05-12/app-llm-a5labs-tools/care2-opus/experiments/care_replay/results/2026-08-22-submission-evidence-audit/EVIDENCE_AUDIT.md</a:t>
+              <a:t>- /Users/rentamac/Documents/Codex/2026-05-12/app-llm-a5labs-tools/care2-opus/experiments/care_replay/results/2026-08-24-online-llm-transport-context-robustness-v3/materials_phonons_to_bulk_modulus/trajectory_5000/summary.json</a:t>
+            </a:r>
+          </a:p>
+          <a:p xmlns:a="http://schemas.openxmlformats.org/drawingml/2006/main">
+            <a:r>
+              <a:t>- /Users/rentamac/Documents/Codex/2026-05-12/app-llm-a5labs-tools/care2-opus/experiments/care_replay/results/2026-08-24-online-llm-transport-context-robustness-v3/materials_phonons_to_bulk_modulus/trajectory_5000/llm_trace.jsonl</a:t>
+            </a:r>
+          </a:p>
+          <a:p xmlns:a="http://schemas.openxmlformats.org/drawingml/2006/main">
+            <a:r>
+              <a:t>- /Users/rentamac/Documents/Codex/2026-05-12/app-llm-a5labs-tools/care2-opus/experiments/care_replay/results/2026-08-24-online-llm-transport-context-robustness-v3/materials_phonons_to_bulk_modulus/trajectory_5000/audit/materials_online_trace_audit.json</a:t>
+            </a:r>
+          </a:p>
+          <a:p xmlns:a="http://schemas.openxmlformats.org/drawingml/2006/main">
+            <a:r>
+              <a:t>- /Users/rentamac/Documents/Codex/2026-05-12/app-llm-a5labs-tools/care2-opus/experiments/care_replay/results/2026-08-24-online-llm-outcome-semantics-robustness-v1/materials_phonons_to_bulk_modulus/trajectory_6000/summary.json</a:t>
+            </a:r>
+          </a:p>
+          <a:p xmlns:a="http://schemas.openxmlformats.org/drawingml/2006/main">
+            <a:r>
+              <a:t>- /Users/rentamac/Documents/Codex/2026-05-12/app-llm-a5labs-tools/care2-opus/experiments/care_replay/results/2026-08-24-online-llm-outcome-semantics-robustness-v1/materials_phonons_to_bulk_modulus/trajectory_6000/audit/outcome_semantics_audit.json</a:t>
             </a:r>
           </a:p>
         </p:txBody>
@@ -904,7 +925,7 @@
           </a:p>
           <a:p xmlns:a="http://schemas.openxmlformats.org/drawingml/2006/main">
             <a:r>
-              <a:t>重复协议已经真正启动，但完成前不能把 pilot 当成统计确认。</a:t>
+              <a:t>这页把已完成的工程能力和仍缺失的科学证据分开。</a:t>
             </a:r>
           </a:p>
           <a:p xmlns:a="http://schemas.openxmlformats.org/drawingml/2006/main">
@@ -919,7 +940,7 @@
           </a:p>
           <a:p xmlns:a="http://schemas.openxmlformats.org/drawingml/2006/main">
             <a:r>
-              <a:t>v1 已完成 11/330 条轨迹，v2 独立确认已完成 1/330。v2 还把 API 限额、超时、模型格式错误和科学结果差明确分开：只有基础设施故障能按冻结规则重试，所有尝试都保存；模型验证失败是终止事件；结果差绝不会触发重跑。下一步是在资金和端点稳定后完成全部轨迹，同时保留全新任务家族和至少一条前瞻湿实验。消融仍需要分别移除 source evidence、critic、gate 和 LLM authority。</a:t>
+              <a:t>context-preserving 协议下的分子、材料和 Suzuki 三条单轨迹均相对同开局 GP 为正，但只有分子和 Suzuki 保留了部分 direct source transfer；材料结果来自 abstention 后的 target 自适应。三条都只是 n=1 development evidence。当前系统更新 run-level state、GP 和假设，不训练模型参数，也没有自动把 trace 蒸馏成可复用 skill。</a:t>
             </a:r>
           </a:p>
           <a:p xmlns:a="http://schemas.openxmlformats.org/drawingml/2006/main">
@@ -939,12 +960,142 @@
           </a:p>
           <a:p xmlns:a="http://schemas.openxmlformats.org/drawingml/2006/main">
             <a:r>
-              <a:t>- /Users/rentamac/Documents/Codex/2026-05-12/app-llm-a5labs-tools/care2-opus/experiments/care_replay/configs/online_llm_repeated_confirmation_v2.json</a:t>
-            </a:r>
-          </a:p>
-          <a:p xmlns:a="http://schemas.openxmlformats.org/drawingml/2006/main">
-            <a:r>
-              <a:t>- /Users/rentamac/Documents/Codex/2026-05-12/app-llm-a5labs-tools/care2-opus/experiments/care_replay/scripts/run_repeated_online_llm_confirmation_v2.py</a:t>
+              <a:t>- /Users/rentamac/Documents/Codex/2026-05-12/app-llm-a5labs-tools/care2-opus/experiments/care_replay/results/2026-08-24-online-llm-transport-context-robustness-v3/aggregate/repeated_confirmation.json</a:t>
+            </a:r>
+          </a:p>
+        </p:txBody>
+      </p:sp>
+      <p:sp>
+        <p:nvSpPr>
+          <p:cNvPr id="4" name="Slide Number Placeholder 3"/>
+          <p:cNvSpPr>
+            <a:spLocks xmlns:a="http://schemas.openxmlformats.org/drawingml/2006/main" noGrp="1"/>
+          </p:cNvSpPr>
+          <p:nvPr>
+            <p:ph type="sldNum" idx="5"/>
+          </p:nvPr>
+        </p:nvSpPr>
+        <p:spPr/>
+        <p:txBody>
+          <a:bodyPr xmlns:a="http://schemas.openxmlformats.org/drawingml/2006/main"/>
+          <a:lstStyle xmlns:a="http://schemas.openxmlformats.org/drawingml/2006/main"/>
+          <a:p xmlns:a="http://schemas.openxmlformats.org/drawingml/2006/main"/>
+        </p:txBody>
+      </p:sp>
+    </p:spTree>
+  </p:cSld>
+  <p:clrMapOvr>
+    <a:masterClrMapping xmlns:a="http://schemas.openxmlformats.org/drawingml/2006/main"/>
+  </p:clrMapOvr>
+</p:notes>
+</file>
+
+<file path=ppt/notesSlides/notesSlide14.xml><?xml version="1.0" encoding="utf-8"?>
+<p:notes xmlns:p="http://schemas.openxmlformats.org/presentationml/2006/main">
+  <p:cSld>
+    <p:spTree>
+      <p:nvGrpSpPr>
+        <p:cNvPr id="1" name=""/>
+        <p:cNvGrpSpPr/>
+        <p:nvPr/>
+      </p:nvGrpSpPr>
+      <p:grpSpPr>
+        <a:xfrm xmlns:a="http://schemas.openxmlformats.org/drawingml/2006/main"/>
+      </p:grpSpPr>
+      <p:sp>
+        <p:nvSpPr>
+          <p:cNvPr id="2" name="Slide Image Placeholder 1"/>
+          <p:cNvSpPr>
+            <a:spLocks xmlns:a="http://schemas.openxmlformats.org/drawingml/2006/main" noGrp="1"/>
+          </p:cNvSpPr>
+          <p:nvPr>
+            <p:ph type="sldImg" idx="0"/>
+          </p:nvPr>
+        </p:nvSpPr>
+        <p:spPr/>
+      </p:sp>
+      <p:sp>
+        <p:nvSpPr>
+          <p:cNvPr id="3" name="Notes Placeholder 2"/>
+          <p:cNvSpPr>
+            <a:spLocks xmlns:a="http://schemas.openxmlformats.org/drawingml/2006/main" noGrp="1"/>
+          </p:cNvSpPr>
+          <p:nvPr>
+            <p:ph type="body" idx="1"/>
+          </p:nvPr>
+        </p:nvSpPr>
+        <p:spPr/>
+        <p:txBody>
+          <a:bodyPr xmlns:a="http://schemas.openxmlformats.org/drawingml/2006/main"/>
+          <a:lstStyle xmlns:a="http://schemas.openxmlformats.org/drawingml/2006/main"/>
+          <a:p xmlns:a="http://schemas.openxmlformats.org/drawingml/2006/main">
+            <a:r>
+              <a:t>本页核心</a:t>
+            </a:r>
+          </a:p>
+          <a:p xmlns:a="http://schemas.openxmlformats.org/drawingml/2006/main">
+            <a:r>
+              <a:t>下一步必须同时完成重复、预先选型的强 transfer baseline 和前瞻实验。</a:t>
+            </a:r>
+          </a:p>
+          <a:p xmlns:a="http://schemas.openxmlformats.org/drawingml/2006/main">
+            <a:r>
+              <a:t/>
+            </a:r>
+          </a:p>
+          <a:p xmlns:a="http://schemas.openxmlformats.org/drawingml/2006/main">
+            <a:r>
+              <a:t>讲解</a:t>
+            </a:r>
+          </a:p>
+          <a:p xmlns:a="http://schemas.openxmlformats.org/drawingml/2006/main">
+            <a:r>
+              <a:t>Opus 冻结 v1 已完成 11/330；context-preserving development 协议另完成分子、材料和 Suzuki 各一条。GLM 仍没有完整轨迹，因此不能报告跨模型效果。同开局 classical stress test 已经完成三条路线，说明分子和材料案例能超过 RGPE/ICM，但 Suzuki 的 multisource ICM-BMA 仍更强。下一步要在看结果前固定 baseline 选择规则，把在线 LLM、RGPE、multitask GP-ICM 和 target-only GP 放进同一个重复协议。最终还需要未参与调参的任务家族和至少一条真实 prospective/wet-lab campaign。</a:t>
+            </a:r>
+          </a:p>
+          <a:p xmlns:a="http://schemas.openxmlformats.org/drawingml/2006/main">
+            <a:r>
+              <a:t/>
+            </a:r>
+          </a:p>
+          <a:p xmlns:a="http://schemas.openxmlformats.org/drawingml/2006/main">
+            <a:r>
+              <a:t>[Sources]</a:t>
+            </a:r>
+          </a:p>
+          <a:p xmlns:a="http://schemas.openxmlformats.org/drawingml/2006/main">
+            <a:r>
+              <a:t>- /Users/rentamac/Documents/Codex/2026-05-12/app-llm-a5labs-tools/care2-opus/docs/NATURE_SUBMISSION_READINESS.md</a:t>
+            </a:r>
+          </a:p>
+          <a:p xmlns:a="http://schemas.openxmlformats.org/drawingml/2006/main">
+            <a:r>
+              <a:t>- /Users/rentamac/Documents/Codex/2026-05-12/app-llm-a5labs-tools/care2-opus/docs/GLM53_CROSS_MODEL_PROTOCOL.md</a:t>
+            </a:r>
+          </a:p>
+          <a:p xmlns:a="http://schemas.openxmlformats.org/drawingml/2006/main">
+            <a:r>
+              <a:t>- /Users/rentamac/Documents/Codex/2026-05-12/app-llm-a5labs-tools/care2-opus/experiments/care_replay/configs/online_llm_transport_context_robustness_v2.json</a:t>
+            </a:r>
+          </a:p>
+          <a:p xmlns:a="http://schemas.openxmlformats.org/drawingml/2006/main">
+            <a:r>
+              <a:t>- /Users/rentamac/Documents/Codex/2026-05-12/app-llm-a5labs-tools/care2-opus/experiments/care_replay/configs/online_llm_matched_classical_audit_v1.json</a:t>
+            </a:r>
+          </a:p>
+          <a:p xmlns:a="http://schemas.openxmlformats.org/drawingml/2006/main">
+            <a:r>
+              <a:t>- /Users/rentamac/Documents/Codex/2026-05-12/app-llm-a5labs-tools/care2-opus/experiments/care_replay/results/2026-08-24-online-llm-matched-classical-audit-v1/aggregate.json</a:t>
+            </a:r>
+          </a:p>
+          <a:p xmlns:a="http://schemas.openxmlformats.org/drawingml/2006/main">
+            <a:r>
+              <a:t>- https://www.nature.com/articles/s41524-025-01851-8</a:t>
+            </a:r>
+          </a:p>
+          <a:p xmlns:a="http://schemas.openxmlformats.org/drawingml/2006/main">
+            <a:r>
+              <a:t>- https://www.nature.com/articles/s41467-025-64105-7</a:t>
             </a:r>
           </a:p>
           <a:p xmlns:a="http://schemas.openxmlformats.org/drawingml/2006/main">
@@ -1579,7 +1730,7 @@
           </a:p>
           <a:p xmlns:a="http://schemas.openxmlformats.org/drawingml/2006/main">
             <a:r>
-              <a:t>最重要的主对照是同开局 target-only GP，而不是随机搜索。</a:t>
+              <a:t>主比较用同开局 target-only GP 隔离在线 LLM 增量，并用 RGPE 与 multitask GP 做同条件压力测试。</a:t>
             </a:r>
           </a:p>
           <a:p xmlns:a="http://schemas.openxmlformats.org/drawingml/2006/main">
@@ -1594,7 +1745,7 @@
           </a:p>
           <a:p xmlns:a="http://schemas.openxmlformats.org/drawingml/2006/main">
             <a:r>
-              <a:t>在线 LLM Scientist 和主对照使用完全相同的三个初始 target 观测、候选空间和 10 轮预算。区别只在后续：LLM 组每轮能读取 source evidence，并由 proposer + critic 决定候选；对照组只用 target 观测拟合 GP-UCB。固定 v2 仍保留为辅助对照，用来分解“初始设计”和“在线 LLM 决策”各自贡献。</a:t>
+              <a:t>在线 LLM Scientist 和所有 baseline 使用完全相同的三个初始 target 观测、候选空间和 10 轮预算。重放程序首先要求 target-only GP 精确复现在线 runner 保存的 AUC 和 final，确认开局与预算一致。FreeSolv→Lipophilicity 的在线 LLM 比三者中最强的 target GP 高 +6.325 AUC；phonons→bulk modulus 比最强的 RGPE 高 +1.922；Suzuki 则比 multisource ICM-BMA 低 1.960。三条路线相对事后最强 baseline 的等权平均为 +2.096，2/3 路线获胜。这里的“最强”是看完结果后的 oracle stress test，不是预先 calibration 的确认性比较。</a:t>
             </a:r>
           </a:p>
           <a:p xmlns:a="http://schemas.openxmlformats.org/drawingml/2006/main">
@@ -1609,12 +1760,27 @@
           </a:p>
           <a:p xmlns:a="http://schemas.openxmlformats.org/drawingml/2006/main">
             <a:r>
-              <a:t>- /Users/rentamac/Documents/Codex/2026-05-12/app-llm-a5labs-tools/care2-opus/experiments/care_replay/results/2026-08-16-opus48-bounded-ei-development-v2/aggregate/RESULTS.md</a:t>
-            </a:r>
-          </a:p>
-          <a:p xmlns:a="http://schemas.openxmlformats.org/drawingml/2006/main">
-            <a:r>
-              <a:t>- /Users/rentamac/Documents/Codex/2026-05-12/app-llm-a5labs-tools/care2-opus/experiments/care_replay/results/2026-08-16-opus48-high-authority-chemistry-holdout-v1/aggregate/RESULTS.md</a:t>
+              <a:t>- /Users/rentamac/Documents/Codex/2026-05-12/app-llm-a5labs-tools/care2-opus/experiments/care_replay/configs/online_llm_matched_classical_audit_v1.json</a:t>
+            </a:r>
+          </a:p>
+          <a:p xmlns:a="http://schemas.openxmlformats.org/drawingml/2006/main">
+            <a:r>
+              <a:t>- /Users/rentamac/Documents/Codex/2026-05-12/app-llm-a5labs-tools/care2-opus/experiments/care_replay/results/2026-08-24-online-llm-matched-classical-audit-v1/aggregate.json</a:t>
+            </a:r>
+          </a:p>
+          <a:p xmlns:a="http://schemas.openxmlformats.org/drawingml/2006/main">
+            <a:r>
+              <a:t>- /Users/rentamac/Documents/Codex/2026-05-12/app-llm-a5labs-tools/care2-opus/experiments/care_replay/results/2026-08-24-online-llm-matched-classical-audit-v1/comparisons.csv</a:t>
+            </a:r>
+          </a:p>
+          <a:p xmlns:a="http://schemas.openxmlformats.org/drawingml/2006/main">
+            <a:r>
+              <a:t>- /Users/rentamac/Documents/Codex/2026-05-12/app-llm-a5labs-tools/care2-opus/experiments/care_replay/configs/classical_transfer_benchmark_v1.json</a:t>
+            </a:r>
+          </a:p>
+          <a:p xmlns:a="http://schemas.openxmlformats.org/drawingml/2006/main">
+            <a:r>
+              <a:t>- https://www.nature.com/articles/s41524-025-01851-8</a:t>
             </a:r>
           </a:p>
         </p:txBody>
@@ -1902,7 +2068,7 @@
   </p:cSld>
   <p:clrMap bg1="lt1" tx1="dk1" bg2="lt2" tx2="dk2" accent1="accent1" accent2="accent2" accent3="accent3" accent4="accent4" accent5="accent5" accent6="accent6" hlink="hlink" folHlink="folHlink"/>
   <p:sldLayoutIdLst>
-    <p:sldLayoutId xmlns:r="http://schemas.openxmlformats.org/officeDocument/2006/relationships" id="2147483649" r:id="R60adce59a24246e5"/>
+    <p:sldLayoutId xmlns:r="http://schemas.openxmlformats.org/officeDocument/2006/relationships" id="2147483649" r:id="Rc076f4bc98944c6d"/>
   </p:sldLayoutIdLst>
   <p:txStyles>
     <p:titleStyle>
@@ -2749,7 +2915,7 @@
                 <a:ea typeface="Arial Unicode MS"/>
                 <a:cs typeface="Arial Unicode MS"/>
               </a:rPr>
-              <a:t>在线 LLM Scientist · 真实重放证据 · 2026-08-23</a:t>
+              <a:t>在线 LLM Scientist · 真实重放证据 · 2026-08-24</a:t>
             </a:r>
           </a:p>
         </p:txBody>
@@ -3467,14 +3633,98 @@
       </p:sp>
       <p:pic>
         <p:nvPicPr>
-          <p:cNvPr id="13" name=""/>
+          <p:cNvPr id="14" name=""/>
           <p:cNvPicPr>
             <a:picLocks xmlns:a="http://schemas.openxmlformats.org/drawingml/2006/main" noChangeAspect="1"/>
           </p:cNvPicPr>
           <p:nvPr/>
         </p:nvPicPr>
         <p:blipFill>
-          <a:blip xmlns:r="http://schemas.openxmlformats.org/officeDocument/2006/relationships" xmlns:a="http://schemas.openxmlformats.org/drawingml/2006/main" r:embed="R9d8c629981f640d2"/>
+          <a:blip xmlns:r="http://schemas.openxmlformats.org/officeDocument/2006/relationships" xmlns:a="http://schemas.openxmlformats.org/drawingml/2006/main" r:embed="R70bda5fc7ead4032"/>
+          <a:stretch xmlns:a="http://schemas.openxmlformats.org/drawingml/2006/main"/>
+        </p:blipFill>
+        <p:spPr>
+          <a:xfrm xmlns:a="http://schemas.openxmlformats.org/drawingml/2006/main">
+            <a:off x="1462686" y="1257300"/>
+            <a:ext cx="9266627" cy="5105400"/>
+          </a:xfrm>
+          <a:prstGeom xmlns:a="http://schemas.openxmlformats.org/drawingml/2006/main" prst="rect">
+            <a:avLst/>
+          </a:prstGeom>
+        </p:spPr>
+      </p:pic>
+      <p:sp>
+        <p:nvSpPr>
+          <p:cNvPr id="6" name="">
+            <a:extLst xmlns:a="http://schemas.openxmlformats.org/drawingml/2006/main">
+              <a:ext uri="{FF2B5EF4-FFF2-40B4-BE49-F238E27FC236}">
+                <a16:creationId xmlns:a16="http://schemas.microsoft.com/office/drawing/2014/main" id="{D1B4F285-B5EF-4E37-9F30-02CAC87F6E8F}"/>
+              </a:ext>
+            </a:extLst>
+          </p:cNvPr>
+          <p:cNvSpPr>
+            <a:spLocks xmlns:a="http://schemas.openxmlformats.org/drawingml/2006/main" noGrp="1"/>
+          </p:cNvSpPr>
+          <p:nvPr/>
+        </p:nvSpPr>
+        <p:spPr>
+          <a:xfrm xmlns:a="http://schemas.openxmlformats.org/drawingml/2006/main">
+            <a:off x="647700" y="6600825"/>
+            <a:ext cx="10896600" cy="133350"/>
+          </a:xfrm>
+          <a:prstGeom xmlns:a="http://schemas.openxmlformats.org/drawingml/2006/main" prst="rect">
+            <a:avLst/>
+          </a:prstGeom>
+          <a:noFill xmlns:a="http://schemas.openxmlformats.org/drawingml/2006/main"/>
+          <a:ln xmlns:a="http://schemas.openxmlformats.org/drawingml/2006/main" w="0">
+            <a:noFill/>
+            <a:prstDash val="solid"/>
+          </a:ln>
+        </p:spPr>
+        <p:txBody>
+          <a:bodyPr xmlns:a="http://schemas.openxmlformats.org/drawingml/2006/main" wrap="square" lIns="0" tIns="0" rIns="0" bIns="0" anchor="t">
+            <a:normAutofit fontScale="100000"/>
+          </a:bodyPr>
+          <a:lstStyle xmlns:a="http://schemas.openxmlformats.org/drawingml/2006/main"/>
+          <a:p xmlns:a="http://schemas.openxmlformats.org/drawingml/2006/main">
+            <a:pPr algn="r">
+              <a:lnSpc>
+                <a:spcPct val="106000"/>
+              </a:lnSpc>
+              <a:buNone/>
+              <a:defRPr sz="750" b="0">
+                <a:solidFill>
+                  <a:srgbClr val="8B959D"/>
+                </a:solidFill>
+                <a:latin typeface="Arial Unicode MS"/>
+                <a:ea typeface="Arial Unicode MS"/>
+                <a:cs typeface="Arial Unicode MS"/>
+              </a:defRPr>
+            </a:pPr>
+            <a:r>
+              <a:rPr sz="750" b="0">
+                <a:solidFill>
+                  <a:srgbClr val="8B959D"/>
+                </a:solidFill>
+                <a:latin typeface="Arial Unicode MS"/>
+                <a:ea typeface="Arial Unicode MS"/>
+                <a:cs typeface="Arial Unicode MS"/>
+              </a:rPr>
+              <a:t>CARE 2.0 · online LLM evidence update · 2026-08-24</a:t>
+            </a:r>
+          </a:p>
+        </p:txBody>
+      </p:sp>
+      <p:pic>
+        <p:nvPicPr>
+          <p:cNvPr id="16" name=""/>
+          <p:cNvPicPr>
+            <a:picLocks xmlns:a="http://schemas.openxmlformats.org/drawingml/2006/main" noChangeAspect="1"/>
+          </p:cNvPicPr>
+          <p:nvPr/>
+        </p:nvPicPr>
+        <p:blipFill>
+          <a:blip xmlns:r="http://schemas.openxmlformats.org/officeDocument/2006/relationships" xmlns:a="http://schemas.openxmlformats.org/drawingml/2006/main" r:embed="R47dcf87f9b094a72"/>
           <a:srcRect xmlns:a="http://schemas.openxmlformats.org/drawingml/2006/main" l="0" t="0" r="0" b="43396"/>
           <a:stretch xmlns:a="http://schemas.openxmlformats.org/drawingml/2006/main"/>
         </p:blipFill>
@@ -3488,68 +3738,6 @@
           </a:prstGeom>
         </p:spPr>
       </p:pic>
-      <p:sp>
-        <p:nvSpPr>
-          <p:cNvPr id="6" name="">
-            <a:extLst xmlns:a="http://schemas.openxmlformats.org/drawingml/2006/main">
-              <a:ext uri="{FF2B5EF4-FFF2-40B4-BE49-F238E27FC236}">
-                <a16:creationId xmlns:a16="http://schemas.microsoft.com/office/drawing/2014/main" id="{D1B4F285-B5EF-4E37-9F30-02CAC87F6E8F}"/>
-              </a:ext>
-            </a:extLst>
-          </p:cNvPr>
-          <p:cNvSpPr>
-            <a:spLocks xmlns:a="http://schemas.openxmlformats.org/drawingml/2006/main" noGrp="1"/>
-          </p:cNvSpPr>
-          <p:nvPr/>
-        </p:nvSpPr>
-        <p:spPr>
-          <a:xfrm xmlns:a="http://schemas.openxmlformats.org/drawingml/2006/main">
-            <a:off x="647700" y="6600825"/>
-            <a:ext cx="10896600" cy="133350"/>
-          </a:xfrm>
-          <a:prstGeom xmlns:a="http://schemas.openxmlformats.org/drawingml/2006/main" prst="rect">
-            <a:avLst/>
-          </a:prstGeom>
-          <a:noFill xmlns:a="http://schemas.openxmlformats.org/drawingml/2006/main"/>
-          <a:ln xmlns:a="http://schemas.openxmlformats.org/drawingml/2006/main" w="0">
-            <a:noFill/>
-            <a:prstDash val="solid"/>
-          </a:ln>
-        </p:spPr>
-        <p:txBody>
-          <a:bodyPr xmlns:a="http://schemas.openxmlformats.org/drawingml/2006/main" wrap="square" lIns="0" tIns="0" rIns="0" bIns="0" anchor="t">
-            <a:normAutofit fontScale="100000"/>
-          </a:bodyPr>
-          <a:lstStyle xmlns:a="http://schemas.openxmlformats.org/drawingml/2006/main"/>
-          <a:p xmlns:a="http://schemas.openxmlformats.org/drawingml/2006/main">
-            <a:pPr algn="r">
-              <a:lnSpc>
-                <a:spcPct val="106000"/>
-              </a:lnSpc>
-              <a:buNone/>
-              <a:defRPr sz="750" b="0">
-                <a:solidFill>
-                  <a:srgbClr val="8B959D"/>
-                </a:solidFill>
-                <a:latin typeface="Arial Unicode MS"/>
-                <a:ea typeface="Arial Unicode MS"/>
-                <a:cs typeface="Arial Unicode MS"/>
-              </a:defRPr>
-            </a:pPr>
-            <a:r>
-              <a:rPr sz="750" b="0">
-                <a:solidFill>
-                  <a:srgbClr val="8B959D"/>
-                </a:solidFill>
-                <a:latin typeface="Arial Unicode MS"/>
-                <a:ea typeface="Arial Unicode MS"/>
-                <a:cs typeface="Arial Unicode MS"/>
-              </a:rPr>
-              <a:t>CARE 2.0 · online LLM evidence update · 2026-08-23</a:t>
-            </a:r>
-          </a:p>
-        </p:txBody>
-      </p:sp>
     </p:spTree>
     <p:extLst>
       <p:ext uri="{BB962C8B-B14F-4D97-AF65-F5344CB8AC3E}">
@@ -3760,7 +3948,7 @@
                 <a:ea typeface="Arial Unicode MS"/>
                 <a:cs typeface="Arial Unicode MS"/>
               </a:rPr>
-              <a:t>第一次重复调用仍是 6 / 2 / 3，但部分路线改变了正负号</a:t>
+              <a:t>两次调用总体同为 6 / 2 / 3，但 4 条路线翻转正负号</a:t>
             </a:r>
           </a:p>
         </p:txBody>
@@ -3798,14 +3986,98 @@
       </p:sp>
       <p:pic>
         <p:nvPicPr>
-          <p:cNvPr id="13" name=""/>
+          <p:cNvPr id="14" name=""/>
           <p:cNvPicPr>
             <a:picLocks xmlns:a="http://schemas.openxmlformats.org/drawingml/2006/main" noChangeAspect="1"/>
           </p:cNvPicPr>
           <p:nvPr/>
         </p:nvPicPr>
         <p:blipFill>
-          <a:blip xmlns:r="http://schemas.openxmlformats.org/officeDocument/2006/relationships" xmlns:a="http://schemas.openxmlformats.org/drawingml/2006/main" r:embed="R1e928dc4fab34298"/>
+          <a:blip xmlns:r="http://schemas.openxmlformats.org/officeDocument/2006/relationships" xmlns:a="http://schemas.openxmlformats.org/drawingml/2006/main" r:embed="Re94e502aaaf24c3a"/>
+          <a:stretch xmlns:a="http://schemas.openxmlformats.org/drawingml/2006/main"/>
+        </p:blipFill>
+        <p:spPr>
+          <a:xfrm xmlns:a="http://schemas.openxmlformats.org/drawingml/2006/main">
+            <a:off x="1462686" y="1257300"/>
+            <a:ext cx="9266627" cy="5105400"/>
+          </a:xfrm>
+          <a:prstGeom xmlns:a="http://schemas.openxmlformats.org/drawingml/2006/main" prst="rect">
+            <a:avLst/>
+          </a:prstGeom>
+        </p:spPr>
+      </p:pic>
+      <p:sp>
+        <p:nvSpPr>
+          <p:cNvPr id="6" name="">
+            <a:extLst xmlns:a="http://schemas.openxmlformats.org/drawingml/2006/main">
+              <a:ext uri="{FF2B5EF4-FFF2-40B4-BE49-F238E27FC236}">
+                <a16:creationId xmlns:a16="http://schemas.microsoft.com/office/drawing/2014/main" id="{D1B4F285-B5EF-4E37-9F30-02CAC87F6E8F}"/>
+              </a:ext>
+            </a:extLst>
+          </p:cNvPr>
+          <p:cNvSpPr>
+            <a:spLocks xmlns:a="http://schemas.openxmlformats.org/drawingml/2006/main" noGrp="1"/>
+          </p:cNvSpPr>
+          <p:nvPr/>
+        </p:nvSpPr>
+        <p:spPr>
+          <a:xfrm xmlns:a="http://schemas.openxmlformats.org/drawingml/2006/main">
+            <a:off x="647700" y="6600825"/>
+            <a:ext cx="10896600" cy="133350"/>
+          </a:xfrm>
+          <a:prstGeom xmlns:a="http://schemas.openxmlformats.org/drawingml/2006/main" prst="rect">
+            <a:avLst/>
+          </a:prstGeom>
+          <a:noFill xmlns:a="http://schemas.openxmlformats.org/drawingml/2006/main"/>
+          <a:ln xmlns:a="http://schemas.openxmlformats.org/drawingml/2006/main" w="0">
+            <a:noFill/>
+            <a:prstDash val="solid"/>
+          </a:ln>
+        </p:spPr>
+        <p:txBody>
+          <a:bodyPr xmlns:a="http://schemas.openxmlformats.org/drawingml/2006/main" wrap="square" lIns="0" tIns="0" rIns="0" bIns="0" anchor="t">
+            <a:normAutofit fontScale="100000"/>
+          </a:bodyPr>
+          <a:lstStyle xmlns:a="http://schemas.openxmlformats.org/drawingml/2006/main"/>
+          <a:p xmlns:a="http://schemas.openxmlformats.org/drawingml/2006/main">
+            <a:pPr algn="r">
+              <a:lnSpc>
+                <a:spcPct val="106000"/>
+              </a:lnSpc>
+              <a:buNone/>
+              <a:defRPr sz="750" b="0">
+                <a:solidFill>
+                  <a:srgbClr val="8B959D"/>
+                </a:solidFill>
+                <a:latin typeface="Arial Unicode MS"/>
+                <a:ea typeface="Arial Unicode MS"/>
+                <a:cs typeface="Arial Unicode MS"/>
+              </a:defRPr>
+            </a:pPr>
+            <a:r>
+              <a:rPr sz="750" b="0">
+                <a:solidFill>
+                  <a:srgbClr val="8B959D"/>
+                </a:solidFill>
+                <a:latin typeface="Arial Unicode MS"/>
+                <a:ea typeface="Arial Unicode MS"/>
+                <a:cs typeface="Arial Unicode MS"/>
+              </a:rPr>
+              <a:t>CARE 2.0 · online LLM evidence update · 2026-08-24</a:t>
+            </a:r>
+          </a:p>
+        </p:txBody>
+      </p:sp>
+      <p:pic>
+        <p:nvPicPr>
+          <p:cNvPr id="16" name=""/>
+          <p:cNvPicPr>
+            <a:picLocks xmlns:a="http://schemas.openxmlformats.org/drawingml/2006/main" noChangeAspect="1"/>
+          </p:cNvPicPr>
+          <p:nvPr/>
+        </p:nvPicPr>
+        <p:blipFill>
+          <a:blip xmlns:r="http://schemas.openxmlformats.org/officeDocument/2006/relationships" xmlns:a="http://schemas.openxmlformats.org/drawingml/2006/main" r:embed="Race971ece4344f7b"/>
           <a:srcRect xmlns:a="http://schemas.openxmlformats.org/drawingml/2006/main" l="0" t="0" r="0" b="0"/>
           <a:stretch xmlns:a="http://schemas.openxmlformats.org/drawingml/2006/main"/>
         </p:blipFill>
@@ -3819,68 +4091,6 @@
           </a:prstGeom>
         </p:spPr>
       </p:pic>
-      <p:sp>
-        <p:nvSpPr>
-          <p:cNvPr id="6" name="">
-            <a:extLst xmlns:a="http://schemas.openxmlformats.org/drawingml/2006/main">
-              <a:ext uri="{FF2B5EF4-FFF2-40B4-BE49-F238E27FC236}">
-                <a16:creationId xmlns:a16="http://schemas.microsoft.com/office/drawing/2014/main" id="{D1B4F285-B5EF-4E37-9F30-02CAC87F6E8F}"/>
-              </a:ext>
-            </a:extLst>
-          </p:cNvPr>
-          <p:cNvSpPr>
-            <a:spLocks xmlns:a="http://schemas.openxmlformats.org/drawingml/2006/main" noGrp="1"/>
-          </p:cNvSpPr>
-          <p:nvPr/>
-        </p:nvSpPr>
-        <p:spPr>
-          <a:xfrm xmlns:a="http://schemas.openxmlformats.org/drawingml/2006/main">
-            <a:off x="647700" y="6600825"/>
-            <a:ext cx="10896600" cy="133350"/>
-          </a:xfrm>
-          <a:prstGeom xmlns:a="http://schemas.openxmlformats.org/drawingml/2006/main" prst="rect">
-            <a:avLst/>
-          </a:prstGeom>
-          <a:noFill xmlns:a="http://schemas.openxmlformats.org/drawingml/2006/main"/>
-          <a:ln xmlns:a="http://schemas.openxmlformats.org/drawingml/2006/main" w="0">
-            <a:noFill/>
-            <a:prstDash val="solid"/>
-          </a:ln>
-        </p:spPr>
-        <p:txBody>
-          <a:bodyPr xmlns:a="http://schemas.openxmlformats.org/drawingml/2006/main" wrap="square" lIns="0" tIns="0" rIns="0" bIns="0" anchor="t">
-            <a:normAutofit fontScale="100000"/>
-          </a:bodyPr>
-          <a:lstStyle xmlns:a="http://schemas.openxmlformats.org/drawingml/2006/main"/>
-          <a:p xmlns:a="http://schemas.openxmlformats.org/drawingml/2006/main">
-            <a:pPr algn="r">
-              <a:lnSpc>
-                <a:spcPct val="106000"/>
-              </a:lnSpc>
-              <a:buNone/>
-              <a:defRPr sz="750" b="0">
-                <a:solidFill>
-                  <a:srgbClr val="8B959D"/>
-                </a:solidFill>
-                <a:latin typeface="Arial Unicode MS"/>
-                <a:ea typeface="Arial Unicode MS"/>
-                <a:cs typeface="Arial Unicode MS"/>
-              </a:defRPr>
-            </a:pPr>
-            <a:r>
-              <a:rPr sz="750" b="0">
-                <a:solidFill>
-                  <a:srgbClr val="8B959D"/>
-                </a:solidFill>
-                <a:latin typeface="Arial Unicode MS"/>
-                <a:ea typeface="Arial Unicode MS"/>
-                <a:cs typeface="Arial Unicode MS"/>
-              </a:rPr>
-              <a:t>CARE 2.0 · online LLM evidence update · 2026-08-23</a:t>
-            </a:r>
-          </a:p>
-        </p:txBody>
-      </p:sp>
     </p:spTree>
     <p:extLst>
       <p:ext uri="{BB962C8B-B14F-4D97-AF65-F5344CB8AC3E}">
@@ -3912,10 +4122,10 @@
       </p:grpSpPr>
       <p:sp>
         <p:nvSpPr>
-          <p:cNvPr id="17" name="">
-            <a:extLst xmlns:a="http://schemas.openxmlformats.org/drawingml/2006/main">
-              <a:ext uri="{FF2B5EF4-FFF2-40B4-BE49-F238E27FC236}">
-                <a16:creationId xmlns:a16="http://schemas.microsoft.com/office/drawing/2014/main" id="{F13116EE-10E9-42CB-87E9-9FFCF69EA14A}"/>
+          <p:cNvPr id="7" name="">
+            <a:extLst xmlns:a="http://schemas.openxmlformats.org/drawingml/2006/main">
+              <a:ext uri="{FF2B5EF4-FFF2-40B4-BE49-F238E27FC236}">
+                <a16:creationId xmlns:a16="http://schemas.microsoft.com/office/drawing/2014/main" id="{6C311705-E0EB-402F-B1A7-C288385A231C}"/>
               </a:ext>
             </a:extLst>
           </p:cNvPr>
@@ -3967,7 +4177,7 @@
                 <a:ea typeface="Arial Unicode MS"/>
                 <a:cs typeface="Arial Unicode MS"/>
               </a:rPr>
-              <a:t>现在能说什么</a:t>
+              <a:t>材料迁移案例</a:t>
             </a:r>
           </a:p>
         </p:txBody>
@@ -3977,7 +4187,7 @@
           <p:cNvPr id="2" name="">
             <a:extLst xmlns:a="http://schemas.openxmlformats.org/drawingml/2006/main">
               <a:ext uri="{FF2B5EF4-FFF2-40B4-BE49-F238E27FC236}">
-                <a16:creationId xmlns:a16="http://schemas.microsoft.com/office/drawing/2014/main" id="{7C93BB4F-687E-41EA-880C-DA077418C84A}"/>
+                <a16:creationId xmlns:a16="http://schemas.microsoft.com/office/drawing/2014/main" id="{1543A56E-44FC-448E-B95A-42B22110256A}"/>
               </a:ext>
             </a:extLst>
           </p:cNvPr>
@@ -4039,7 +4249,7 @@
           <p:cNvPr id="3" name="">
             <a:extLst xmlns:a="http://schemas.openxmlformats.org/drawingml/2006/main">
               <a:ext uri="{FF2B5EF4-FFF2-40B4-BE49-F238E27FC236}">
-                <a16:creationId xmlns:a16="http://schemas.microsoft.com/office/drawing/2014/main" id="{9CC42BAC-7B39-48DE-98FE-F217E9DA94C0}"/>
+                <a16:creationId xmlns:a16="http://schemas.microsoft.com/office/drawing/2014/main" id="{91589F62-8A06-48D2-A906-6E23C1D2A667}"/>
               </a:ext>
             </a:extLst>
           </p:cNvPr>
@@ -4091,7 +4301,7 @@
                 <a:ea typeface="Arial Unicode MS"/>
                 <a:cs typeface="Arial Unicode MS"/>
               </a:rPr>
-              <a:t>当前证据支持“路线特异的正向信号”，不支持“普遍跨领域提升”</a:t>
+              <a:t>拒绝不可靠迁移后仍更早找到高值材料；单位语义错误 5 → 0</a:t>
             </a:r>
           </a:p>
         </p:txBody>
@@ -4101,7 +4311,7 @@
           <p:cNvPr id="4" name="">
             <a:extLst xmlns:a="http://schemas.openxmlformats.org/drawingml/2006/main">
               <a:ext uri="{FF2B5EF4-FFF2-40B4-BE49-F238E27FC236}">
-                <a16:creationId xmlns:a16="http://schemas.microsoft.com/office/drawing/2014/main" id="{A7036B3D-8368-4946-B1A4-22E1178B0E5B}"/>
+                <a16:creationId xmlns:a16="http://schemas.microsoft.com/office/drawing/2014/main" id="{77ECEF1D-351C-443E-8CF8-6F33B746330A}"/>
               </a:ext>
             </a:extLst>
           </p:cNvPr>
@@ -4127,24 +4337,46 @@
           </a:ln>
         </p:spPr>
       </p:sp>
-      <p:sp>
-        <p:nvSpPr>
-          <p:cNvPr id="5" name="">
-            <a:extLst xmlns:a="http://schemas.openxmlformats.org/drawingml/2006/main">
-              <a:ext uri="{FF2B5EF4-FFF2-40B4-BE49-F238E27FC236}">
-                <a16:creationId xmlns:a16="http://schemas.microsoft.com/office/drawing/2014/main" id="{57D85720-6F57-4F74-A324-0BFA22D53BFC}"/>
-              </a:ext>
-            </a:extLst>
-          </p:cNvPr>
-          <p:cNvSpPr>
-            <a:spLocks xmlns:a="http://schemas.openxmlformats.org/drawingml/2006/main" noGrp="1"/>
-          </p:cNvSpPr>
-          <p:nvPr/>
-        </p:nvSpPr>
-        <p:spPr>
-          <a:xfrm xmlns:a="http://schemas.openxmlformats.org/drawingml/2006/main">
-            <a:off x="647700" y="1714500"/>
-            <a:ext cx="3143250" cy="342900"/>
+      <p:pic>
+        <p:nvPicPr>
+          <p:cNvPr id="14" name=""/>
+          <p:cNvPicPr>
+            <a:picLocks xmlns:a="http://schemas.openxmlformats.org/drawingml/2006/main" noChangeAspect="1"/>
+          </p:cNvPicPr>
+          <p:nvPr/>
+        </p:nvPicPr>
+        <p:blipFill>
+          <a:blip xmlns:r="http://schemas.openxmlformats.org/officeDocument/2006/relationships" xmlns:a="http://schemas.openxmlformats.org/drawingml/2006/main" r:embed="Rcd633a3dcea948e5"/>
+          <a:stretch xmlns:a="http://schemas.openxmlformats.org/drawingml/2006/main"/>
+        </p:blipFill>
+        <p:spPr>
+          <a:xfrm xmlns:a="http://schemas.openxmlformats.org/drawingml/2006/main">
+            <a:off x="1462686" y="1257300"/>
+            <a:ext cx="9266627" cy="5105400"/>
+          </a:xfrm>
+          <a:prstGeom xmlns:a="http://schemas.openxmlformats.org/drawingml/2006/main" prst="rect">
+            <a:avLst/>
+          </a:prstGeom>
+        </p:spPr>
+      </p:pic>
+      <p:sp>
+        <p:nvSpPr>
+          <p:cNvPr id="6" name="">
+            <a:extLst xmlns:a="http://schemas.openxmlformats.org/drawingml/2006/main">
+              <a:ext uri="{FF2B5EF4-FFF2-40B4-BE49-F238E27FC236}">
+                <a16:creationId xmlns:a16="http://schemas.microsoft.com/office/drawing/2014/main" id="{D1B4F285-B5EF-4E37-9F30-02CAC87F6E8F}"/>
+              </a:ext>
+            </a:extLst>
+          </p:cNvPr>
+          <p:cNvSpPr>
+            <a:spLocks xmlns:a="http://schemas.openxmlformats.org/drawingml/2006/main" noGrp="1"/>
+          </p:cNvSpPr>
+          <p:nvPr/>
+        </p:nvSpPr>
+        <p:spPr>
+          <a:xfrm xmlns:a="http://schemas.openxmlformats.org/drawingml/2006/main">
+            <a:off x="647700" y="6600825"/>
+            <a:ext cx="10896600" cy="133350"/>
           </a:xfrm>
           <a:prstGeom xmlns:a="http://schemas.openxmlformats.org/drawingml/2006/main" prst="rect">
             <a:avLst/>
@@ -4161,839 +4393,11 @@
           </a:bodyPr>
           <a:lstStyle xmlns:a="http://schemas.openxmlformats.org/drawingml/2006/main"/>
           <a:p xmlns:a="http://schemas.openxmlformats.org/drawingml/2006/main">
-            <a:pPr algn="l">
+            <a:pPr algn="r">
               <a:lnSpc>
                 <a:spcPct val="106000"/>
               </a:lnSpc>
               <a:buNone/>
-              <a:defRPr sz="1875" b="1">
-                <a:solidFill>
-                  <a:srgbClr val="2C8A62"/>
-                </a:solidFill>
-                <a:latin typeface="Arial Unicode MS"/>
-                <a:ea typeface="Arial Unicode MS"/>
-                <a:cs typeface="Arial Unicode MS"/>
-              </a:defRPr>
-            </a:pPr>
-            <a:r>
-              <a:rPr sz="1875" b="1">
-                <a:solidFill>
-                  <a:srgbClr val="2C8A62"/>
-                </a:solidFill>
-                <a:latin typeface="Arial Unicode MS"/>
-                <a:ea typeface="Arial Unicode MS"/>
-                <a:cs typeface="Arial Unicode MS"/>
-              </a:rPr>
-              <a:t>已经做到</a:t>
-            </a:r>
-          </a:p>
-        </p:txBody>
-      </p:sp>
-      <p:sp>
-        <p:nvSpPr>
-          <p:cNvPr id="6" name="">
-            <a:extLst xmlns:a="http://schemas.openxmlformats.org/drawingml/2006/main">
-              <a:ext uri="{FF2B5EF4-FFF2-40B4-BE49-F238E27FC236}">
-                <a16:creationId xmlns:a16="http://schemas.microsoft.com/office/drawing/2014/main" id="{F1C3C5FB-A495-4A31-9A88-FA2DD4032E37}"/>
-              </a:ext>
-            </a:extLst>
-          </p:cNvPr>
-          <p:cNvSpPr>
-            <a:spLocks xmlns:a="http://schemas.openxmlformats.org/drawingml/2006/main" noGrp="1"/>
-          </p:cNvSpPr>
-          <p:nvPr/>
-        </p:nvSpPr>
-        <p:spPr>
-          <a:xfrm xmlns:a="http://schemas.openxmlformats.org/drawingml/2006/main">
-            <a:off x="647700" y="2171700"/>
-            <a:ext cx="3143250" cy="28575"/>
-          </a:xfrm>
-          <a:prstGeom xmlns:a="http://schemas.openxmlformats.org/drawingml/2006/main" prst="rect">
-            <a:avLst/>
-          </a:prstGeom>
-          <a:solidFill xmlns:a="http://schemas.openxmlformats.org/drawingml/2006/main">
-            <a:srgbClr val="2C8A62"/>
-          </a:solidFill>
-          <a:ln xmlns:a="http://schemas.openxmlformats.org/drawingml/2006/main" w="0">
-            <a:noFill/>
-            <a:prstDash val="solid"/>
-          </a:ln>
-        </p:spPr>
-      </p:sp>
-      <p:sp>
-        <p:nvSpPr>
-          <p:cNvPr id="7" name="">
-            <a:extLst xmlns:a="http://schemas.openxmlformats.org/drawingml/2006/main">
-              <a:ext uri="{FF2B5EF4-FFF2-40B4-BE49-F238E27FC236}">
-                <a16:creationId xmlns:a16="http://schemas.microsoft.com/office/drawing/2014/main" id="{7EA04F9C-2AAB-439F-AAAB-57819E2FBFBB}"/>
-              </a:ext>
-            </a:extLst>
-          </p:cNvPr>
-          <p:cNvSpPr>
-            <a:spLocks xmlns:a="http://schemas.openxmlformats.org/drawingml/2006/main" noGrp="1"/>
-          </p:cNvSpPr>
-          <p:nvPr/>
-        </p:nvSpPr>
-        <p:spPr>
-          <a:xfrm xmlns:a="http://schemas.openxmlformats.org/drawingml/2006/main">
-            <a:off x="647700" y="2457450"/>
-            <a:ext cx="3143250" cy="2266950"/>
-          </a:xfrm>
-          <a:prstGeom xmlns:a="http://schemas.openxmlformats.org/drawingml/2006/main" prst="rect">
-            <a:avLst/>
-          </a:prstGeom>
-          <a:noFill xmlns:a="http://schemas.openxmlformats.org/drawingml/2006/main"/>
-          <a:ln xmlns:a="http://schemas.openxmlformats.org/drawingml/2006/main" w="0">
-            <a:noFill/>
-            <a:prstDash val="solid"/>
-          </a:ln>
-        </p:spPr>
-        <p:txBody>
-          <a:bodyPr xmlns:a="http://schemas.openxmlformats.org/drawingml/2006/main" wrap="square" lIns="0" tIns="0" rIns="0" bIns="0" anchor="t">
-            <a:normAutofit fontScale="100000"/>
-          </a:bodyPr>
-          <a:lstStyle xmlns:a="http://schemas.openxmlformats.org/drawingml/2006/main"/>
-          <a:p xmlns:a="http://schemas.openxmlformats.org/drawingml/2006/main">
-            <a:pPr algn="l">
-              <a:lnSpc>
-                <a:spcPct val="120000"/>
-              </a:lnSpc>
-              <a:buNone/>
-              <a:defRPr sz="1500" b="0">
-                <a:solidFill>
-                  <a:srgbClr val="17232E"/>
-                </a:solidFill>
-                <a:latin typeface="Arial Unicode MS"/>
-                <a:ea typeface="Arial Unicode MS"/>
-                <a:cs typeface="Arial Unicode MS"/>
-              </a:defRPr>
-            </a:pPr>
-            <a:r>
-              <a:rPr sz="1500" b="0">
-                <a:solidFill>
-                  <a:srgbClr val="17232E"/>
-                </a:solidFill>
-                <a:latin typeface="Arial Unicode MS"/>
-                <a:ea typeface="Arial Unicode MS"/>
-                <a:cs typeface="Arial Unicode MS"/>
-              </a:rPr>
-              <a:t>• 无泄漏 replay 与同预算对照</a:t>
-            </a:r>
-          </a:p>
-          <a:p xmlns:a="http://schemas.openxmlformats.org/drawingml/2006/main">
-            <a:pPr algn="l">
-              <a:lnSpc>
-                <a:spcPct val="120000"/>
-              </a:lnSpc>
-              <a:buNone/>
-              <a:defRPr sz="1500" b="0">
-                <a:solidFill>
-                  <a:srgbClr val="17232E"/>
-                </a:solidFill>
-                <a:latin typeface="Arial Unicode MS"/>
-                <a:ea typeface="Arial Unicode MS"/>
-                <a:cs typeface="Arial Unicode MS"/>
-              </a:defRPr>
-            </a:pPr>
-            <a:r>
-              <a:rPr sz="1500" b="0">
-                <a:solidFill>
-                  <a:srgbClr val="17232E"/>
-                </a:solidFill>
-                <a:latin typeface="Arial Unicode MS"/>
-                <a:ea typeface="Arial Unicode MS"/>
-                <a:cs typeface="Arial Unicode MS"/>
-              </a:rPr>
-              <a:t>• 覆盖 11 条化学/分子/材料路线</a:t>
-            </a:r>
-          </a:p>
-          <a:p xmlns:a="http://schemas.openxmlformats.org/drawingml/2006/main">
-            <a:pPr algn="l">
-              <a:lnSpc>
-                <a:spcPct val="120000"/>
-              </a:lnSpc>
-              <a:buNone/>
-              <a:defRPr sz="1500" b="0">
-                <a:solidFill>
-                  <a:srgbClr val="17232E"/>
-                </a:solidFill>
-                <a:latin typeface="Arial Unicode MS"/>
-                <a:ea typeface="Arial Unicode MS"/>
-                <a:cs typeface="Arial Unicode MS"/>
-              </a:defRPr>
-            </a:pPr>
-            <a:r>
-              <a:rPr sz="1500" b="0">
-                <a:solidFill>
-                  <a:srgbClr val="17232E"/>
-                </a:solidFill>
-                <a:latin typeface="Arial Unicode MS"/>
-                <a:ea typeface="Arial Unicode MS"/>
-                <a:cs typeface="Arial Unicode MS"/>
-              </a:rPr>
-              <a:t>• LLM 在 10 / 10 轮参与决策</a:t>
-            </a:r>
-          </a:p>
-          <a:p xmlns:a="http://schemas.openxmlformats.org/drawingml/2006/main">
-            <a:pPr algn="l">
-              <a:lnSpc>
-                <a:spcPct val="120000"/>
-              </a:lnSpc>
-              <a:buNone/>
-              <a:defRPr sz="1500" b="0">
-                <a:solidFill>
-                  <a:srgbClr val="17232E"/>
-                </a:solidFill>
-                <a:latin typeface="Arial Unicode MS"/>
-                <a:ea typeface="Arial Unicode MS"/>
-                <a:cs typeface="Arial Unicode MS"/>
-              </a:defRPr>
-            </a:pPr>
-            <a:r>
-              <a:rPr sz="1500" b="0">
-                <a:solidFill>
-                  <a:srgbClr val="17232E"/>
-                </a:solidFill>
-                <a:latin typeface="Arial Unicode MS"/>
-                <a:ea typeface="Arial Unicode MS"/>
-                <a:cs typeface="Arial Unicode MS"/>
-              </a:rPr>
-              <a:t>• prompt、回答、选择和结果可追溯</a:t>
-            </a:r>
-          </a:p>
-        </p:txBody>
-      </p:sp>
-      <p:sp>
-        <p:nvSpPr>
-          <p:cNvPr id="8" name="">
-            <a:extLst xmlns:a="http://schemas.openxmlformats.org/drawingml/2006/main">
-              <a:ext uri="{FF2B5EF4-FFF2-40B4-BE49-F238E27FC236}">
-                <a16:creationId xmlns:a16="http://schemas.microsoft.com/office/drawing/2014/main" id="{50E871CA-3863-4F0F-AD47-D7F772330FD6}"/>
-              </a:ext>
-            </a:extLst>
-          </p:cNvPr>
-          <p:cNvSpPr>
-            <a:spLocks xmlns:a="http://schemas.openxmlformats.org/drawingml/2006/main" noGrp="1"/>
-          </p:cNvSpPr>
-          <p:nvPr/>
-        </p:nvSpPr>
-        <p:spPr>
-          <a:xfrm xmlns:a="http://schemas.openxmlformats.org/drawingml/2006/main">
-            <a:off x="4343400" y="1714500"/>
-            <a:ext cx="3143250" cy="342900"/>
-          </a:xfrm>
-          <a:prstGeom xmlns:a="http://schemas.openxmlformats.org/drawingml/2006/main" prst="rect">
-            <a:avLst/>
-          </a:prstGeom>
-          <a:noFill xmlns:a="http://schemas.openxmlformats.org/drawingml/2006/main"/>
-          <a:ln xmlns:a="http://schemas.openxmlformats.org/drawingml/2006/main" w="0">
-            <a:noFill/>
-            <a:prstDash val="solid"/>
-          </a:ln>
-        </p:spPr>
-        <p:txBody>
-          <a:bodyPr xmlns:a="http://schemas.openxmlformats.org/drawingml/2006/main" wrap="square" lIns="0" tIns="0" rIns="0" bIns="0" anchor="t">
-            <a:normAutofit fontScale="100000"/>
-          </a:bodyPr>
-          <a:lstStyle xmlns:a="http://schemas.openxmlformats.org/drawingml/2006/main"/>
-          <a:p xmlns:a="http://schemas.openxmlformats.org/drawingml/2006/main">
-            <a:pPr algn="l">
-              <a:lnSpc>
-                <a:spcPct val="106000"/>
-              </a:lnSpc>
-              <a:buNone/>
-              <a:defRPr sz="1875" b="1">
-                <a:solidFill>
-                  <a:srgbClr val="C94D4D"/>
-                </a:solidFill>
-                <a:latin typeface="Arial Unicode MS"/>
-                <a:ea typeface="Arial Unicode MS"/>
-                <a:cs typeface="Arial Unicode MS"/>
-              </a:defRPr>
-            </a:pPr>
-            <a:r>
-              <a:rPr sz="1875" b="1">
-                <a:solidFill>
-                  <a:srgbClr val="C94D4D"/>
-                </a:solidFill>
-                <a:latin typeface="Arial Unicode MS"/>
-                <a:ea typeface="Arial Unicode MS"/>
-                <a:cs typeface="Arial Unicode MS"/>
-              </a:rPr>
-              <a:t>还没有做到</a:t>
-            </a:r>
-          </a:p>
-        </p:txBody>
-      </p:sp>
-      <p:sp>
-        <p:nvSpPr>
-          <p:cNvPr id="9" name="">
-            <a:extLst xmlns:a="http://schemas.openxmlformats.org/drawingml/2006/main">
-              <a:ext uri="{FF2B5EF4-FFF2-40B4-BE49-F238E27FC236}">
-                <a16:creationId xmlns:a16="http://schemas.microsoft.com/office/drawing/2014/main" id="{F03EDA0F-719B-4FB6-8EF4-3EE305D0169A}"/>
-              </a:ext>
-            </a:extLst>
-          </p:cNvPr>
-          <p:cNvSpPr>
-            <a:spLocks xmlns:a="http://schemas.openxmlformats.org/drawingml/2006/main" noGrp="1"/>
-          </p:cNvSpPr>
-          <p:nvPr/>
-        </p:nvSpPr>
-        <p:spPr>
-          <a:xfrm xmlns:a="http://schemas.openxmlformats.org/drawingml/2006/main">
-            <a:off x="4343400" y="2171700"/>
-            <a:ext cx="3143250" cy="28575"/>
-          </a:xfrm>
-          <a:prstGeom xmlns:a="http://schemas.openxmlformats.org/drawingml/2006/main" prst="rect">
-            <a:avLst/>
-          </a:prstGeom>
-          <a:solidFill xmlns:a="http://schemas.openxmlformats.org/drawingml/2006/main">
-            <a:srgbClr val="C94D4D"/>
-          </a:solidFill>
-          <a:ln xmlns:a="http://schemas.openxmlformats.org/drawingml/2006/main" w="0">
-            <a:noFill/>
-            <a:prstDash val="solid"/>
-          </a:ln>
-        </p:spPr>
-      </p:sp>
-      <p:sp>
-        <p:nvSpPr>
-          <p:cNvPr id="10" name="">
-            <a:extLst xmlns:a="http://schemas.openxmlformats.org/drawingml/2006/main">
-              <a:ext uri="{FF2B5EF4-FFF2-40B4-BE49-F238E27FC236}">
-                <a16:creationId xmlns:a16="http://schemas.microsoft.com/office/drawing/2014/main" id="{68841F36-5B20-49DF-BA94-2CB3D6E69748}"/>
-              </a:ext>
-            </a:extLst>
-          </p:cNvPr>
-          <p:cNvSpPr>
-            <a:spLocks xmlns:a="http://schemas.openxmlformats.org/drawingml/2006/main" noGrp="1"/>
-          </p:cNvSpPr>
-          <p:nvPr/>
-        </p:nvSpPr>
-        <p:spPr>
-          <a:xfrm xmlns:a="http://schemas.openxmlformats.org/drawingml/2006/main">
-            <a:off x="4343400" y="2457450"/>
-            <a:ext cx="3143250" cy="2266950"/>
-          </a:xfrm>
-          <a:prstGeom xmlns:a="http://schemas.openxmlformats.org/drawingml/2006/main" prst="rect">
-            <a:avLst/>
-          </a:prstGeom>
-          <a:noFill xmlns:a="http://schemas.openxmlformats.org/drawingml/2006/main"/>
-          <a:ln xmlns:a="http://schemas.openxmlformats.org/drawingml/2006/main" w="0">
-            <a:noFill/>
-            <a:prstDash val="solid"/>
-          </a:ln>
-        </p:spPr>
-        <p:txBody>
-          <a:bodyPr xmlns:a="http://schemas.openxmlformats.org/drawingml/2006/main" wrap="square" lIns="0" tIns="0" rIns="0" bIns="0" anchor="t">
-            <a:normAutofit fontScale="100000"/>
-          </a:bodyPr>
-          <a:lstStyle xmlns:a="http://schemas.openxmlformats.org/drawingml/2006/main"/>
-          <a:p xmlns:a="http://schemas.openxmlformats.org/drawingml/2006/main">
-            <a:pPr algn="l">
-              <a:lnSpc>
-                <a:spcPct val="120000"/>
-              </a:lnSpc>
-              <a:buNone/>
-              <a:defRPr sz="1500" b="0">
-                <a:solidFill>
-                  <a:srgbClr val="17232E"/>
-                </a:solidFill>
-                <a:latin typeface="Arial Unicode MS"/>
-                <a:ea typeface="Arial Unicode MS"/>
-                <a:cs typeface="Arial Unicode MS"/>
-              </a:defRPr>
-            </a:pPr>
-            <a:r>
-              <a:rPr sz="1500" b="0">
-                <a:solidFill>
-                  <a:srgbClr val="17232E"/>
-                </a:solidFill>
-                <a:latin typeface="Arial Unicode MS"/>
-                <a:ea typeface="Arial Unicode MS"/>
-                <a:cs typeface="Arial Unicode MS"/>
-              </a:rPr>
-              <a:t>• 每条路线足量、独立的 LLM 重复</a:t>
-            </a:r>
-          </a:p>
-          <a:p xmlns:a="http://schemas.openxmlformats.org/drawingml/2006/main">
-            <a:pPr algn="l">
-              <a:lnSpc>
-                <a:spcPct val="120000"/>
-              </a:lnSpc>
-              <a:buNone/>
-              <a:defRPr sz="1500" b="0">
-                <a:solidFill>
-                  <a:srgbClr val="17232E"/>
-                </a:solidFill>
-                <a:latin typeface="Arial Unicode MS"/>
-                <a:ea typeface="Arial Unicode MS"/>
-                <a:cs typeface="Arial Unicode MS"/>
-              </a:defRPr>
-            </a:pPr>
-            <a:r>
-              <a:rPr sz="1500" b="0">
-                <a:solidFill>
-                  <a:srgbClr val="17232E"/>
-                </a:solidFill>
-                <a:latin typeface="Arial Unicode MS"/>
-                <a:ea typeface="Arial Unicode MS"/>
-                <a:cs typeface="Arial Unicode MS"/>
-              </a:rPr>
-              <a:t>• 窄且不跨 0 的确认区间</a:t>
-            </a:r>
-          </a:p>
-          <a:p xmlns:a="http://schemas.openxmlformats.org/drawingml/2006/main">
-            <a:pPr algn="l">
-              <a:lnSpc>
-                <a:spcPct val="120000"/>
-              </a:lnSpc>
-              <a:buNone/>
-              <a:defRPr sz="1500" b="0">
-                <a:solidFill>
-                  <a:srgbClr val="17232E"/>
-                </a:solidFill>
-                <a:latin typeface="Arial Unicode MS"/>
-                <a:ea typeface="Arial Unicode MS"/>
-                <a:cs typeface="Arial Unicode MS"/>
-              </a:defRPr>
-            </a:pPr>
-            <a:r>
-              <a:rPr sz="1500" b="0">
-                <a:solidFill>
-                  <a:srgbClr val="17232E"/>
-                </a:solidFill>
-                <a:latin typeface="Arial Unicode MS"/>
-                <a:ea typeface="Arial Unicode MS"/>
-                <a:cs typeface="Arial Unicode MS"/>
-              </a:rPr>
-              <a:t>• 未参与开发的新任务家族</a:t>
-            </a:r>
-          </a:p>
-          <a:p xmlns:a="http://schemas.openxmlformats.org/drawingml/2006/main">
-            <a:pPr algn="l">
-              <a:lnSpc>
-                <a:spcPct val="120000"/>
-              </a:lnSpc>
-              <a:buNone/>
-              <a:defRPr sz="1500" b="0">
-                <a:solidFill>
-                  <a:srgbClr val="17232E"/>
-                </a:solidFill>
-                <a:latin typeface="Arial Unicode MS"/>
-                <a:ea typeface="Arial Unicode MS"/>
-                <a:cs typeface="Arial Unicode MS"/>
-              </a:defRPr>
-            </a:pPr>
-            <a:r>
-              <a:rPr sz="1500" b="0">
-                <a:solidFill>
-                  <a:srgbClr val="17232E"/>
-                </a:solidFill>
-                <a:latin typeface="Arial Unicode MS"/>
-                <a:ea typeface="Arial Unicode MS"/>
-                <a:cs typeface="Arial Unicode MS"/>
-              </a:rPr>
-              <a:t>• 前瞻 wet-lab 独立验证</a:t>
-            </a:r>
-          </a:p>
-        </p:txBody>
-      </p:sp>
-      <p:sp>
-        <p:nvSpPr>
-          <p:cNvPr id="11" name="">
-            <a:extLst xmlns:a="http://schemas.openxmlformats.org/drawingml/2006/main">
-              <a:ext uri="{FF2B5EF4-FFF2-40B4-BE49-F238E27FC236}">
-                <a16:creationId xmlns:a16="http://schemas.microsoft.com/office/drawing/2014/main" id="{FA4E01B4-FF74-43B9-836C-866227510DCD}"/>
-              </a:ext>
-            </a:extLst>
-          </p:cNvPr>
-          <p:cNvSpPr>
-            <a:spLocks xmlns:a="http://schemas.openxmlformats.org/drawingml/2006/main" noGrp="1"/>
-          </p:cNvSpPr>
-          <p:nvPr/>
-        </p:nvSpPr>
-        <p:spPr>
-          <a:xfrm xmlns:a="http://schemas.openxmlformats.org/drawingml/2006/main">
-            <a:off x="8039100" y="1714500"/>
-            <a:ext cx="3143250" cy="342900"/>
-          </a:xfrm>
-          <a:prstGeom xmlns:a="http://schemas.openxmlformats.org/drawingml/2006/main" prst="rect">
-            <a:avLst/>
-          </a:prstGeom>
-          <a:noFill xmlns:a="http://schemas.openxmlformats.org/drawingml/2006/main"/>
-          <a:ln xmlns:a="http://schemas.openxmlformats.org/drawingml/2006/main" w="0">
-            <a:noFill/>
-            <a:prstDash val="solid"/>
-          </a:ln>
-        </p:spPr>
-        <p:txBody>
-          <a:bodyPr xmlns:a="http://schemas.openxmlformats.org/drawingml/2006/main" wrap="square" lIns="0" tIns="0" rIns="0" bIns="0" anchor="t">
-            <a:normAutofit fontScale="100000"/>
-          </a:bodyPr>
-          <a:lstStyle xmlns:a="http://schemas.openxmlformats.org/drawingml/2006/main"/>
-          <a:p xmlns:a="http://schemas.openxmlformats.org/drawingml/2006/main">
-            <a:pPr algn="l">
-              <a:lnSpc>
-                <a:spcPct val="106000"/>
-              </a:lnSpc>
-              <a:buNone/>
-              <a:defRPr sz="1875" b="1">
-                <a:solidFill>
-                  <a:srgbClr val="2F6FB6"/>
-                </a:solidFill>
-                <a:latin typeface="Arial Unicode MS"/>
-                <a:ea typeface="Arial Unicode MS"/>
-                <a:cs typeface="Arial Unicode MS"/>
-              </a:defRPr>
-            </a:pPr>
-            <a:r>
-              <a:rPr sz="1875" b="1">
-                <a:solidFill>
-                  <a:srgbClr val="2F6FB6"/>
-                </a:solidFill>
-                <a:latin typeface="Arial Unicode MS"/>
-                <a:ea typeface="Arial Unicode MS"/>
-                <a:cs typeface="Arial Unicode MS"/>
-              </a:rPr>
-              <a:t>系统边界</a:t>
-            </a:r>
-          </a:p>
-        </p:txBody>
-      </p:sp>
-      <p:sp>
-        <p:nvSpPr>
-          <p:cNvPr id="12" name="">
-            <a:extLst xmlns:a="http://schemas.openxmlformats.org/drawingml/2006/main">
-              <a:ext uri="{FF2B5EF4-FFF2-40B4-BE49-F238E27FC236}">
-                <a16:creationId xmlns:a16="http://schemas.microsoft.com/office/drawing/2014/main" id="{3FC90A63-4DAD-4827-B80E-F6F73DC57EF0}"/>
-              </a:ext>
-            </a:extLst>
-          </p:cNvPr>
-          <p:cNvSpPr>
-            <a:spLocks xmlns:a="http://schemas.openxmlformats.org/drawingml/2006/main" noGrp="1"/>
-          </p:cNvSpPr>
-          <p:nvPr/>
-        </p:nvSpPr>
-        <p:spPr>
-          <a:xfrm xmlns:a="http://schemas.openxmlformats.org/drawingml/2006/main">
-            <a:off x="8039100" y="2171700"/>
-            <a:ext cx="3143250" cy="28575"/>
-          </a:xfrm>
-          <a:prstGeom xmlns:a="http://schemas.openxmlformats.org/drawingml/2006/main" prst="rect">
-            <a:avLst/>
-          </a:prstGeom>
-          <a:solidFill xmlns:a="http://schemas.openxmlformats.org/drawingml/2006/main">
-            <a:srgbClr val="2F6FB6"/>
-          </a:solidFill>
-          <a:ln xmlns:a="http://schemas.openxmlformats.org/drawingml/2006/main" w="0">
-            <a:noFill/>
-            <a:prstDash val="solid"/>
-          </a:ln>
-        </p:spPr>
-      </p:sp>
-      <p:sp>
-        <p:nvSpPr>
-          <p:cNvPr id="13" name="">
-            <a:extLst xmlns:a="http://schemas.openxmlformats.org/drawingml/2006/main">
-              <a:ext uri="{FF2B5EF4-FFF2-40B4-BE49-F238E27FC236}">
-                <a16:creationId xmlns:a16="http://schemas.microsoft.com/office/drawing/2014/main" id="{F0E6C171-175C-4A68-B81C-6F3601CBF1F8}"/>
-              </a:ext>
-            </a:extLst>
-          </p:cNvPr>
-          <p:cNvSpPr>
-            <a:spLocks xmlns:a="http://schemas.openxmlformats.org/drawingml/2006/main" noGrp="1"/>
-          </p:cNvSpPr>
-          <p:nvPr/>
-        </p:nvSpPr>
-        <p:spPr>
-          <a:xfrm xmlns:a="http://schemas.openxmlformats.org/drawingml/2006/main">
-            <a:off x="8039100" y="2457450"/>
-            <a:ext cx="3143250" cy="2266950"/>
-          </a:xfrm>
-          <a:prstGeom xmlns:a="http://schemas.openxmlformats.org/drawingml/2006/main" prst="rect">
-            <a:avLst/>
-          </a:prstGeom>
-          <a:noFill xmlns:a="http://schemas.openxmlformats.org/drawingml/2006/main"/>
-          <a:ln xmlns:a="http://schemas.openxmlformats.org/drawingml/2006/main" w="0">
-            <a:noFill/>
-            <a:prstDash val="solid"/>
-          </a:ln>
-        </p:spPr>
-        <p:txBody>
-          <a:bodyPr xmlns:a="http://schemas.openxmlformats.org/drawingml/2006/main" wrap="square" lIns="0" tIns="0" rIns="0" bIns="0" anchor="t">
-            <a:normAutofit fontScale="100000"/>
-          </a:bodyPr>
-          <a:lstStyle xmlns:a="http://schemas.openxmlformats.org/drawingml/2006/main"/>
-          <a:p xmlns:a="http://schemas.openxmlformats.org/drawingml/2006/main">
-            <a:pPr algn="l">
-              <a:lnSpc>
-                <a:spcPct val="120000"/>
-              </a:lnSpc>
-              <a:buNone/>
-              <a:defRPr sz="1500" b="0">
-                <a:solidFill>
-                  <a:srgbClr val="17232E"/>
-                </a:solidFill>
-                <a:latin typeface="Arial Unicode MS"/>
-                <a:ea typeface="Arial Unicode MS"/>
-                <a:cs typeface="Arial Unicode MS"/>
-              </a:defRPr>
-            </a:pPr>
-            <a:r>
-              <a:rPr sz="1500" b="0">
-                <a:solidFill>
-                  <a:srgbClr val="17232E"/>
-                </a:solidFill>
-                <a:latin typeface="Arial Unicode MS"/>
-                <a:ea typeface="Arial Unicode MS"/>
-                <a:cs typeface="Arial Unicode MS"/>
-              </a:rPr>
-              <a:t>• 新结果会更新状态和 GP</a:t>
-            </a:r>
-          </a:p>
-          <a:p xmlns:a="http://schemas.openxmlformats.org/drawingml/2006/main">
-            <a:pPr algn="l">
-              <a:lnSpc>
-                <a:spcPct val="120000"/>
-              </a:lnSpc>
-              <a:buNone/>
-              <a:defRPr sz="1500" b="0">
-                <a:solidFill>
-                  <a:srgbClr val="17232E"/>
-                </a:solidFill>
-                <a:latin typeface="Arial Unicode MS"/>
-                <a:ea typeface="Arial Unicode MS"/>
-                <a:cs typeface="Arial Unicode MS"/>
-              </a:defRPr>
-            </a:pPr>
-            <a:r>
-              <a:rPr sz="1500" b="0">
-                <a:solidFill>
-                  <a:srgbClr val="17232E"/>
-                </a:solidFill>
-                <a:latin typeface="Arial Unicode MS"/>
-                <a:ea typeface="Arial Unicode MS"/>
-                <a:cs typeface="Arial Unicode MS"/>
-              </a:rPr>
-              <a:t>• 不训练 LLM 模型权重</a:t>
-            </a:r>
-          </a:p>
-          <a:p xmlns:a="http://schemas.openxmlformats.org/drawingml/2006/main">
-            <a:pPr algn="l">
-              <a:lnSpc>
-                <a:spcPct val="120000"/>
-              </a:lnSpc>
-              <a:buNone/>
-              <a:defRPr sz="1500" b="0">
-                <a:solidFill>
-                  <a:srgbClr val="17232E"/>
-                </a:solidFill>
-                <a:latin typeface="Arial Unicode MS"/>
-                <a:ea typeface="Arial Unicode MS"/>
-                <a:cs typeface="Arial Unicode MS"/>
-              </a:defRPr>
-            </a:pPr>
-            <a:r>
-              <a:rPr sz="1500" b="0">
-                <a:solidFill>
-                  <a:srgbClr val="17232E"/>
-                </a:solidFill>
-                <a:latin typeface="Arial Unicode MS"/>
-                <a:ea typeface="Arial Unicode MS"/>
-                <a:cs typeface="Arial Unicode MS"/>
-              </a:rPr>
-              <a:t>• trace 尚未自动蒸馏为永久 skill</a:t>
-            </a:r>
-          </a:p>
-          <a:p xmlns:a="http://schemas.openxmlformats.org/drawingml/2006/main">
-            <a:pPr algn="l">
-              <a:lnSpc>
-                <a:spcPct val="120000"/>
-              </a:lnSpc>
-              <a:buNone/>
-              <a:defRPr sz="1500" b="0">
-                <a:solidFill>
-                  <a:srgbClr val="17232E"/>
-                </a:solidFill>
-                <a:latin typeface="Arial Unicode MS"/>
-                <a:ea typeface="Arial Unicode MS"/>
-                <a:cs typeface="Arial Unicode MS"/>
-              </a:defRPr>
-            </a:pPr>
-            <a:r>
-              <a:rPr sz="1500" b="0">
-                <a:solidFill>
-                  <a:srgbClr val="17232E"/>
-                </a:solidFill>
-                <a:latin typeface="Arial Unicode MS"/>
-                <a:ea typeface="Arial Unicode MS"/>
-                <a:cs typeface="Arial Unicode MS"/>
-              </a:rPr>
-              <a:t>• 负迁移路线不会被删除</a:t>
-            </a:r>
-          </a:p>
-        </p:txBody>
-      </p:sp>
-      <p:sp>
-        <p:nvSpPr>
-          <p:cNvPr id="14" name="">
-            <a:extLst xmlns:a="http://schemas.openxmlformats.org/drawingml/2006/main">
-              <a:ext uri="{FF2B5EF4-FFF2-40B4-BE49-F238E27FC236}">
-                <a16:creationId xmlns:a16="http://schemas.microsoft.com/office/drawing/2014/main" id="{5DA5B1B0-A476-4A17-870B-B30AB152AA40}"/>
-              </a:ext>
-            </a:extLst>
-          </p:cNvPr>
-          <p:cNvSpPr>
-            <a:spLocks xmlns:a="http://schemas.openxmlformats.org/drawingml/2006/main" noGrp="1"/>
-          </p:cNvSpPr>
-          <p:nvPr/>
-        </p:nvSpPr>
-        <p:spPr>
-          <a:xfrm xmlns:a="http://schemas.openxmlformats.org/drawingml/2006/main">
-            <a:off x="647700" y="5219700"/>
-            <a:ext cx="10896600" cy="800100"/>
-          </a:xfrm>
-          <a:prstGeom xmlns:a="http://schemas.openxmlformats.org/drawingml/2006/main" prst="rect">
-            <a:avLst/>
-          </a:prstGeom>
-          <a:solidFill xmlns:a="http://schemas.openxmlformats.org/drawingml/2006/main">
-            <a:srgbClr val="17324D"/>
-          </a:solidFill>
-          <a:ln xmlns:a="http://schemas.openxmlformats.org/drawingml/2006/main" w="0">
-            <a:noFill/>
-            <a:prstDash val="solid"/>
-          </a:ln>
-        </p:spPr>
-      </p:sp>
-      <p:sp>
-        <p:nvSpPr>
-          <p:cNvPr id="15" name="">
-            <a:extLst xmlns:a="http://schemas.openxmlformats.org/drawingml/2006/main">
-              <a:ext uri="{FF2B5EF4-FFF2-40B4-BE49-F238E27FC236}">
-                <a16:creationId xmlns:a16="http://schemas.microsoft.com/office/drawing/2014/main" id="{347E0A7A-9D50-4462-9357-1E2DF1605B5F}"/>
-              </a:ext>
-            </a:extLst>
-          </p:cNvPr>
-          <p:cNvSpPr>
-            <a:spLocks xmlns:a="http://schemas.openxmlformats.org/drawingml/2006/main" noGrp="1"/>
-          </p:cNvSpPr>
-          <p:nvPr/>
-        </p:nvSpPr>
-        <p:spPr>
-          <a:xfrm xmlns:a="http://schemas.openxmlformats.org/drawingml/2006/main">
-            <a:off x="857250" y="5353050"/>
-            <a:ext cx="10477500" cy="552450"/>
-          </a:xfrm>
-          <a:prstGeom xmlns:a="http://schemas.openxmlformats.org/drawingml/2006/main" prst="rect">
-            <a:avLst/>
-          </a:prstGeom>
-          <a:noFill xmlns:a="http://schemas.openxmlformats.org/drawingml/2006/main"/>
-          <a:ln xmlns:a="http://schemas.openxmlformats.org/drawingml/2006/main" w="0">
-            <a:noFill/>
-            <a:prstDash val="solid"/>
-          </a:ln>
-        </p:spPr>
-        <p:txBody>
-          <a:bodyPr xmlns:a="http://schemas.openxmlformats.org/drawingml/2006/main" wrap="square" lIns="0" tIns="0" rIns="0" bIns="0" anchor="ctr">
-            <a:normAutofit fontScale="99125"/>
-          </a:bodyPr>
-          <a:lstStyle xmlns:a="http://schemas.openxmlformats.org/drawingml/2006/main"/>
-          <a:p xmlns:a="http://schemas.openxmlformats.org/drawingml/2006/main">
-            <a:pPr algn="ctr">
-              <a:lnSpc>
-                <a:spcPct val="106000"/>
-              </a:lnSpc>
-              <a:buNone/>
-              <a:defRPr sz="1725" b="1">
-                <a:solidFill>
-                  <a:srgbClr val="FFFFFF"/>
-                </a:solidFill>
-                <a:latin typeface="Arial Unicode MS"/>
-                <a:ea typeface="Arial Unicode MS"/>
-                <a:cs typeface="Arial Unicode MS"/>
-              </a:defRPr>
-            </a:pPr>
-            <a:r>
-              <a:rPr sz="1725" b="1">
-                <a:solidFill>
-                  <a:srgbClr val="FFFFFF"/>
-                </a:solidFill>
-                <a:latin typeface="Arial Unicode MS"/>
-                <a:ea typeface="Arial Unicode MS"/>
-                <a:cs typeface="Arial Unicode MS"/>
-              </a:rPr>
-              <a:t>一句话：CARE 2.0 已证明 LLM 能在部分路线里把旧知识变成更早的高值发现；</a:t>
-            </a:r>
-          </a:p>
-          <a:p xmlns:a="http://schemas.openxmlformats.org/drawingml/2006/main">
-            <a:pPr algn="ctr">
-              <a:lnSpc>
-                <a:spcPct val="106000"/>
-              </a:lnSpc>
-              <a:buNone/>
-              <a:defRPr sz="1725" b="1">
-                <a:solidFill>
-                  <a:srgbClr val="FFFFFF"/>
-                </a:solidFill>
-                <a:latin typeface="Arial Unicode MS"/>
-                <a:ea typeface="Arial Unicode MS"/>
-                <a:cs typeface="Arial Unicode MS"/>
-              </a:defRPr>
-            </a:pPr>
-            <a:r>
-              <a:rPr sz="1725" b="1">
-                <a:solidFill>
-                  <a:srgbClr val="FFFFFF"/>
-                </a:solidFill>
-                <a:latin typeface="Arial Unicode MS"/>
-                <a:ea typeface="Arial Unicode MS"/>
-                <a:cs typeface="Arial Unicode MS"/>
-              </a:rPr>
-              <a:t>能否稳定泛化，必须靠冻结协议、独立重复和前瞻实验回答。</a:t>
-            </a:r>
-          </a:p>
-        </p:txBody>
-      </p:sp>
-      <p:sp>
-        <p:nvSpPr>
-          <p:cNvPr id="16" name="">
-            <a:extLst xmlns:a="http://schemas.openxmlformats.org/drawingml/2006/main">
-              <a:ext uri="{FF2B5EF4-FFF2-40B4-BE49-F238E27FC236}">
-                <a16:creationId xmlns:a16="http://schemas.microsoft.com/office/drawing/2014/main" id="{D63BEB5A-896B-489B-8B8A-474FCA6E07C2}"/>
-              </a:ext>
-            </a:extLst>
-          </p:cNvPr>
-          <p:cNvSpPr>
-            <a:spLocks xmlns:a="http://schemas.openxmlformats.org/drawingml/2006/main" noGrp="1"/>
-          </p:cNvSpPr>
-          <p:nvPr/>
-        </p:nvSpPr>
-        <p:spPr>
-          <a:xfrm xmlns:a="http://schemas.openxmlformats.org/drawingml/2006/main">
-            <a:off x="647700" y="6600825"/>
-            <a:ext cx="10896600" cy="133350"/>
-          </a:xfrm>
-          <a:prstGeom xmlns:a="http://schemas.openxmlformats.org/drawingml/2006/main" prst="rect">
-            <a:avLst/>
-          </a:prstGeom>
-          <a:noFill xmlns:a="http://schemas.openxmlformats.org/drawingml/2006/main"/>
-          <a:ln xmlns:a="http://schemas.openxmlformats.org/drawingml/2006/main" w="0">
-            <a:noFill/>
-            <a:prstDash val="solid"/>
-          </a:ln>
-        </p:spPr>
-        <p:txBody>
-          <a:bodyPr xmlns:a="http://schemas.openxmlformats.org/drawingml/2006/main" wrap="square" lIns="0" tIns="0" rIns="0" bIns="0" anchor="t">
-            <a:normAutofit fontScale="100000"/>
-          </a:bodyPr>
-          <a:lstStyle xmlns:a="http://schemas.openxmlformats.org/drawingml/2006/main"/>
-          <a:p xmlns:a="http://schemas.openxmlformats.org/drawingml/2006/main">
-            <a:pPr algn="r">
-              <a:lnSpc>
-                <a:spcPct val="106000"/>
-              </a:lnSpc>
-              <a:buNone/>
               <a:defRPr sz="750" b="0">
                 <a:solidFill>
                   <a:srgbClr val="8B959D"/>
@@ -5012,15 +4416,38 @@
                 <a:ea typeface="Arial Unicode MS"/>
                 <a:cs typeface="Arial Unicode MS"/>
               </a:rPr>
-              <a:t>CARE 2.0 · online LLM evidence update · 2026-08-23</a:t>
-            </a:r>
-          </a:p>
-        </p:txBody>
-      </p:sp>
+              <a:t>CARE 2.0 · online LLM evidence update · 2026-08-24</a:t>
+            </a:r>
+          </a:p>
+        </p:txBody>
+      </p:sp>
+      <p:pic>
+        <p:nvPicPr>
+          <p:cNvPr id="16" name=""/>
+          <p:cNvPicPr>
+            <a:picLocks xmlns:a="http://schemas.openxmlformats.org/drawingml/2006/main" noChangeAspect="1"/>
+          </p:cNvPicPr>
+          <p:nvPr/>
+        </p:nvPicPr>
+        <p:blipFill>
+          <a:blip xmlns:r="http://schemas.openxmlformats.org/officeDocument/2006/relationships" xmlns:a="http://schemas.openxmlformats.org/drawingml/2006/main" r:embed="Rb184f924b9ef40c2"/>
+          <a:srcRect xmlns:a="http://schemas.openxmlformats.org/drawingml/2006/main" l="0" t="12000" r="0" b="0"/>
+          <a:stretch xmlns:a="http://schemas.openxmlformats.org/drawingml/2006/main"/>
+        </p:blipFill>
+        <p:spPr>
+          <a:xfrm xmlns:a="http://schemas.openxmlformats.org/drawingml/2006/main" flipH="0" flipV="0">
+            <a:off x="1462686" y="1257300"/>
+            <a:ext cx="9266627" cy="5105400"/>
+          </a:xfrm>
+          <a:prstGeom xmlns:a="http://schemas.openxmlformats.org/drawingml/2006/main" prst="rect">
+            <a:avLst/>
+          </a:prstGeom>
+        </p:spPr>
+      </p:pic>
     </p:spTree>
     <p:extLst>
       <p:ext uri="{BB962C8B-B14F-4D97-AF65-F5344CB8AC3E}">
-        <p14:creationId xmlns:p14="http://schemas.microsoft.com/office/powerpoint/2010/main" val="1901578672"/>
+        <p14:creationId xmlns:p14="http://schemas.microsoft.com/office/powerpoint/2010/main" val="248175514"/>
       </p:ext>
     </p:extLst>
   </p:cSld>
@@ -5048,10 +4475,10 @@
       </p:grpSpPr>
       <p:sp>
         <p:nvSpPr>
-          <p:cNvPr id="26" name="">
-            <a:extLst xmlns:a="http://schemas.openxmlformats.org/drawingml/2006/main">
-              <a:ext uri="{FF2B5EF4-FFF2-40B4-BE49-F238E27FC236}">
-                <a16:creationId xmlns:a16="http://schemas.microsoft.com/office/drawing/2014/main" id="{CF7F2D13-8B4E-4B7B-942E-F0FA2569EDC5}"/>
+          <p:cNvPr id="17" name="">
+            <a:extLst xmlns:a="http://schemas.openxmlformats.org/drawingml/2006/main">
+              <a:ext uri="{FF2B5EF4-FFF2-40B4-BE49-F238E27FC236}">
+                <a16:creationId xmlns:a16="http://schemas.microsoft.com/office/drawing/2014/main" id="{F13116EE-10E9-42CB-87E9-9FFCF69EA14A}"/>
               </a:ext>
             </a:extLst>
           </p:cNvPr>
@@ -5103,7 +4530,7 @@
                 <a:ea typeface="Arial Unicode MS"/>
                 <a:cs typeface="Arial Unicode MS"/>
               </a:rPr>
-              <a:t>下一步</a:t>
+              <a:t>现在能说什么</a:t>
             </a:r>
           </a:p>
         </p:txBody>
@@ -5113,7 +4540,7 @@
           <p:cNvPr id="2" name="">
             <a:extLst xmlns:a="http://schemas.openxmlformats.org/drawingml/2006/main">
               <a:ext uri="{FF2B5EF4-FFF2-40B4-BE49-F238E27FC236}">
-                <a16:creationId xmlns:a16="http://schemas.microsoft.com/office/drawing/2014/main" id="{FB1C6B19-68E6-44C5-A6F5-4D3CDD25A058}"/>
+                <a16:creationId xmlns:a16="http://schemas.microsoft.com/office/drawing/2014/main" id="{7C93BB4F-687E-41EA-880C-DA077418C84A}"/>
               </a:ext>
             </a:extLst>
           </p:cNvPr>
@@ -5175,7 +4602,7 @@
           <p:cNvPr id="3" name="">
             <a:extLst xmlns:a="http://schemas.openxmlformats.org/drawingml/2006/main">
               <a:ext uri="{FF2B5EF4-FFF2-40B4-BE49-F238E27FC236}">
-                <a16:creationId xmlns:a16="http://schemas.microsoft.com/office/drawing/2014/main" id="{630DFCA5-FB0C-4D8C-BF5E-A41CE4647145}"/>
+                <a16:creationId xmlns:a16="http://schemas.microsoft.com/office/drawing/2014/main" id="{9CC42BAC-7B39-48DE-98FE-F217E9DA94C0}"/>
               </a:ext>
             </a:extLst>
           </p:cNvPr>
@@ -5209,25 +4636,25 @@
                 <a:spcPct val="96000"/>
               </a:lnSpc>
               <a:buNone/>
-              <a:defRPr sz="2550" b="1">
-                <a:solidFill>
-                  <a:srgbClr val="17232E"/>
-                </a:solidFill>
-                <a:latin typeface="Arial Unicode MS"/>
-                <a:ea typeface="Arial Unicode MS"/>
-                <a:cs typeface="Arial Unicode MS"/>
-              </a:defRPr>
-            </a:pPr>
-            <a:r>
-              <a:rPr sz="2550" b="1">
-                <a:solidFill>
-                  <a:srgbClr val="17232E"/>
-                </a:solidFill>
-                <a:latin typeface="Arial Unicode MS"/>
-                <a:ea typeface="Arial Unicode MS"/>
-                <a:cs typeface="Arial Unicode MS"/>
-              </a:rPr>
-              <a:t>独立重复已经启动，下一步完成冻结确认</a:t>
+              <a:defRPr sz="2475" b="1">
+                <a:solidFill>
+                  <a:srgbClr val="17232E"/>
+                </a:solidFill>
+                <a:latin typeface="Arial Unicode MS"/>
+                <a:ea typeface="Arial Unicode MS"/>
+                <a:cs typeface="Arial Unicode MS"/>
+              </a:defRPr>
+            </a:pPr>
+            <a:r>
+              <a:rPr sz="2475" b="1">
+                <a:solidFill>
+                  <a:srgbClr val="17232E"/>
+                </a:solidFill>
+                <a:latin typeface="Arial Unicode MS"/>
+                <a:ea typeface="Arial Unicode MS"/>
+                <a:cs typeface="Arial Unicode MS"/>
+              </a:rPr>
+              <a:t>当前证据支持“路线特异的正向信号”，不支持“普遍跨领域提升”</a:t>
             </a:r>
           </a:p>
         </p:txBody>
@@ -5237,7 +4664,7 @@
           <p:cNvPr id="4" name="">
             <a:extLst xmlns:a="http://schemas.openxmlformats.org/drawingml/2006/main">
               <a:ext uri="{FF2B5EF4-FFF2-40B4-BE49-F238E27FC236}">
-                <a16:creationId xmlns:a16="http://schemas.microsoft.com/office/drawing/2014/main" id="{FA4400FA-5A0E-4659-B4E5-4C74DFCCB429}"/>
+                <a16:creationId xmlns:a16="http://schemas.microsoft.com/office/drawing/2014/main" id="{A7036B3D-8368-4946-B1A4-22E1178B0E5B}"/>
               </a:ext>
             </a:extLst>
           </p:cNvPr>
@@ -5268,6 +4695,1142 @@
           <p:cNvPr id="5" name="">
             <a:extLst xmlns:a="http://schemas.openxmlformats.org/drawingml/2006/main">
               <a:ext uri="{FF2B5EF4-FFF2-40B4-BE49-F238E27FC236}">
+                <a16:creationId xmlns:a16="http://schemas.microsoft.com/office/drawing/2014/main" id="{57D85720-6F57-4F74-A324-0BFA22D53BFC}"/>
+              </a:ext>
+            </a:extLst>
+          </p:cNvPr>
+          <p:cNvSpPr>
+            <a:spLocks xmlns:a="http://schemas.openxmlformats.org/drawingml/2006/main" noGrp="1"/>
+          </p:cNvSpPr>
+          <p:nvPr/>
+        </p:nvSpPr>
+        <p:spPr>
+          <a:xfrm xmlns:a="http://schemas.openxmlformats.org/drawingml/2006/main">
+            <a:off x="647700" y="1714500"/>
+            <a:ext cx="3143250" cy="342900"/>
+          </a:xfrm>
+          <a:prstGeom xmlns:a="http://schemas.openxmlformats.org/drawingml/2006/main" prst="rect">
+            <a:avLst/>
+          </a:prstGeom>
+          <a:noFill xmlns:a="http://schemas.openxmlformats.org/drawingml/2006/main"/>
+          <a:ln xmlns:a="http://schemas.openxmlformats.org/drawingml/2006/main" w="0">
+            <a:noFill/>
+            <a:prstDash val="solid"/>
+          </a:ln>
+        </p:spPr>
+        <p:txBody>
+          <a:bodyPr xmlns:a="http://schemas.openxmlformats.org/drawingml/2006/main" wrap="square" lIns="0" tIns="0" rIns="0" bIns="0" anchor="t">
+            <a:normAutofit fontScale="100000"/>
+          </a:bodyPr>
+          <a:lstStyle xmlns:a="http://schemas.openxmlformats.org/drawingml/2006/main"/>
+          <a:p xmlns:a="http://schemas.openxmlformats.org/drawingml/2006/main">
+            <a:pPr algn="l">
+              <a:lnSpc>
+                <a:spcPct val="106000"/>
+              </a:lnSpc>
+              <a:buNone/>
+              <a:defRPr sz="1875" b="1">
+                <a:solidFill>
+                  <a:srgbClr val="2C8A62"/>
+                </a:solidFill>
+                <a:latin typeface="Arial Unicode MS"/>
+                <a:ea typeface="Arial Unicode MS"/>
+                <a:cs typeface="Arial Unicode MS"/>
+              </a:defRPr>
+            </a:pPr>
+            <a:r>
+              <a:rPr sz="1875" b="1">
+                <a:solidFill>
+                  <a:srgbClr val="2C8A62"/>
+                </a:solidFill>
+                <a:latin typeface="Arial Unicode MS"/>
+                <a:ea typeface="Arial Unicode MS"/>
+                <a:cs typeface="Arial Unicode MS"/>
+              </a:rPr>
+              <a:t>已经做到</a:t>
+            </a:r>
+          </a:p>
+        </p:txBody>
+      </p:sp>
+      <p:sp>
+        <p:nvSpPr>
+          <p:cNvPr id="6" name="">
+            <a:extLst xmlns:a="http://schemas.openxmlformats.org/drawingml/2006/main">
+              <a:ext uri="{FF2B5EF4-FFF2-40B4-BE49-F238E27FC236}">
+                <a16:creationId xmlns:a16="http://schemas.microsoft.com/office/drawing/2014/main" id="{F1C3C5FB-A495-4A31-9A88-FA2DD4032E37}"/>
+              </a:ext>
+            </a:extLst>
+          </p:cNvPr>
+          <p:cNvSpPr>
+            <a:spLocks xmlns:a="http://schemas.openxmlformats.org/drawingml/2006/main" noGrp="1"/>
+          </p:cNvSpPr>
+          <p:nvPr/>
+        </p:nvSpPr>
+        <p:spPr>
+          <a:xfrm xmlns:a="http://schemas.openxmlformats.org/drawingml/2006/main">
+            <a:off x="647700" y="2171700"/>
+            <a:ext cx="3143250" cy="28575"/>
+          </a:xfrm>
+          <a:prstGeom xmlns:a="http://schemas.openxmlformats.org/drawingml/2006/main" prst="rect">
+            <a:avLst/>
+          </a:prstGeom>
+          <a:solidFill xmlns:a="http://schemas.openxmlformats.org/drawingml/2006/main">
+            <a:srgbClr val="2C8A62"/>
+          </a:solidFill>
+          <a:ln xmlns:a="http://schemas.openxmlformats.org/drawingml/2006/main" w="0">
+            <a:noFill/>
+            <a:prstDash val="solid"/>
+          </a:ln>
+        </p:spPr>
+      </p:sp>
+      <p:sp>
+        <p:nvSpPr>
+          <p:cNvPr id="7" name="">
+            <a:extLst xmlns:a="http://schemas.openxmlformats.org/drawingml/2006/main">
+              <a:ext uri="{FF2B5EF4-FFF2-40B4-BE49-F238E27FC236}">
+                <a16:creationId xmlns:a16="http://schemas.microsoft.com/office/drawing/2014/main" id="{7EA04F9C-2AAB-439F-AAAB-57819E2FBFBB}"/>
+              </a:ext>
+            </a:extLst>
+          </p:cNvPr>
+          <p:cNvSpPr>
+            <a:spLocks xmlns:a="http://schemas.openxmlformats.org/drawingml/2006/main" noGrp="1"/>
+          </p:cNvSpPr>
+          <p:nvPr/>
+        </p:nvSpPr>
+        <p:spPr>
+          <a:xfrm xmlns:a="http://schemas.openxmlformats.org/drawingml/2006/main">
+            <a:off x="647700" y="2457450"/>
+            <a:ext cx="3143250" cy="2266950"/>
+          </a:xfrm>
+          <a:prstGeom xmlns:a="http://schemas.openxmlformats.org/drawingml/2006/main" prst="rect">
+            <a:avLst/>
+          </a:prstGeom>
+          <a:noFill xmlns:a="http://schemas.openxmlformats.org/drawingml/2006/main"/>
+          <a:ln xmlns:a="http://schemas.openxmlformats.org/drawingml/2006/main" w="0">
+            <a:noFill/>
+            <a:prstDash val="solid"/>
+          </a:ln>
+        </p:spPr>
+        <p:txBody>
+          <a:bodyPr xmlns:a="http://schemas.openxmlformats.org/drawingml/2006/main" wrap="square" lIns="0" tIns="0" rIns="0" bIns="0" anchor="t">
+            <a:normAutofit fontScale="100000"/>
+          </a:bodyPr>
+          <a:lstStyle xmlns:a="http://schemas.openxmlformats.org/drawingml/2006/main"/>
+          <a:p xmlns:a="http://schemas.openxmlformats.org/drawingml/2006/main">
+            <a:pPr algn="l">
+              <a:lnSpc>
+                <a:spcPct val="120000"/>
+              </a:lnSpc>
+              <a:buNone/>
+              <a:defRPr sz="1500" b="0">
+                <a:solidFill>
+                  <a:srgbClr val="17232E"/>
+                </a:solidFill>
+                <a:latin typeface="Arial Unicode MS"/>
+                <a:ea typeface="Arial Unicode MS"/>
+                <a:cs typeface="Arial Unicode MS"/>
+              </a:defRPr>
+            </a:pPr>
+            <a:r>
+              <a:rPr sz="1500" b="0">
+                <a:solidFill>
+                  <a:srgbClr val="17232E"/>
+                </a:solidFill>
+                <a:latin typeface="Arial Unicode MS"/>
+                <a:ea typeface="Arial Unicode MS"/>
+                <a:cs typeface="Arial Unicode MS"/>
+              </a:rPr>
+              <a:t>• 无泄漏 replay 与同预算对照</a:t>
+            </a:r>
+          </a:p>
+          <a:p xmlns:a="http://schemas.openxmlformats.org/drawingml/2006/main">
+            <a:pPr algn="l">
+              <a:lnSpc>
+                <a:spcPct val="120000"/>
+              </a:lnSpc>
+              <a:buNone/>
+              <a:defRPr sz="1500" b="0">
+                <a:solidFill>
+                  <a:srgbClr val="17232E"/>
+                </a:solidFill>
+                <a:latin typeface="Arial Unicode MS"/>
+                <a:ea typeface="Arial Unicode MS"/>
+                <a:cs typeface="Arial Unicode MS"/>
+              </a:defRPr>
+            </a:pPr>
+            <a:r>
+              <a:rPr sz="1500" b="0">
+                <a:solidFill>
+                  <a:srgbClr val="17232E"/>
+                </a:solidFill>
+                <a:latin typeface="Arial Unicode MS"/>
+                <a:ea typeface="Arial Unicode MS"/>
+                <a:cs typeface="Arial Unicode MS"/>
+              </a:rPr>
+              <a:t>• 覆盖化学、分子和材料任务</a:t>
+            </a:r>
+          </a:p>
+          <a:p xmlns:a="http://schemas.openxmlformats.org/drawingml/2006/main">
+            <a:pPr algn="l">
+              <a:lnSpc>
+                <a:spcPct val="120000"/>
+              </a:lnSpc>
+              <a:buNone/>
+              <a:defRPr sz="1500" b="0">
+                <a:solidFill>
+                  <a:srgbClr val="17232E"/>
+                </a:solidFill>
+                <a:latin typeface="Arial Unicode MS"/>
+                <a:ea typeface="Arial Unicode MS"/>
+                <a:cs typeface="Arial Unicode MS"/>
+              </a:defRPr>
+            </a:pPr>
+            <a:r>
+              <a:rPr sz="1500" b="0">
+                <a:solidFill>
+                  <a:srgbClr val="17232E"/>
+                </a:solidFill>
+                <a:latin typeface="Arial Unicode MS"/>
+                <a:ea typeface="Arial Unicode MS"/>
+                <a:cs typeface="Arial Unicode MS"/>
+              </a:rPr>
+              <a:t>• 三条 context-robust 轨迹均正向</a:t>
+            </a:r>
+          </a:p>
+          <a:p xmlns:a="http://schemas.openxmlformats.org/drawingml/2006/main">
+            <a:pPr algn="l">
+              <a:lnSpc>
+                <a:spcPct val="120000"/>
+              </a:lnSpc>
+              <a:buNone/>
+              <a:defRPr sz="1500" b="0">
+                <a:solidFill>
+                  <a:srgbClr val="17232E"/>
+                </a:solidFill>
+                <a:latin typeface="Arial Unicode MS"/>
+                <a:ea typeface="Arial Unicode MS"/>
+                <a:cs typeface="Arial Unicode MS"/>
+              </a:defRPr>
+            </a:pPr>
+            <a:r>
+              <a:rPr sz="1500" b="0">
+                <a:solidFill>
+                  <a:srgbClr val="17232E"/>
+                </a:solidFill>
+                <a:latin typeface="Arial Unicode MS"/>
+                <a:ea typeface="Arial Unicode MS"/>
+                <a:cs typeface="Arial Unicode MS"/>
+              </a:rPr>
+              <a:t>• prompt、选择、结果和失败可追溯</a:t>
+            </a:r>
+          </a:p>
+        </p:txBody>
+      </p:sp>
+      <p:sp>
+        <p:nvSpPr>
+          <p:cNvPr id="8" name="">
+            <a:extLst xmlns:a="http://schemas.openxmlformats.org/drawingml/2006/main">
+              <a:ext uri="{FF2B5EF4-FFF2-40B4-BE49-F238E27FC236}">
+                <a16:creationId xmlns:a16="http://schemas.microsoft.com/office/drawing/2014/main" id="{50E871CA-3863-4F0F-AD47-D7F772330FD6}"/>
+              </a:ext>
+            </a:extLst>
+          </p:cNvPr>
+          <p:cNvSpPr>
+            <a:spLocks xmlns:a="http://schemas.openxmlformats.org/drawingml/2006/main" noGrp="1"/>
+          </p:cNvSpPr>
+          <p:nvPr/>
+        </p:nvSpPr>
+        <p:spPr>
+          <a:xfrm xmlns:a="http://schemas.openxmlformats.org/drawingml/2006/main">
+            <a:off x="4343400" y="1714500"/>
+            <a:ext cx="3143250" cy="342900"/>
+          </a:xfrm>
+          <a:prstGeom xmlns:a="http://schemas.openxmlformats.org/drawingml/2006/main" prst="rect">
+            <a:avLst/>
+          </a:prstGeom>
+          <a:noFill xmlns:a="http://schemas.openxmlformats.org/drawingml/2006/main"/>
+          <a:ln xmlns:a="http://schemas.openxmlformats.org/drawingml/2006/main" w="0">
+            <a:noFill/>
+            <a:prstDash val="solid"/>
+          </a:ln>
+        </p:spPr>
+        <p:txBody>
+          <a:bodyPr xmlns:a="http://schemas.openxmlformats.org/drawingml/2006/main" wrap="square" lIns="0" tIns="0" rIns="0" bIns="0" anchor="t">
+            <a:normAutofit fontScale="100000"/>
+          </a:bodyPr>
+          <a:lstStyle xmlns:a="http://schemas.openxmlformats.org/drawingml/2006/main"/>
+          <a:p xmlns:a="http://schemas.openxmlformats.org/drawingml/2006/main">
+            <a:pPr algn="l">
+              <a:lnSpc>
+                <a:spcPct val="106000"/>
+              </a:lnSpc>
+              <a:buNone/>
+              <a:defRPr sz="1875" b="1">
+                <a:solidFill>
+                  <a:srgbClr val="C94D4D"/>
+                </a:solidFill>
+                <a:latin typeface="Arial Unicode MS"/>
+                <a:ea typeface="Arial Unicode MS"/>
+                <a:cs typeface="Arial Unicode MS"/>
+              </a:defRPr>
+            </a:pPr>
+            <a:r>
+              <a:rPr sz="1875" b="1">
+                <a:solidFill>
+                  <a:srgbClr val="C94D4D"/>
+                </a:solidFill>
+                <a:latin typeface="Arial Unicode MS"/>
+                <a:ea typeface="Arial Unicode MS"/>
+                <a:cs typeface="Arial Unicode MS"/>
+              </a:rPr>
+              <a:t>还没有做到</a:t>
+            </a:r>
+          </a:p>
+        </p:txBody>
+      </p:sp>
+      <p:sp>
+        <p:nvSpPr>
+          <p:cNvPr id="9" name="">
+            <a:extLst xmlns:a="http://schemas.openxmlformats.org/drawingml/2006/main">
+              <a:ext uri="{FF2B5EF4-FFF2-40B4-BE49-F238E27FC236}">
+                <a16:creationId xmlns:a16="http://schemas.microsoft.com/office/drawing/2014/main" id="{F03EDA0F-719B-4FB6-8EF4-3EE305D0169A}"/>
+              </a:ext>
+            </a:extLst>
+          </p:cNvPr>
+          <p:cNvSpPr>
+            <a:spLocks xmlns:a="http://schemas.openxmlformats.org/drawingml/2006/main" noGrp="1"/>
+          </p:cNvSpPr>
+          <p:nvPr/>
+        </p:nvSpPr>
+        <p:spPr>
+          <a:xfrm xmlns:a="http://schemas.openxmlformats.org/drawingml/2006/main">
+            <a:off x="4343400" y="2171700"/>
+            <a:ext cx="3143250" cy="28575"/>
+          </a:xfrm>
+          <a:prstGeom xmlns:a="http://schemas.openxmlformats.org/drawingml/2006/main" prst="rect">
+            <a:avLst/>
+          </a:prstGeom>
+          <a:solidFill xmlns:a="http://schemas.openxmlformats.org/drawingml/2006/main">
+            <a:srgbClr val="C94D4D"/>
+          </a:solidFill>
+          <a:ln xmlns:a="http://schemas.openxmlformats.org/drawingml/2006/main" w="0">
+            <a:noFill/>
+            <a:prstDash val="solid"/>
+          </a:ln>
+        </p:spPr>
+      </p:sp>
+      <p:sp>
+        <p:nvSpPr>
+          <p:cNvPr id="10" name="">
+            <a:extLst xmlns:a="http://schemas.openxmlformats.org/drawingml/2006/main">
+              <a:ext uri="{FF2B5EF4-FFF2-40B4-BE49-F238E27FC236}">
+                <a16:creationId xmlns:a16="http://schemas.microsoft.com/office/drawing/2014/main" id="{68841F36-5B20-49DF-BA94-2CB3D6E69748}"/>
+              </a:ext>
+            </a:extLst>
+          </p:cNvPr>
+          <p:cNvSpPr>
+            <a:spLocks xmlns:a="http://schemas.openxmlformats.org/drawingml/2006/main" noGrp="1"/>
+          </p:cNvSpPr>
+          <p:nvPr/>
+        </p:nvSpPr>
+        <p:spPr>
+          <a:xfrm xmlns:a="http://schemas.openxmlformats.org/drawingml/2006/main">
+            <a:off x="4343400" y="2457450"/>
+            <a:ext cx="3143250" cy="2266950"/>
+          </a:xfrm>
+          <a:prstGeom xmlns:a="http://schemas.openxmlformats.org/drawingml/2006/main" prst="rect">
+            <a:avLst/>
+          </a:prstGeom>
+          <a:noFill xmlns:a="http://schemas.openxmlformats.org/drawingml/2006/main"/>
+          <a:ln xmlns:a="http://schemas.openxmlformats.org/drawingml/2006/main" w="0">
+            <a:noFill/>
+            <a:prstDash val="solid"/>
+          </a:ln>
+        </p:spPr>
+        <p:txBody>
+          <a:bodyPr xmlns:a="http://schemas.openxmlformats.org/drawingml/2006/main" wrap="square" lIns="0" tIns="0" rIns="0" bIns="0" anchor="t">
+            <a:normAutofit fontScale="100000"/>
+          </a:bodyPr>
+          <a:lstStyle xmlns:a="http://schemas.openxmlformats.org/drawingml/2006/main"/>
+          <a:p xmlns:a="http://schemas.openxmlformats.org/drawingml/2006/main">
+            <a:pPr algn="l">
+              <a:lnSpc>
+                <a:spcPct val="120000"/>
+              </a:lnSpc>
+              <a:buNone/>
+              <a:defRPr sz="1500" b="0">
+                <a:solidFill>
+                  <a:srgbClr val="17232E"/>
+                </a:solidFill>
+                <a:latin typeface="Arial Unicode MS"/>
+                <a:ea typeface="Arial Unicode MS"/>
+                <a:cs typeface="Arial Unicode MS"/>
+              </a:defRPr>
+            </a:pPr>
+            <a:r>
+              <a:rPr sz="1500" b="0">
+                <a:solidFill>
+                  <a:srgbClr val="17232E"/>
+                </a:solidFill>
+                <a:latin typeface="Arial Unicode MS"/>
+                <a:ea typeface="Arial Unicode MS"/>
+                <a:cs typeface="Arial Unicode MS"/>
+              </a:rPr>
+              <a:t>• 每条路线足量、独立的 LLM 重复</a:t>
+            </a:r>
+          </a:p>
+          <a:p xmlns:a="http://schemas.openxmlformats.org/drawingml/2006/main">
+            <a:pPr algn="l">
+              <a:lnSpc>
+                <a:spcPct val="120000"/>
+              </a:lnSpc>
+              <a:buNone/>
+              <a:defRPr sz="1500" b="0">
+                <a:solidFill>
+                  <a:srgbClr val="17232E"/>
+                </a:solidFill>
+                <a:latin typeface="Arial Unicode MS"/>
+                <a:ea typeface="Arial Unicode MS"/>
+                <a:cs typeface="Arial Unicode MS"/>
+              </a:defRPr>
+            </a:pPr>
+            <a:r>
+              <a:rPr sz="1500" b="0">
+                <a:solidFill>
+                  <a:srgbClr val="17232E"/>
+                </a:solidFill>
+                <a:latin typeface="Arial Unicode MS"/>
+                <a:ea typeface="Arial Unicode MS"/>
+                <a:cs typeface="Arial Unicode MS"/>
+              </a:rPr>
+              <a:t>• 窄且不跨 0 的确认区间</a:t>
+            </a:r>
+          </a:p>
+          <a:p xmlns:a="http://schemas.openxmlformats.org/drawingml/2006/main">
+            <a:pPr algn="l">
+              <a:lnSpc>
+                <a:spcPct val="120000"/>
+              </a:lnSpc>
+              <a:buNone/>
+              <a:defRPr sz="1500" b="0">
+                <a:solidFill>
+                  <a:srgbClr val="17232E"/>
+                </a:solidFill>
+                <a:latin typeface="Arial Unicode MS"/>
+                <a:ea typeface="Arial Unicode MS"/>
+                <a:cs typeface="Arial Unicode MS"/>
+              </a:defRPr>
+            </a:pPr>
+            <a:r>
+              <a:rPr sz="1500" b="0">
+                <a:solidFill>
+                  <a:srgbClr val="17232E"/>
+                </a:solidFill>
+                <a:latin typeface="Arial Unicode MS"/>
+                <a:ea typeface="Arial Unicode MS"/>
+                <a:cs typeface="Arial Unicode MS"/>
+              </a:rPr>
+              <a:t>• 预先选型后稳定超过 transfer GP</a:t>
+            </a:r>
+          </a:p>
+          <a:p xmlns:a="http://schemas.openxmlformats.org/drawingml/2006/main">
+            <a:pPr algn="l">
+              <a:lnSpc>
+                <a:spcPct val="120000"/>
+              </a:lnSpc>
+              <a:buNone/>
+              <a:defRPr sz="1500" b="0">
+                <a:solidFill>
+                  <a:srgbClr val="17232E"/>
+                </a:solidFill>
+                <a:latin typeface="Arial Unicode MS"/>
+                <a:ea typeface="Arial Unicode MS"/>
+                <a:cs typeface="Arial Unicode MS"/>
+              </a:defRPr>
+            </a:pPr>
+            <a:r>
+              <a:rPr sz="1500" b="0">
+                <a:solidFill>
+                  <a:srgbClr val="17232E"/>
+                </a:solidFill>
+                <a:latin typeface="Arial Unicode MS"/>
+                <a:ea typeface="Arial Unicode MS"/>
+                <a:cs typeface="Arial Unicode MS"/>
+              </a:rPr>
+              <a:t>• 前瞻 wet-lab 独立验证</a:t>
+            </a:r>
+          </a:p>
+        </p:txBody>
+      </p:sp>
+      <p:sp>
+        <p:nvSpPr>
+          <p:cNvPr id="11" name="">
+            <a:extLst xmlns:a="http://schemas.openxmlformats.org/drawingml/2006/main">
+              <a:ext uri="{FF2B5EF4-FFF2-40B4-BE49-F238E27FC236}">
+                <a16:creationId xmlns:a16="http://schemas.microsoft.com/office/drawing/2014/main" id="{FA4E01B4-FF74-43B9-836C-866227510DCD}"/>
+              </a:ext>
+            </a:extLst>
+          </p:cNvPr>
+          <p:cNvSpPr>
+            <a:spLocks xmlns:a="http://schemas.openxmlformats.org/drawingml/2006/main" noGrp="1"/>
+          </p:cNvSpPr>
+          <p:nvPr/>
+        </p:nvSpPr>
+        <p:spPr>
+          <a:xfrm xmlns:a="http://schemas.openxmlformats.org/drawingml/2006/main">
+            <a:off x="8039100" y="1714500"/>
+            <a:ext cx="3143250" cy="342900"/>
+          </a:xfrm>
+          <a:prstGeom xmlns:a="http://schemas.openxmlformats.org/drawingml/2006/main" prst="rect">
+            <a:avLst/>
+          </a:prstGeom>
+          <a:noFill xmlns:a="http://schemas.openxmlformats.org/drawingml/2006/main"/>
+          <a:ln xmlns:a="http://schemas.openxmlformats.org/drawingml/2006/main" w="0">
+            <a:noFill/>
+            <a:prstDash val="solid"/>
+          </a:ln>
+        </p:spPr>
+        <p:txBody>
+          <a:bodyPr xmlns:a="http://schemas.openxmlformats.org/drawingml/2006/main" wrap="square" lIns="0" tIns="0" rIns="0" bIns="0" anchor="t">
+            <a:normAutofit fontScale="100000"/>
+          </a:bodyPr>
+          <a:lstStyle xmlns:a="http://schemas.openxmlformats.org/drawingml/2006/main"/>
+          <a:p xmlns:a="http://schemas.openxmlformats.org/drawingml/2006/main">
+            <a:pPr algn="l">
+              <a:lnSpc>
+                <a:spcPct val="106000"/>
+              </a:lnSpc>
+              <a:buNone/>
+              <a:defRPr sz="1875" b="1">
+                <a:solidFill>
+                  <a:srgbClr val="2F6FB6"/>
+                </a:solidFill>
+                <a:latin typeface="Arial Unicode MS"/>
+                <a:ea typeface="Arial Unicode MS"/>
+                <a:cs typeface="Arial Unicode MS"/>
+              </a:defRPr>
+            </a:pPr>
+            <a:r>
+              <a:rPr sz="1875" b="1">
+                <a:solidFill>
+                  <a:srgbClr val="2F6FB6"/>
+                </a:solidFill>
+                <a:latin typeface="Arial Unicode MS"/>
+                <a:ea typeface="Arial Unicode MS"/>
+                <a:cs typeface="Arial Unicode MS"/>
+              </a:rPr>
+              <a:t>系统边界</a:t>
+            </a:r>
+          </a:p>
+        </p:txBody>
+      </p:sp>
+      <p:sp>
+        <p:nvSpPr>
+          <p:cNvPr id="12" name="">
+            <a:extLst xmlns:a="http://schemas.openxmlformats.org/drawingml/2006/main">
+              <a:ext uri="{FF2B5EF4-FFF2-40B4-BE49-F238E27FC236}">
+                <a16:creationId xmlns:a16="http://schemas.microsoft.com/office/drawing/2014/main" id="{3FC90A63-4DAD-4827-B80E-F6F73DC57EF0}"/>
+              </a:ext>
+            </a:extLst>
+          </p:cNvPr>
+          <p:cNvSpPr>
+            <a:spLocks xmlns:a="http://schemas.openxmlformats.org/drawingml/2006/main" noGrp="1"/>
+          </p:cNvSpPr>
+          <p:nvPr/>
+        </p:nvSpPr>
+        <p:spPr>
+          <a:xfrm xmlns:a="http://schemas.openxmlformats.org/drawingml/2006/main">
+            <a:off x="8039100" y="2171700"/>
+            <a:ext cx="3143250" cy="28575"/>
+          </a:xfrm>
+          <a:prstGeom xmlns:a="http://schemas.openxmlformats.org/drawingml/2006/main" prst="rect">
+            <a:avLst/>
+          </a:prstGeom>
+          <a:solidFill xmlns:a="http://schemas.openxmlformats.org/drawingml/2006/main">
+            <a:srgbClr val="2F6FB6"/>
+          </a:solidFill>
+          <a:ln xmlns:a="http://schemas.openxmlformats.org/drawingml/2006/main" w="0">
+            <a:noFill/>
+            <a:prstDash val="solid"/>
+          </a:ln>
+        </p:spPr>
+      </p:sp>
+      <p:sp>
+        <p:nvSpPr>
+          <p:cNvPr id="13" name="">
+            <a:extLst xmlns:a="http://schemas.openxmlformats.org/drawingml/2006/main">
+              <a:ext uri="{FF2B5EF4-FFF2-40B4-BE49-F238E27FC236}">
+                <a16:creationId xmlns:a16="http://schemas.microsoft.com/office/drawing/2014/main" id="{F0E6C171-175C-4A68-B81C-6F3601CBF1F8}"/>
+              </a:ext>
+            </a:extLst>
+          </p:cNvPr>
+          <p:cNvSpPr>
+            <a:spLocks xmlns:a="http://schemas.openxmlformats.org/drawingml/2006/main" noGrp="1"/>
+          </p:cNvSpPr>
+          <p:nvPr/>
+        </p:nvSpPr>
+        <p:spPr>
+          <a:xfrm xmlns:a="http://schemas.openxmlformats.org/drawingml/2006/main">
+            <a:off x="8039100" y="2457450"/>
+            <a:ext cx="3143250" cy="2266950"/>
+          </a:xfrm>
+          <a:prstGeom xmlns:a="http://schemas.openxmlformats.org/drawingml/2006/main" prst="rect">
+            <a:avLst/>
+          </a:prstGeom>
+          <a:noFill xmlns:a="http://schemas.openxmlformats.org/drawingml/2006/main"/>
+          <a:ln xmlns:a="http://schemas.openxmlformats.org/drawingml/2006/main" w="0">
+            <a:noFill/>
+            <a:prstDash val="solid"/>
+          </a:ln>
+        </p:spPr>
+        <p:txBody>
+          <a:bodyPr xmlns:a="http://schemas.openxmlformats.org/drawingml/2006/main" wrap="square" lIns="0" tIns="0" rIns="0" bIns="0" anchor="t">
+            <a:normAutofit fontScale="100000"/>
+          </a:bodyPr>
+          <a:lstStyle xmlns:a="http://schemas.openxmlformats.org/drawingml/2006/main"/>
+          <a:p xmlns:a="http://schemas.openxmlformats.org/drawingml/2006/main">
+            <a:pPr algn="l">
+              <a:lnSpc>
+                <a:spcPct val="120000"/>
+              </a:lnSpc>
+              <a:buNone/>
+              <a:defRPr sz="1500" b="0">
+                <a:solidFill>
+                  <a:srgbClr val="17232E"/>
+                </a:solidFill>
+                <a:latin typeface="Arial Unicode MS"/>
+                <a:ea typeface="Arial Unicode MS"/>
+                <a:cs typeface="Arial Unicode MS"/>
+              </a:defRPr>
+            </a:pPr>
+            <a:r>
+              <a:rPr sz="1500" b="0">
+                <a:solidFill>
+                  <a:srgbClr val="17232E"/>
+                </a:solidFill>
+                <a:latin typeface="Arial Unicode MS"/>
+                <a:ea typeface="Arial Unicode MS"/>
+                <a:cs typeface="Arial Unicode MS"/>
+              </a:rPr>
+              <a:t>• 新结果更新状态、GP 和假设</a:t>
+            </a:r>
+          </a:p>
+          <a:p xmlns:a="http://schemas.openxmlformats.org/drawingml/2006/main">
+            <a:pPr algn="l">
+              <a:lnSpc>
+                <a:spcPct val="120000"/>
+              </a:lnSpc>
+              <a:buNone/>
+              <a:defRPr sz="1500" b="0">
+                <a:solidFill>
+                  <a:srgbClr val="17232E"/>
+                </a:solidFill>
+                <a:latin typeface="Arial Unicode MS"/>
+                <a:ea typeface="Arial Unicode MS"/>
+                <a:cs typeface="Arial Unicode MS"/>
+              </a:defRPr>
+            </a:pPr>
+            <a:r>
+              <a:rPr sz="1500" b="0">
+                <a:solidFill>
+                  <a:srgbClr val="17232E"/>
+                </a:solidFill>
+                <a:latin typeface="Arial Unicode MS"/>
+                <a:ea typeface="Arial Unicode MS"/>
+                <a:cs typeface="Arial Unicode MS"/>
+              </a:rPr>
+              <a:t>• 证据不足时可关闭 source transfer</a:t>
+            </a:r>
+          </a:p>
+          <a:p xmlns:a="http://schemas.openxmlformats.org/drawingml/2006/main">
+            <a:pPr algn="l">
+              <a:lnSpc>
+                <a:spcPct val="120000"/>
+              </a:lnSpc>
+              <a:buNone/>
+              <a:defRPr sz="1500" b="0">
+                <a:solidFill>
+                  <a:srgbClr val="17232E"/>
+                </a:solidFill>
+                <a:latin typeface="Arial Unicode MS"/>
+                <a:ea typeface="Arial Unicode MS"/>
+                <a:cs typeface="Arial Unicode MS"/>
+              </a:defRPr>
+            </a:pPr>
+            <a:r>
+              <a:rPr sz="1500" b="0">
+                <a:solidFill>
+                  <a:srgbClr val="17232E"/>
+                </a:solidFill>
+                <a:latin typeface="Arial Unicode MS"/>
+                <a:ea typeface="Arial Unicode MS"/>
+                <a:cs typeface="Arial Unicode MS"/>
+              </a:rPr>
+              <a:t>• 不训练 LLM 模型权重</a:t>
+            </a:r>
+          </a:p>
+          <a:p xmlns:a="http://schemas.openxmlformats.org/drawingml/2006/main">
+            <a:pPr algn="l">
+              <a:lnSpc>
+                <a:spcPct val="120000"/>
+              </a:lnSpc>
+              <a:buNone/>
+              <a:defRPr sz="1500" b="0">
+                <a:solidFill>
+                  <a:srgbClr val="17232E"/>
+                </a:solidFill>
+                <a:latin typeface="Arial Unicode MS"/>
+                <a:ea typeface="Arial Unicode MS"/>
+                <a:cs typeface="Arial Unicode MS"/>
+              </a:defRPr>
+            </a:pPr>
+            <a:r>
+              <a:rPr sz="1500" b="0">
+                <a:solidFill>
+                  <a:srgbClr val="17232E"/>
+                </a:solidFill>
+                <a:latin typeface="Arial Unicode MS"/>
+                <a:ea typeface="Arial Unicode MS"/>
+                <a:cs typeface="Arial Unicode MS"/>
+              </a:rPr>
+              <a:t>• trace 尚未自动蒸馏为永久 skill</a:t>
+            </a:r>
+          </a:p>
+        </p:txBody>
+      </p:sp>
+      <p:sp>
+        <p:nvSpPr>
+          <p:cNvPr id="14" name="">
+            <a:extLst xmlns:a="http://schemas.openxmlformats.org/drawingml/2006/main">
+              <a:ext uri="{FF2B5EF4-FFF2-40B4-BE49-F238E27FC236}">
+                <a16:creationId xmlns:a16="http://schemas.microsoft.com/office/drawing/2014/main" id="{5DA5B1B0-A476-4A17-870B-B30AB152AA40}"/>
+              </a:ext>
+            </a:extLst>
+          </p:cNvPr>
+          <p:cNvSpPr>
+            <a:spLocks xmlns:a="http://schemas.openxmlformats.org/drawingml/2006/main" noGrp="1"/>
+          </p:cNvSpPr>
+          <p:nvPr/>
+        </p:nvSpPr>
+        <p:spPr>
+          <a:xfrm xmlns:a="http://schemas.openxmlformats.org/drawingml/2006/main">
+            <a:off x="647700" y="5219700"/>
+            <a:ext cx="10896600" cy="800100"/>
+          </a:xfrm>
+          <a:prstGeom xmlns:a="http://schemas.openxmlformats.org/drawingml/2006/main" prst="rect">
+            <a:avLst/>
+          </a:prstGeom>
+          <a:solidFill xmlns:a="http://schemas.openxmlformats.org/drawingml/2006/main">
+            <a:srgbClr val="17324D"/>
+          </a:solidFill>
+          <a:ln xmlns:a="http://schemas.openxmlformats.org/drawingml/2006/main" w="0">
+            <a:noFill/>
+            <a:prstDash val="solid"/>
+          </a:ln>
+        </p:spPr>
+      </p:sp>
+      <p:sp>
+        <p:nvSpPr>
+          <p:cNvPr id="15" name="">
+            <a:extLst xmlns:a="http://schemas.openxmlformats.org/drawingml/2006/main">
+              <a:ext uri="{FF2B5EF4-FFF2-40B4-BE49-F238E27FC236}">
+                <a16:creationId xmlns:a16="http://schemas.microsoft.com/office/drawing/2014/main" id="{347E0A7A-9D50-4462-9357-1E2DF1605B5F}"/>
+              </a:ext>
+            </a:extLst>
+          </p:cNvPr>
+          <p:cNvSpPr>
+            <a:spLocks xmlns:a="http://schemas.openxmlformats.org/drawingml/2006/main" noGrp="1"/>
+          </p:cNvSpPr>
+          <p:nvPr/>
+        </p:nvSpPr>
+        <p:spPr>
+          <a:xfrm xmlns:a="http://schemas.openxmlformats.org/drawingml/2006/main">
+            <a:off x="857250" y="5353050"/>
+            <a:ext cx="10477500" cy="552450"/>
+          </a:xfrm>
+          <a:prstGeom xmlns:a="http://schemas.openxmlformats.org/drawingml/2006/main" prst="rect">
+            <a:avLst/>
+          </a:prstGeom>
+          <a:noFill xmlns:a="http://schemas.openxmlformats.org/drawingml/2006/main"/>
+          <a:ln xmlns:a="http://schemas.openxmlformats.org/drawingml/2006/main" w="0">
+            <a:noFill/>
+            <a:prstDash val="solid"/>
+          </a:ln>
+        </p:spPr>
+        <p:txBody>
+          <a:bodyPr xmlns:a="http://schemas.openxmlformats.org/drawingml/2006/main" wrap="square" lIns="0" tIns="0" rIns="0" bIns="0" anchor="ctr">
+            <a:normAutofit fontScale="99125"/>
+          </a:bodyPr>
+          <a:lstStyle xmlns:a="http://schemas.openxmlformats.org/drawingml/2006/main"/>
+          <a:p xmlns:a="http://schemas.openxmlformats.org/drawingml/2006/main">
+            <a:pPr algn="ctr">
+              <a:lnSpc>
+                <a:spcPct val="106000"/>
+              </a:lnSpc>
+              <a:buNone/>
+              <a:defRPr sz="1725" b="1">
+                <a:solidFill>
+                  <a:srgbClr val="FFFFFF"/>
+                </a:solidFill>
+                <a:latin typeface="Arial Unicode MS"/>
+                <a:ea typeface="Arial Unicode MS"/>
+                <a:cs typeface="Arial Unicode MS"/>
+              </a:defRPr>
+            </a:pPr>
+            <a:r>
+              <a:rPr sz="1725" b="1">
+                <a:solidFill>
+                  <a:srgbClr val="FFFFFF"/>
+                </a:solidFill>
+                <a:latin typeface="Arial Unicode MS"/>
+                <a:ea typeface="Arial Unicode MS"/>
+                <a:cs typeface="Arial Unicode MS"/>
+              </a:rPr>
+              <a:t>一句话：LLM 已能在三类真实 replay 中改变搜索并识别不可靠迁移；</a:t>
+            </a:r>
+          </a:p>
+          <a:p xmlns:a="http://schemas.openxmlformats.org/drawingml/2006/main">
+            <a:pPr algn="ctr">
+              <a:lnSpc>
+                <a:spcPct val="106000"/>
+              </a:lnSpc>
+              <a:buNone/>
+              <a:defRPr sz="1725" b="1">
+                <a:solidFill>
+                  <a:srgbClr val="FFFFFF"/>
+                </a:solidFill>
+                <a:latin typeface="Arial Unicode MS"/>
+                <a:ea typeface="Arial Unicode MS"/>
+                <a:cs typeface="Arial Unicode MS"/>
+              </a:defRPr>
+            </a:pPr>
+            <a:r>
+              <a:rPr sz="1725" b="1">
+                <a:solidFill>
+                  <a:srgbClr val="FFFFFF"/>
+                </a:solidFill>
+                <a:latin typeface="Arial Unicode MS"/>
+                <a:ea typeface="Arial Unicode MS"/>
+                <a:cs typeface="Arial Unicode MS"/>
+              </a:rPr>
+              <a:t>是否稳定泛化，仍必须靠冻结重复、强 baseline 和前瞻实验回答。</a:t>
+            </a:r>
+          </a:p>
+        </p:txBody>
+      </p:sp>
+      <p:sp>
+        <p:nvSpPr>
+          <p:cNvPr id="16" name="">
+            <a:extLst xmlns:a="http://schemas.openxmlformats.org/drawingml/2006/main">
+              <a:ext uri="{FF2B5EF4-FFF2-40B4-BE49-F238E27FC236}">
+                <a16:creationId xmlns:a16="http://schemas.microsoft.com/office/drawing/2014/main" id="{D63BEB5A-896B-489B-8B8A-474FCA6E07C2}"/>
+              </a:ext>
+            </a:extLst>
+          </p:cNvPr>
+          <p:cNvSpPr>
+            <a:spLocks xmlns:a="http://schemas.openxmlformats.org/drawingml/2006/main" noGrp="1"/>
+          </p:cNvSpPr>
+          <p:nvPr/>
+        </p:nvSpPr>
+        <p:spPr>
+          <a:xfrm xmlns:a="http://schemas.openxmlformats.org/drawingml/2006/main">
+            <a:off x="647700" y="6600825"/>
+            <a:ext cx="10896600" cy="133350"/>
+          </a:xfrm>
+          <a:prstGeom xmlns:a="http://schemas.openxmlformats.org/drawingml/2006/main" prst="rect">
+            <a:avLst/>
+          </a:prstGeom>
+          <a:noFill xmlns:a="http://schemas.openxmlformats.org/drawingml/2006/main"/>
+          <a:ln xmlns:a="http://schemas.openxmlformats.org/drawingml/2006/main" w="0">
+            <a:noFill/>
+            <a:prstDash val="solid"/>
+          </a:ln>
+        </p:spPr>
+        <p:txBody>
+          <a:bodyPr xmlns:a="http://schemas.openxmlformats.org/drawingml/2006/main" wrap="square" lIns="0" tIns="0" rIns="0" bIns="0" anchor="t">
+            <a:normAutofit fontScale="100000"/>
+          </a:bodyPr>
+          <a:lstStyle xmlns:a="http://schemas.openxmlformats.org/drawingml/2006/main"/>
+          <a:p xmlns:a="http://schemas.openxmlformats.org/drawingml/2006/main">
+            <a:pPr algn="r">
+              <a:lnSpc>
+                <a:spcPct val="106000"/>
+              </a:lnSpc>
+              <a:buNone/>
+              <a:defRPr sz="750" b="0">
+                <a:solidFill>
+                  <a:srgbClr val="8B959D"/>
+                </a:solidFill>
+                <a:latin typeface="Arial Unicode MS"/>
+                <a:ea typeface="Arial Unicode MS"/>
+                <a:cs typeface="Arial Unicode MS"/>
+              </a:defRPr>
+            </a:pPr>
+            <a:r>
+              <a:rPr sz="750" b="0">
+                <a:solidFill>
+                  <a:srgbClr val="8B959D"/>
+                </a:solidFill>
+                <a:latin typeface="Arial Unicode MS"/>
+                <a:ea typeface="Arial Unicode MS"/>
+                <a:cs typeface="Arial Unicode MS"/>
+              </a:rPr>
+              <a:t>CARE 2.0 · online LLM evidence update · 2026-08-24</a:t>
+            </a:r>
+          </a:p>
+        </p:txBody>
+      </p:sp>
+    </p:spTree>
+    <p:extLst>
+      <p:ext uri="{BB962C8B-B14F-4D97-AF65-F5344CB8AC3E}">
+        <p14:creationId xmlns:p14="http://schemas.microsoft.com/office/powerpoint/2010/main" val="1901578672"/>
+      </p:ext>
+    </p:extLst>
+  </p:cSld>
+</p:sld>
+</file>
+
+<file path=ppt/slides/slide14.xml><?xml version="1.0" encoding="utf-8"?>
+<p:sld xmlns:p="http://schemas.openxmlformats.org/presentationml/2006/main">
+  <p:cSld>
+    <p:bg>
+      <p:bgPr>
+        <a:solidFill xmlns:a="http://schemas.openxmlformats.org/drawingml/2006/main">
+          <a:srgbClr val="FFFFFF"/>
+        </a:solidFill>
+      </p:bgPr>
+    </p:bg>
+    <p:spTree>
+      <p:nvGrpSpPr>
+        <p:cNvPr id="1" name=""/>
+        <p:cNvGrpSpPr/>
+        <p:nvPr/>
+      </p:nvGrpSpPr>
+      <p:grpSpPr>
+        <a:xfrm xmlns:a="http://schemas.openxmlformats.org/drawingml/2006/main"/>
+      </p:grpSpPr>
+      <p:sp>
+        <p:nvSpPr>
+          <p:cNvPr id="26" name="">
+            <a:extLst xmlns:a="http://schemas.openxmlformats.org/drawingml/2006/main">
+              <a:ext uri="{FF2B5EF4-FFF2-40B4-BE49-F238E27FC236}">
+                <a16:creationId xmlns:a16="http://schemas.microsoft.com/office/drawing/2014/main" id="{CF7F2D13-8B4E-4B7B-942E-F0FA2569EDC5}"/>
+              </a:ext>
+            </a:extLst>
+          </p:cNvPr>
+          <p:cNvSpPr>
+            <a:spLocks xmlns:a="http://schemas.openxmlformats.org/drawingml/2006/main" noGrp="1"/>
+          </p:cNvSpPr>
+          <p:nvPr/>
+        </p:nvSpPr>
+        <p:spPr>
+          <a:xfrm xmlns:a="http://schemas.openxmlformats.org/drawingml/2006/main">
+            <a:off x="647700" y="266700"/>
+            <a:ext cx="4191000" cy="190500"/>
+          </a:xfrm>
+          <a:prstGeom xmlns:a="http://schemas.openxmlformats.org/drawingml/2006/main" prst="rect">
+            <a:avLst/>
+          </a:prstGeom>
+          <a:noFill xmlns:a="http://schemas.openxmlformats.org/drawingml/2006/main"/>
+          <a:ln xmlns:a="http://schemas.openxmlformats.org/drawingml/2006/main" w="0">
+            <a:noFill/>
+            <a:prstDash val="solid"/>
+          </a:ln>
+        </p:spPr>
+        <p:txBody>
+          <a:bodyPr xmlns:a="http://schemas.openxmlformats.org/drawingml/2006/main" wrap="square" lIns="0" tIns="0" rIns="0" bIns="0" anchor="t">
+            <a:normAutofit fontScale="100000"/>
+          </a:bodyPr>
+          <a:lstStyle xmlns:a="http://schemas.openxmlformats.org/drawingml/2006/main"/>
+          <a:p xmlns:a="http://schemas.openxmlformats.org/drawingml/2006/main">
+            <a:pPr algn="l">
+              <a:lnSpc>
+                <a:spcPct val="106000"/>
+              </a:lnSpc>
+              <a:buNone/>
+              <a:defRPr sz="975" b="1">
+                <a:solidFill>
+                  <a:srgbClr val="2F6FB6"/>
+                </a:solidFill>
+                <a:latin typeface="Arial Unicode MS"/>
+                <a:ea typeface="Arial Unicode MS"/>
+                <a:cs typeface="Arial Unicode MS"/>
+              </a:defRPr>
+            </a:pPr>
+            <a:r>
+              <a:rPr sz="975" b="1">
+                <a:solidFill>
+                  <a:srgbClr val="2F6FB6"/>
+                </a:solidFill>
+                <a:latin typeface="Arial Unicode MS"/>
+                <a:ea typeface="Arial Unicode MS"/>
+                <a:cs typeface="Arial Unicode MS"/>
+              </a:rPr>
+              <a:t>下一步</a:t>
+            </a:r>
+          </a:p>
+        </p:txBody>
+      </p:sp>
+      <p:sp>
+        <p:nvSpPr>
+          <p:cNvPr id="2" name="">
+            <a:extLst xmlns:a="http://schemas.openxmlformats.org/drawingml/2006/main">
+              <a:ext uri="{FF2B5EF4-FFF2-40B4-BE49-F238E27FC236}">
+                <a16:creationId xmlns:a16="http://schemas.microsoft.com/office/drawing/2014/main" id="{FB1C6B19-68E6-44C5-A6F5-4D3CDD25A058}"/>
+              </a:ext>
+            </a:extLst>
+          </p:cNvPr>
+          <p:cNvSpPr>
+            <a:spLocks xmlns:a="http://schemas.openxmlformats.org/drawingml/2006/main" noGrp="1"/>
+          </p:cNvSpPr>
+          <p:nvPr/>
+        </p:nvSpPr>
+        <p:spPr>
+          <a:xfrm xmlns:a="http://schemas.openxmlformats.org/drawingml/2006/main">
+            <a:off x="11258550" y="266700"/>
+            <a:ext cx="285750" cy="171450"/>
+          </a:xfrm>
+          <a:prstGeom xmlns:a="http://schemas.openxmlformats.org/drawingml/2006/main" prst="rect">
+            <a:avLst/>
+          </a:prstGeom>
+          <a:noFill xmlns:a="http://schemas.openxmlformats.org/drawingml/2006/main"/>
+          <a:ln xmlns:a="http://schemas.openxmlformats.org/drawingml/2006/main" w="0">
+            <a:noFill/>
+            <a:prstDash val="solid"/>
+          </a:ln>
+        </p:spPr>
+        <p:txBody>
+          <a:bodyPr xmlns:a="http://schemas.openxmlformats.org/drawingml/2006/main" wrap="square" lIns="0" tIns="0" rIns="0" bIns="0" anchor="t">
+            <a:normAutofit fontScale="100000"/>
+          </a:bodyPr>
+          <a:lstStyle xmlns:a="http://schemas.openxmlformats.org/drawingml/2006/main"/>
+          <a:p xmlns:a="http://schemas.openxmlformats.org/drawingml/2006/main">
+            <a:pPr algn="r">
+              <a:lnSpc>
+                <a:spcPct val="106000"/>
+              </a:lnSpc>
+              <a:buNone/>
+              <a:defRPr sz="900" b="0">
+                <a:solidFill>
+                  <a:srgbClr val="687681"/>
+                </a:solidFill>
+                <a:latin typeface="Arial Unicode MS"/>
+                <a:ea typeface="Arial Unicode MS"/>
+                <a:cs typeface="Arial Unicode MS"/>
+              </a:defRPr>
+            </a:pPr>
+            <a:r>
+              <a:rPr sz="900" b="0">
+                <a:solidFill>
+                  <a:srgbClr val="687681"/>
+                </a:solidFill>
+                <a:latin typeface="Arial Unicode MS"/>
+                <a:ea typeface="Arial Unicode MS"/>
+                <a:cs typeface="Arial Unicode MS"/>
+              </a:rPr>
+              <a:t>14</a:t>
+            </a:r>
+          </a:p>
+        </p:txBody>
+      </p:sp>
+      <p:sp>
+        <p:nvSpPr>
+          <p:cNvPr id="3" name="">
+            <a:extLst xmlns:a="http://schemas.openxmlformats.org/drawingml/2006/main">
+              <a:ext uri="{FF2B5EF4-FFF2-40B4-BE49-F238E27FC236}">
+                <a16:creationId xmlns:a16="http://schemas.microsoft.com/office/drawing/2014/main" id="{630DFCA5-FB0C-4D8C-BF5E-A41CE4647145}"/>
+              </a:ext>
+            </a:extLst>
+          </p:cNvPr>
+          <p:cNvSpPr>
+            <a:spLocks xmlns:a="http://schemas.openxmlformats.org/drawingml/2006/main" noGrp="1"/>
+          </p:cNvSpPr>
+          <p:nvPr/>
+        </p:nvSpPr>
+        <p:spPr>
+          <a:xfrm xmlns:a="http://schemas.openxmlformats.org/drawingml/2006/main">
+            <a:off x="647700" y="552450"/>
+            <a:ext cx="10896600" cy="552450"/>
+          </a:xfrm>
+          <a:prstGeom xmlns:a="http://schemas.openxmlformats.org/drawingml/2006/main" prst="rect">
+            <a:avLst/>
+          </a:prstGeom>
+          <a:noFill xmlns:a="http://schemas.openxmlformats.org/drawingml/2006/main"/>
+          <a:ln xmlns:a="http://schemas.openxmlformats.org/drawingml/2006/main" w="0">
+            <a:noFill/>
+            <a:prstDash val="solid"/>
+          </a:ln>
+        </p:spPr>
+        <p:txBody>
+          <a:bodyPr xmlns:a="http://schemas.openxmlformats.org/drawingml/2006/main" wrap="square" lIns="0" tIns="0" rIns="0" bIns="0" anchor="t">
+            <a:normAutofit fontScale="100000"/>
+          </a:bodyPr>
+          <a:lstStyle xmlns:a="http://schemas.openxmlformats.org/drawingml/2006/main"/>
+          <a:p xmlns:a="http://schemas.openxmlformats.org/drawingml/2006/main">
+            <a:pPr algn="l">
+              <a:lnSpc>
+                <a:spcPct val="96000"/>
+              </a:lnSpc>
+              <a:buNone/>
+              <a:defRPr sz="2550" b="1">
+                <a:solidFill>
+                  <a:srgbClr val="17232E"/>
+                </a:solidFill>
+                <a:latin typeface="Arial Unicode MS"/>
+                <a:ea typeface="Arial Unicode MS"/>
+                <a:cs typeface="Arial Unicode MS"/>
+              </a:defRPr>
+            </a:pPr>
+            <a:r>
+              <a:rPr sz="2550" b="1">
+                <a:solidFill>
+                  <a:srgbClr val="17232E"/>
+                </a:solidFill>
+                <a:latin typeface="Arial Unicode MS"/>
+                <a:ea typeface="Arial Unicode MS"/>
+                <a:cs typeface="Arial Unicode MS"/>
+              </a:rPr>
+              <a:t>独立重复、强 baseline 与前瞻验证</a:t>
+            </a:r>
+          </a:p>
+        </p:txBody>
+      </p:sp>
+      <p:sp>
+        <p:nvSpPr>
+          <p:cNvPr id="4" name="">
+            <a:extLst xmlns:a="http://schemas.openxmlformats.org/drawingml/2006/main">
+              <a:ext uri="{FF2B5EF4-FFF2-40B4-BE49-F238E27FC236}">
+                <a16:creationId xmlns:a16="http://schemas.microsoft.com/office/drawing/2014/main" id="{FA4400FA-5A0E-4659-B4E5-4C74DFCCB429}"/>
+              </a:ext>
+            </a:extLst>
+          </p:cNvPr>
+          <p:cNvSpPr>
+            <a:spLocks xmlns:a="http://schemas.openxmlformats.org/drawingml/2006/main" noGrp="1"/>
+          </p:cNvSpPr>
+          <p:nvPr/>
+        </p:nvSpPr>
+        <p:spPr>
+          <a:xfrm xmlns:a="http://schemas.openxmlformats.org/drawingml/2006/main">
+            <a:off x="647700" y="1200150"/>
+            <a:ext cx="400050" cy="28575"/>
+          </a:xfrm>
+          <a:prstGeom xmlns:a="http://schemas.openxmlformats.org/drawingml/2006/main" prst="rect">
+            <a:avLst/>
+          </a:prstGeom>
+          <a:solidFill xmlns:a="http://schemas.openxmlformats.org/drawingml/2006/main">
+            <a:srgbClr val="17232E"/>
+          </a:solidFill>
+          <a:ln xmlns:a="http://schemas.openxmlformats.org/drawingml/2006/main" w="0">
+            <a:noFill/>
+            <a:prstDash val="solid"/>
+          </a:ln>
+        </p:spPr>
+      </p:sp>
+      <p:sp>
+        <p:nvSpPr>
+          <p:cNvPr id="5" name="">
+            <a:extLst xmlns:a="http://schemas.openxmlformats.org/drawingml/2006/main">
+              <a:ext uri="{FF2B5EF4-FFF2-40B4-BE49-F238E27FC236}">
                 <a16:creationId xmlns:a16="http://schemas.microsoft.com/office/drawing/2014/main" id="{40D7FD66-9A24-4FB5-87EB-78C973CCDABA}"/>
               </a:ext>
             </a:extLst>
@@ -5444,7 +6007,7 @@
                 <a:ea typeface="Arial Unicode MS"/>
                 <a:cs typeface="Arial Unicode MS"/>
               </a:rPr>
-              <a:t>v1 已完成 11 / 330；v2 已完成 1 / 330。全部完成前不做确认性推断。</a:t>
+              <a:t>Opus 冻结 v1 为 11/330；另有 3 条 context-robust 轨迹；GLM 暂无完整轨迹。</a:t>
             </a:r>
           </a:p>
         </p:txBody>
@@ -5599,7 +6162,7 @@
                 <a:ea typeface="Arial Unicode MS"/>
                 <a:cs typeface="Arial Unicode MS"/>
               </a:rPr>
-              <a:t>冻结确认集</a:t>
+              <a:t>强 transfer baseline</a:t>
             </a:r>
           </a:p>
         </p:txBody>
@@ -5661,7 +6224,7 @@
                 <a:ea typeface="Arial Unicode MS"/>
                 <a:cs typeface="Arial Unicode MS"/>
               </a:rPr>
-              <a:t>保留未参与任何调参的新 source-target pair，并预注册主要指标、失败处理和分析。</a:t>
+              <a:t>同开局审计已完成 3 条；下一步预先选型，并扩大到冻结重复协议。</a:t>
             </a:r>
           </a:p>
         </p:txBody>
@@ -6312,7 +6875,7 @@
                 <a:ea typeface="Arial Unicode MS"/>
                 <a:cs typeface="Arial Unicode MS"/>
               </a:rPr>
-              <a:t>公开代码、数据版本、完整 trace、模型版本、哈希和精确统计口径。</a:t>
+              <a:t>公开代码、数据、完整 trace、模型版本、失败记录和精确统计口径。</a:t>
             </a:r>
           </a:p>
         </p:txBody>
@@ -6405,7 +6968,7 @@
                 <a:ea typeface="Arial Unicode MS"/>
                 <a:cs typeface="Arial Unicode MS"/>
               </a:rPr>
-              <a:t>CARE 2.0 · online LLM evidence update · 2026-08-23</a:t>
+              <a:t>CARE 2.0 · online LLM evidence update · 2026-08-24</a:t>
             </a:r>
           </a:p>
         </p:txBody>
@@ -6620,7 +7183,7 @@
                 <a:ea typeface="Arial Unicode MS"/>
                 <a:cs typeface="Arial Unicode MS"/>
               </a:rPr>
-              <a:t>LLM 全程参与 11 条真实路线，独立重复已经启动</a:t>
+              <a:t>LLM 全程参与 11 条真实路线，跨模型独立重复已经启动</a:t>
             </a:r>
           </a:p>
         </p:txBody>
@@ -7639,7 +8202,7 @@
                 <a:ea typeface="Arial Unicode MS"/>
                 <a:cs typeface="Arial Unicode MS"/>
               </a:rPr>
-              <a:t>CARE 2.0 · online LLM evidence update · 2026-08-23</a:t>
+              <a:t>CARE 2.0 · online LLM evidence update · 2026-08-24</a:t>
             </a:r>
           </a:p>
         </p:txBody>
@@ -8934,7 +9497,7 @@
                 <a:ea typeface="Arial Unicode MS"/>
                 <a:cs typeface="Arial Unicode MS"/>
               </a:rPr>
-              <a:t>CARE 2.0 · online LLM evidence update · 2026-08-23</a:t>
+              <a:t>CARE 2.0 · online LLM evidence update · 2026-08-24</a:t>
             </a:r>
           </a:p>
         </p:txBody>
@@ -10740,7 +11303,7 @@
                 <a:ea typeface="Arial Unicode MS"/>
                 <a:cs typeface="Arial Unicode MS"/>
               </a:rPr>
-              <a:t>CARE 2.0 · online LLM evidence update · 2026-08-23</a:t>
+              <a:t>CARE 2.0 · online LLM evidence update · 2026-08-24</a:t>
             </a:r>
           </a:p>
         </p:txBody>
@@ -12123,7 +12686,7 @@
                 <a:ea typeface="Arial Unicode MS"/>
                 <a:cs typeface="Arial Unicode MS"/>
               </a:rPr>
-              <a:t>CARE 2.0 · online LLM evidence update · 2026-08-23</a:t>
+              <a:t>CARE 2.0 · online LLM evidence update · 2026-08-24</a:t>
             </a:r>
           </a:p>
         </p:txBody>
@@ -13360,7 +13923,7 @@
                 <a:ea typeface="Arial Unicode MS"/>
                 <a:cs typeface="Arial Unicode MS"/>
               </a:rPr>
-              <a:t>CARE 2.0 · online LLM evidence update · 2026-08-23</a:t>
+              <a:t>CARE 2.0 · online LLM evidence update · 2026-08-24</a:t>
             </a:r>
           </a:p>
         </p:txBody>
@@ -13986,7 +14549,7 @@
                 <a:ea typeface="Arial Unicode MS"/>
                 <a:cs typeface="Arial Unicode MS"/>
               </a:rPr>
-              <a:t>固定 v2（辅助）</a:t>
+              <a:t>传统 transfer BO</a:t>
             </a:r>
           </a:p>
         </p:txBody>
@@ -14366,7 +14929,7 @@
                 <a:ea typeface="Arial Unicode MS"/>
                 <a:cs typeface="Arial Unicode MS"/>
               </a:rPr>
-              <a:t>固定规则选择</a:t>
+              <a:t>与主对照匹配</a:t>
             </a:r>
           </a:p>
         </p:txBody>
@@ -14746,7 +15309,7 @@
                 <a:ea typeface="Arial Unicode MS"/>
                 <a:cs typeface="Arial Unicode MS"/>
               </a:rPr>
-              <a:t>target-only GP-UCB</a:t>
+              <a:t>RGPE / multitask GP</a:t>
             </a:r>
           </a:p>
         </p:txBody>
@@ -15886,7 +16449,7 @@
                 <a:ea typeface="Arial Unicode MS"/>
                 <a:cs typeface="Arial Unicode MS"/>
               </a:rPr>
-              <a:t>完整系统归因</a:t>
+              <a:t>传统 transfer 对照</a:t>
             </a:r>
           </a:p>
         </p:txBody>
@@ -15979,7 +16542,7 @@
                 <a:ea typeface="Arial Unicode MS"/>
                 <a:cs typeface="Arial Unicode MS"/>
               </a:rPr>
-              <a:t>主比较只改变“后续是否由 LLM 使用 source evidence”；初始观测、候选空间和预算完全相同。</a:t>
+              <a:t>同开局压力测试：分子、材料路线超过全部 baseline；Suzuki 的 ICM-BMA 更强。</a:t>
             </a:r>
           </a:p>
         </p:txBody>
@@ -16041,7 +16604,7 @@
                 <a:ea typeface="Arial Unicode MS"/>
                 <a:cs typeface="Arial Unicode MS"/>
               </a:rPr>
-              <a:t>CARE 2.0 · online LLM evidence update · 2026-08-23</a:t>
+              <a:t>CARE 2.0 · online LLM evidence update · 2026-08-24</a:t>
             </a:r>
           </a:p>
         </p:txBody>
@@ -16740,7 +17303,7 @@
                 <a:ea typeface="Arial Unicode MS"/>
                 <a:cs typeface="Arial Unicode MS"/>
               </a:rPr>
-              <a:t>Claude Opus 4.8</a:t>
+              <a:t>Opus 4.8 / GLM 5.3</a:t>
             </a:r>
           </a:p>
         </p:txBody>
@@ -17561,7 +18124,7 @@
                 <a:ea typeface="Arial Unicode MS"/>
                 <a:cs typeface="Arial Unicode MS"/>
               </a:rPr>
-              <a:t>CARE 2.0 · online LLM evidence update · 2026-08-23</a:t>
+              <a:t>CARE 2.0 · online LLM evidence update · 2026-08-24</a:t>
             </a:r>
           </a:p>
         </p:txBody>
@@ -20234,7 +20797,7 @@
                 <a:ea typeface="Arial Unicode MS"/>
                 <a:cs typeface="Arial Unicode MS"/>
               </a:rPr>
-              <a:t>CARE 2.0 · online LLM evidence update · 2026-08-23</a:t>
+              <a:t>CARE 2.0 · online LLM evidence update · 2026-08-24</a:t>
             </a:r>
           </a:p>
         </p:txBody>

</xml_diff>

<commit_message>
experiments: add portfolio audit and calibration gate
</commit_message>
<xml_diff>
--- a/CARE2.0_Nature_evidence_update_2026-08-23.pptx
+++ b/CARE2.0_Nature_evidence_update_2026-08-23.pptx
@@ -2,26 +2,27 @@
 <file path=ppt/presentation.xml><?xml version="1.0" encoding="utf-8"?>
 <p:presentation xmlns:p="http://schemas.openxmlformats.org/presentationml/2006/main">
   <p:sldMasterIdLst>
-    <p:sldMasterId xmlns:r="http://schemas.openxmlformats.org/officeDocument/2006/relationships" id="2147483648" r:id="Rf55fde6a86394190"/>
+    <p:sldMasterId xmlns:r="http://schemas.openxmlformats.org/officeDocument/2006/relationships" id="2147483648" r:id="Rbdf8c7a59e504fcf"/>
   </p:sldMasterIdLst>
   <p:notesMasterIdLst>
-    <p:notesMasterId xmlns:r="http://schemas.openxmlformats.org/officeDocument/2006/relationships" r:id="R372e691b6a684f7c"/>
+    <p:notesMasterId xmlns:r="http://schemas.openxmlformats.org/officeDocument/2006/relationships" r:id="R8608fbc0a0ca4bef"/>
   </p:notesMasterIdLst>
   <p:sldIdLst>
-    <p:sldId xmlns:r="http://schemas.openxmlformats.org/officeDocument/2006/relationships" id="256" r:id="R9f82da3149464481"/>
-    <p:sldId xmlns:r="http://schemas.openxmlformats.org/officeDocument/2006/relationships" id="257" r:id="Rb9c382a4e2184730"/>
-    <p:sldId xmlns:r="http://schemas.openxmlformats.org/officeDocument/2006/relationships" id="258" r:id="R447fd42427ec4d93"/>
-    <p:sldId xmlns:r="http://schemas.openxmlformats.org/officeDocument/2006/relationships" id="259" r:id="Raac42eeaec7346e7"/>
-    <p:sldId xmlns:r="http://schemas.openxmlformats.org/officeDocument/2006/relationships" id="260" r:id="R84e48c17e5064842"/>
-    <p:sldId xmlns:r="http://schemas.openxmlformats.org/officeDocument/2006/relationships" id="261" r:id="Rdfbe113b226f47c0"/>
-    <p:sldId xmlns:r="http://schemas.openxmlformats.org/officeDocument/2006/relationships" id="262" r:id="R2f79a5881c444b43"/>
-    <p:sldId xmlns:r="http://schemas.openxmlformats.org/officeDocument/2006/relationships" id="263" r:id="R32705afeb31d4fb4"/>
-    <p:sldId xmlns:r="http://schemas.openxmlformats.org/officeDocument/2006/relationships" id="264" r:id="R8467e1d973c14162"/>
-    <p:sldId xmlns:r="http://schemas.openxmlformats.org/officeDocument/2006/relationships" id="265" r:id="Rad58a4d7baa04682"/>
-    <p:sldId xmlns:r="http://schemas.openxmlformats.org/officeDocument/2006/relationships" id="266" r:id="Ra6b076d7d771451f"/>
-    <p:sldId xmlns:r="http://schemas.openxmlformats.org/officeDocument/2006/relationships" id="267" r:id="Rf5799cb0bc7c435b"/>
-    <p:sldId xmlns:r="http://schemas.openxmlformats.org/officeDocument/2006/relationships" id="268" r:id="R442c462d768d47a7"/>
-    <p:sldId xmlns:r="http://schemas.openxmlformats.org/officeDocument/2006/relationships" id="269" r:id="R2a35a5ec02ec4051"/>
+    <p:sldId xmlns:r="http://schemas.openxmlformats.org/officeDocument/2006/relationships" id="256" r:id="R07cc9626a9ef40ff"/>
+    <p:sldId xmlns:r="http://schemas.openxmlformats.org/officeDocument/2006/relationships" id="257" r:id="R50206b112ec6401d"/>
+    <p:sldId xmlns:r="http://schemas.openxmlformats.org/officeDocument/2006/relationships" id="258" r:id="R6ba4e0064ba243e5"/>
+    <p:sldId xmlns:r="http://schemas.openxmlformats.org/officeDocument/2006/relationships" id="259" r:id="Ra353c1d27ce04b46"/>
+    <p:sldId xmlns:r="http://schemas.openxmlformats.org/officeDocument/2006/relationships" id="260" r:id="Rb5b42841495342cc"/>
+    <p:sldId xmlns:r="http://schemas.openxmlformats.org/officeDocument/2006/relationships" id="261" r:id="R3f89d246139e41ed"/>
+    <p:sldId xmlns:r="http://schemas.openxmlformats.org/officeDocument/2006/relationships" id="262" r:id="R3e219f34d29d4d8f"/>
+    <p:sldId xmlns:r="http://schemas.openxmlformats.org/officeDocument/2006/relationships" id="263" r:id="R6cc8a12e351740d6"/>
+    <p:sldId xmlns:r="http://schemas.openxmlformats.org/officeDocument/2006/relationships" id="264" r:id="Re2dff3a70ef64964"/>
+    <p:sldId xmlns:r="http://schemas.openxmlformats.org/officeDocument/2006/relationships" id="265" r:id="Ra6b0f3be9e854b87"/>
+    <p:sldId xmlns:r="http://schemas.openxmlformats.org/officeDocument/2006/relationships" id="266" r:id="R281f5b62f1bf415f"/>
+    <p:sldId xmlns:r="http://schemas.openxmlformats.org/officeDocument/2006/relationships" id="267" r:id="R5bb1aa1618b941fb"/>
+    <p:sldId xmlns:r="http://schemas.openxmlformats.org/officeDocument/2006/relationships" id="268" r:id="R4cb3a85b2f734f78"/>
+    <p:sldId xmlns:r="http://schemas.openxmlformats.org/officeDocument/2006/relationships" id="269" r:id="Ra06b6aad026046c0"/>
+    <p:sldId xmlns:r="http://schemas.openxmlformats.org/officeDocument/2006/relationships" id="270" r:id="R6b8c32e1fbe9441d"/>
   </p:sldIdLst>
   <p:sldSz cx="12192000" cy="6858000"/>
   <p:notesSz cx="6858000" cy="9144000"/>
@@ -490,12 +491,12 @@
           </a:p>
           <a:p xmlns:a="http://schemas.openxmlformats.org/drawingml/2006/main">
             <a:r>
-              <a:t>- /Users/rentamac/Documents/Codex/2026-05-12/app-llm-a5labs-tools/care2-opus/experiments/care_replay/CARE2_METHOD.md</a:t>
-            </a:r>
-          </a:p>
-          <a:p xmlns:a="http://schemas.openxmlformats.org/drawingml/2006/main">
-            <a:r>
-              <a:t>- /Users/rentamac/Documents/Codex/2026-05-12/app-llm-a5labs-tools/care2-opus/experiments/care_replay/scripts/run_online_llm_scientist.py</a:t>
+              <a:t>- experiments/care_replay/CARE2_METHOD.md</a:t>
+            </a:r>
+          </a:p>
+          <a:p xmlns:a="http://schemas.openxmlformats.org/drawingml/2006/main">
+            <a:r>
+              <a:t>- experiments/care_replay/scripts/run_online_llm_scientist.py</a:t>
             </a:r>
           </a:p>
         </p:txBody>
@@ -570,7 +571,7 @@
           </a:p>
           <a:p xmlns:a="http://schemas.openxmlformats.org/drawingml/2006/main">
             <a:r>
-              <a:t>真实路线结果高度异质：既有明显正迁移，也有负迁移。</a:t>
+              <a:t>真实路线结果高度异质，LLM 相对 no-transfer 更有优势，但没有稳定压过经典 transfer BO。</a:t>
             </a:r>
           </a:p>
           <a:p xmlns:a="http://schemas.openxmlformats.org/drawingml/2006/main">
@@ -585,7 +586,7 @@
           </a:p>
           <a:p xmlns:a="http://schemas.openxmlformats.org/drawingml/2006/main">
             <a:r>
-              <a:t>横轴是在线 LLM Scientist 相对同开局 target-only GP 的 best-so-far AUC 差值。正值表示更早找到好条件，负值表示迁移拖慢了搜索。11 条路线中 6 条正向、2 条持平、3 条负向。最大的正向包括 materials expt gap→dielectric（+6.75）和 FreeSolv→Lipophilicity（+6.33）；最大负向是 materials expt gap→mp gap（-2.45）。红色为冻结后化学扩展，蓝绿色为开发路线。</a:t>
+              <a:t>圆点表示在线 LLM 相对同开局 target-only GP-UCB 的 best-so-far AUC 差值；方块表示相对固定 RGPE 规则的差值。正值表示 LLM 更早找到好条件，负值表示更慢。11 条路线中，相对 target GP 为 6 胜、2 平、3 负；相对固定 RGPE 为 6 胜、1 平、4 负。最大的正向包括 expt gap→dielectric 和 FreeSolv→Lipophilicity，但若每条路线事后选择最强 baseline，LLM 只取得 3 胜、1 平、7 负。</a:t>
             </a:r>
           </a:p>
           <a:p xmlns:a="http://schemas.openxmlformats.org/drawingml/2006/main">
@@ -600,12 +601,12 @@
           </a:p>
           <a:p xmlns:a="http://schemas.openxmlformats.org/drawingml/2006/main">
             <a:r>
-              <a:t>- /Users/rentamac/Documents/Codex/2026-05-12/app-llm-a5labs-tools/care2-opus/experiments/care_replay/results/2026-08-22-submission-evidence-audit/route_evidence.csv</a:t>
-            </a:r>
-          </a:p>
-          <a:p xmlns:a="http://schemas.openxmlformats.org/drawingml/2006/main">
-            <a:r>
-              <a:t>- /Users/rentamac/Documents/Codex/2026-05-12/app-llm-a5labs-tools/care2-opus/experiments/care_replay/results/2026-08-22-submission-evidence-audit/route_level_auc_deltas.svg</a:t>
+              <a:t>- experiments/care_replay/results/2026-08-24-online-llm-predeclared-baseline-portfolio-v1/route_comparisons.csv</a:t>
+            </a:r>
+          </a:p>
+          <a:p xmlns:a="http://schemas.openxmlformats.org/drawingml/2006/main">
+            <a:r>
+              <a:t>- experiments/care_replay/results/2026-08-24-online-llm-predeclared-baseline-portfolio-v1/aggregate.json</a:t>
             </a:r>
           </a:p>
         </p:txBody>
@@ -710,17 +711,17 @@
           </a:p>
           <a:p xmlns:a="http://schemas.openxmlformats.org/drawingml/2006/main">
             <a:r>
-              <a:t>- /Users/rentamac/Documents/Codex/2026-05-12/app-llm-a5labs-tools/care2-opus/experiments/care_replay/results/2026-08-23-llm-trajectory-stability-audit/paired_route_stability.csv</a:t>
-            </a:r>
-          </a:p>
-          <a:p xmlns:a="http://schemas.openxmlformats.org/drawingml/2006/main">
-            <a:r>
-              <a:t>- /Users/rentamac/Documents/Codex/2026-05-12/app-llm-a5labs-tools/care2-opus/experiments/care_replay/results/2026-08-23-llm-trajectory-stability-audit/paired_route_stability.svg</a:t>
-            </a:r>
-          </a:p>
-          <a:p xmlns:a="http://schemas.openxmlformats.org/drawingml/2006/main">
-            <a:r>
-              <a:t>- /Users/rentamac/Documents/Codex/2026-05-12/app-llm-a5labs-tools/care2-opus/experiments/care_replay/results/2026-08-23-llm-trajectory-stability-audit/stability_audit.json</a:t>
+              <a:t>- experiments/care_replay/results/2026-08-23-llm-trajectory-stability-audit/paired_route_stability.csv</a:t>
+            </a:r>
+          </a:p>
+          <a:p xmlns:a="http://schemas.openxmlformats.org/drawingml/2006/main">
+            <a:r>
+              <a:t>- experiments/care_replay/results/2026-08-23-llm-trajectory-stability-audit/paired_route_stability.svg</a:t>
+            </a:r>
+          </a:p>
+          <a:p xmlns:a="http://schemas.openxmlformats.org/drawingml/2006/main">
+            <a:r>
+              <a:t>- experiments/care_replay/results/2026-08-23-llm-trajectory-stability-audit/stability_audit.json</a:t>
             </a:r>
           </a:p>
           <a:p xmlns:a="http://schemas.openxmlformats.org/drawingml/2006/main">
@@ -830,27 +831,27 @@
           </a:p>
           <a:p xmlns:a="http://schemas.openxmlformats.org/drawingml/2006/main">
             <a:r>
-              <a:t>- /Users/rentamac/Documents/Codex/2026-05-12/app-llm-a5labs-tools/care2-opus/experiments/care_replay/results/2026-08-24-online-llm-transport-context-robustness-v3/materials_phonons_to_bulk_modulus/trajectory_5000/summary.json</a:t>
-            </a:r>
-          </a:p>
-          <a:p xmlns:a="http://schemas.openxmlformats.org/drawingml/2006/main">
-            <a:r>
-              <a:t>- /Users/rentamac/Documents/Codex/2026-05-12/app-llm-a5labs-tools/care2-opus/experiments/care_replay/results/2026-08-24-online-llm-transport-context-robustness-v3/materials_phonons_to_bulk_modulus/trajectory_5000/llm_trace.jsonl</a:t>
-            </a:r>
-          </a:p>
-          <a:p xmlns:a="http://schemas.openxmlformats.org/drawingml/2006/main">
-            <a:r>
-              <a:t>- /Users/rentamac/Documents/Codex/2026-05-12/app-llm-a5labs-tools/care2-opus/experiments/care_replay/results/2026-08-24-online-llm-transport-context-robustness-v3/materials_phonons_to_bulk_modulus/trajectory_5000/audit/materials_online_trace_audit.json</a:t>
-            </a:r>
-          </a:p>
-          <a:p xmlns:a="http://schemas.openxmlformats.org/drawingml/2006/main">
-            <a:r>
-              <a:t>- /Users/rentamac/Documents/Codex/2026-05-12/app-llm-a5labs-tools/care2-opus/experiments/care_replay/results/2026-08-24-online-llm-outcome-semantics-robustness-v1/materials_phonons_to_bulk_modulus/trajectory_6000/summary.json</a:t>
-            </a:r>
-          </a:p>
-          <a:p xmlns:a="http://schemas.openxmlformats.org/drawingml/2006/main">
-            <a:r>
-              <a:t>- /Users/rentamac/Documents/Codex/2026-05-12/app-llm-a5labs-tools/care2-opus/experiments/care_replay/results/2026-08-24-online-llm-outcome-semantics-robustness-v1/materials_phonons_to_bulk_modulus/trajectory_6000/audit/outcome_semantics_audit.json</a:t>
+              <a:t>- experiments/care_replay/results/2026-08-24-online-llm-transport-context-robustness-v3/materials_phonons_to_bulk_modulus/trajectory_5000/summary.json</a:t>
+            </a:r>
+          </a:p>
+          <a:p xmlns:a="http://schemas.openxmlformats.org/drawingml/2006/main">
+            <a:r>
+              <a:t>- experiments/care_replay/results/2026-08-24-online-llm-transport-context-robustness-v3/materials_phonons_to_bulk_modulus/trajectory_5000/llm_trace.jsonl</a:t>
+            </a:r>
+          </a:p>
+          <a:p xmlns:a="http://schemas.openxmlformats.org/drawingml/2006/main">
+            <a:r>
+              <a:t>- experiments/care_replay/results/2026-08-24-online-llm-transport-context-robustness-v3/materials_phonons_to_bulk_modulus/trajectory_5000/audit/materials_online_trace_audit.json</a:t>
+            </a:r>
+          </a:p>
+          <a:p xmlns:a="http://schemas.openxmlformats.org/drawingml/2006/main">
+            <a:r>
+              <a:t>- experiments/care_replay/results/2026-08-24-online-llm-outcome-semantics-robustness-v1/materials_phonons_to_bulk_modulus/trajectory_6000/summary.json</a:t>
+            </a:r>
+          </a:p>
+          <a:p xmlns:a="http://schemas.openxmlformats.org/drawingml/2006/main">
+            <a:r>
+              <a:t>- experiments/care_replay/results/2026-08-24-online-llm-outcome-semantics-robustness-v1/materials_phonons_to_bulk_modulus/trajectory_6000/audit/outcome_semantics_audit.json</a:t>
             </a:r>
           </a:p>
         </p:txBody>
@@ -940,7 +941,7 @@
           </a:p>
           <a:p xmlns:a="http://schemas.openxmlformats.org/drawingml/2006/main">
             <a:r>
-              <a:t>context-preserving 协议下的分子、材料和 Suzuki 三条单轨迹均相对同开局 GP 为正，但只有分子和 Suzuki 保留了部分 direct source transfer；材料结果来自 abstention 后的 target 自适应。三条都只是 n=1 development evidence。当前系统更新 run-level state、GP 和假设，不训练模型参数，也没有自动把 trace 蒸馏成可复用 skill。</a:t>
+              <a:t>冻结 11 路线中 LLM 相对 target GP 有平均正向信号；完整 17 路线均值仍为正，但区间跨 0；面对每条路线事后最强 baseline，多数路线仍然落后。校准 Gate 把 11 路线负向数从 3 降到 2，但其相对原 LLM 的增量区间也跨 0。当前最准确定位是“可审计、可校准的知识迁移控制器”，而不是“已经普遍优于现有优化器”。</a:t>
             </a:r>
           </a:p>
           <a:p xmlns:a="http://schemas.openxmlformats.org/drawingml/2006/main">
@@ -955,12 +956,17 @@
           </a:p>
           <a:p xmlns:a="http://schemas.openxmlformats.org/drawingml/2006/main">
             <a:r>
-              <a:t>- /Users/rentamac/Documents/Codex/2026-05-12/app-llm-a5labs-tools/care2-opus/docs/NATURE_SUBMISSION_READINESS.md</a:t>
-            </a:r>
-          </a:p>
-          <a:p xmlns:a="http://schemas.openxmlformats.org/drawingml/2006/main">
-            <a:r>
-              <a:t>- /Users/rentamac/Documents/Codex/2026-05-12/app-llm-a5labs-tools/care2-opus/experiments/care_replay/results/2026-08-24-online-llm-transport-context-robustness-v3/aggregate/repeated_confirmation.json</a:t>
+              <a:t>- docs/NATURE_SUBMISSION_READINESS.md</a:t>
+            </a:r>
+          </a:p>
+          <a:p xmlns:a="http://schemas.openxmlformats.org/drawingml/2006/main">
+            <a:r>
+              <a:t>- experiments/care_replay/results/2026-08-24-online-llm-predeclared-baseline-portfolio-v2/aggregate.json</a:t>
+            </a:r>
+          </a:p>
+          <a:p xmlns:a="http://schemas.openxmlformats.org/drawingml/2006/main">
+            <a:r>
+              <a:t>- experiments/care_replay/results/2026-08-24-online-llm-calibration-gate-audit-v1/aggregate.json</a:t>
             </a:r>
           </a:p>
         </p:txBody>
@@ -1035,7 +1041,7 @@
           </a:p>
           <a:p xmlns:a="http://schemas.openxmlformats.org/drawingml/2006/main">
             <a:r>
-              <a:t>下一步必须同时完成重复、预先选型的强 transfer baseline 和前瞻实验。</a:t>
+              <a:t>下一步必须做真正前瞻的重复确认，而不是继续围绕当前路线调规则。</a:t>
             </a:r>
           </a:p>
           <a:p xmlns:a="http://schemas.openxmlformats.org/drawingml/2006/main">
@@ -1050,7 +1056,7 @@
           </a:p>
           <a:p xmlns:a="http://schemas.openxmlformats.org/drawingml/2006/main">
             <a:r>
-              <a:t>Opus 冻结 v1 已完成 11/330；context-preserving development 协议另完成分子、材料和 Suzuki 各一条。GLM 仍没有完整轨迹，因此不能报告跨模型效果。同开局 classical stress test 已经完成三条路线，说明分子和材料案例能超过 RGPE/ICM，但 Suzuki 的 multisource ICM-BMA 仍更强。下一步要在看结果前固定 baseline 选择规则，把在线 LLM、RGPE、multitask GP-ICM 和 target-only GP 放进同一个重复协议。最终还需要未参与调参的任务家族和至少一条真实 prospective/wet-lab campaign。</a:t>
+              <a:t>在新 LLM 调用前冻结 gate round、阈值网格、baseline 规则、主要指标和排除标准。随后并行重复在线 LLM、gated LLM、target GP、RGPE 与 multitask GP，并保留全部失败。还需要一个未参与开发的任务家族和至少一条真实 prospective/wet-lab campaign，才能把 retrospective evidence 推进成投稿主证据。</a:t>
             </a:r>
           </a:p>
           <a:p xmlns:a="http://schemas.openxmlformats.org/drawingml/2006/main">
@@ -1065,37 +1071,17 @@
           </a:p>
           <a:p xmlns:a="http://schemas.openxmlformats.org/drawingml/2006/main">
             <a:r>
-              <a:t>- /Users/rentamac/Documents/Codex/2026-05-12/app-llm-a5labs-tools/care2-opus/docs/NATURE_SUBMISSION_READINESS.md</a:t>
-            </a:r>
-          </a:p>
-          <a:p xmlns:a="http://schemas.openxmlformats.org/drawingml/2006/main">
-            <a:r>
-              <a:t>- /Users/rentamac/Documents/Codex/2026-05-12/app-llm-a5labs-tools/care2-opus/docs/GLM53_CROSS_MODEL_PROTOCOL.md</a:t>
-            </a:r>
-          </a:p>
-          <a:p xmlns:a="http://schemas.openxmlformats.org/drawingml/2006/main">
-            <a:r>
-              <a:t>- /Users/rentamac/Documents/Codex/2026-05-12/app-llm-a5labs-tools/care2-opus/experiments/care_replay/configs/online_llm_transport_context_robustness_v2.json</a:t>
-            </a:r>
-          </a:p>
-          <a:p xmlns:a="http://schemas.openxmlformats.org/drawingml/2006/main">
-            <a:r>
-              <a:t>- /Users/rentamac/Documents/Codex/2026-05-12/app-llm-a5labs-tools/care2-opus/experiments/care_replay/configs/online_llm_matched_classical_audit_v1.json</a:t>
-            </a:r>
-          </a:p>
-          <a:p xmlns:a="http://schemas.openxmlformats.org/drawingml/2006/main">
-            <a:r>
-              <a:t>- /Users/rentamac/Documents/Codex/2026-05-12/app-llm-a5labs-tools/care2-opus/experiments/care_replay/results/2026-08-24-online-llm-matched-classical-audit-v1/aggregate.json</a:t>
-            </a:r>
-          </a:p>
-          <a:p xmlns:a="http://schemas.openxmlformats.org/drawingml/2006/main">
-            <a:r>
-              <a:t>- https://www.nature.com/articles/s41524-025-01851-8</a:t>
-            </a:r>
-          </a:p>
-          <a:p xmlns:a="http://schemas.openxmlformats.org/drawingml/2006/main">
-            <a:r>
-              <a:t>- https://www.nature.com/articles/s41467-025-64105-7</a:t>
+              <a:t>- docs/NATURE_SUBMISSION_READINESS.md</a:t>
+            </a:r>
+          </a:p>
+          <a:p xmlns:a="http://schemas.openxmlformats.org/drawingml/2006/main">
+            <a:r>
+              <a:t>- experiments/care_replay/configs/online_llm_predeclared_baseline_portfolio_v1.json</a:t>
+            </a:r>
+          </a:p>
+          <a:p xmlns:a="http://schemas.openxmlformats.org/drawingml/2006/main">
+            <a:r>
+              <a:t>- experiments/care_replay/scripts/build_online_llm_calibration_gate_audit.py</a:t>
             </a:r>
           </a:p>
           <a:p xmlns:a="http://schemas.openxmlformats.org/drawingml/2006/main">
@@ -1106,6 +1092,121 @@
           <a:p xmlns:a="http://schemas.openxmlformats.org/drawingml/2006/main">
             <a:r>
               <a:t>- https://www.nature.com/nature/editorial-policies/ai</a:t>
+            </a:r>
+          </a:p>
+        </p:txBody>
+      </p:sp>
+      <p:sp>
+        <p:nvSpPr>
+          <p:cNvPr id="4" name="Slide Number Placeholder 3"/>
+          <p:cNvSpPr>
+            <a:spLocks xmlns:a="http://schemas.openxmlformats.org/drawingml/2006/main" noGrp="1"/>
+          </p:cNvSpPr>
+          <p:nvPr>
+            <p:ph type="sldNum" idx="5"/>
+          </p:nvPr>
+        </p:nvSpPr>
+        <p:spPr/>
+        <p:txBody>
+          <a:bodyPr xmlns:a="http://schemas.openxmlformats.org/drawingml/2006/main"/>
+          <a:lstStyle xmlns:a="http://schemas.openxmlformats.org/drawingml/2006/main"/>
+          <a:p xmlns:a="http://schemas.openxmlformats.org/drawingml/2006/main"/>
+        </p:txBody>
+      </p:sp>
+    </p:spTree>
+  </p:cSld>
+  <p:clrMapOvr>
+    <a:masterClrMapping xmlns:a="http://schemas.openxmlformats.org/drawingml/2006/main"/>
+  </p:clrMapOvr>
+</p:notes>
+</file>
+
+<file path=ppt/notesSlides/notesSlide15.xml><?xml version="1.0" encoding="utf-8"?>
+<p:notes xmlns:p="http://schemas.openxmlformats.org/presentationml/2006/main">
+  <p:cSld>
+    <p:spTree>
+      <p:nvGrpSpPr>
+        <p:cNvPr id="1" name=""/>
+        <p:cNvGrpSpPr/>
+        <p:nvPr/>
+      </p:nvGrpSpPr>
+      <p:grpSpPr>
+        <a:xfrm xmlns:a="http://schemas.openxmlformats.org/drawingml/2006/main"/>
+      </p:grpSpPr>
+      <p:sp>
+        <p:nvSpPr>
+          <p:cNvPr id="2" name="Slide Image Placeholder 1"/>
+          <p:cNvSpPr>
+            <a:spLocks xmlns:a="http://schemas.openxmlformats.org/drawingml/2006/main" noGrp="1"/>
+          </p:cNvSpPr>
+          <p:nvPr>
+            <p:ph type="sldImg" idx="0"/>
+          </p:nvPr>
+        </p:nvSpPr>
+        <p:spPr/>
+      </p:sp>
+      <p:sp>
+        <p:nvSpPr>
+          <p:cNvPr id="3" name="Notes Placeholder 2"/>
+          <p:cNvSpPr>
+            <a:spLocks xmlns:a="http://schemas.openxmlformats.org/drawingml/2006/main" noGrp="1"/>
+          </p:cNvSpPr>
+          <p:nvPr>
+            <p:ph type="body" idx="1"/>
+          </p:nvPr>
+        </p:nvSpPr>
+        <p:spPr/>
+        <p:txBody>
+          <a:bodyPr xmlns:a="http://schemas.openxmlformats.org/drawingml/2006/main"/>
+          <a:lstStyle xmlns:a="http://schemas.openxmlformats.org/drawingml/2006/main"/>
+          <a:p xmlns:a="http://schemas.openxmlformats.org/drawingml/2006/main">
+            <a:r>
+              <a:t>本页核心</a:t>
+            </a:r>
+          </a:p>
+          <a:p xmlns:a="http://schemas.openxmlformats.org/drawingml/2006/main">
+            <a:r>
+              <a:t>校准 Gate 用 LLM 自己的预测误差决定是否继续给它迁移权限。</a:t>
+            </a:r>
+          </a:p>
+          <a:p xmlns:a="http://schemas.openxmlformats.org/drawingml/2006/main">
+            <a:r>
+              <a:t/>
+            </a:r>
+          </a:p>
+          <a:p xmlns:a="http://schemas.openxmlformats.org/drawingml/2006/main">
+            <a:r>
+              <a:t>讲解</a:t>
+            </a:r>
+          </a:p>
+          <a:p xmlns:a="http://schemas.openxmlformats.org/drawingml/2006/main">
+            <a:r>
+              <a:t>Gate 固定在第三个 LLM 在线实验之后。它计算前三轮“明确给出 expected outcome”的平均绝对误差；如果误差超过阈值，或者 LLM 主动证伪、放弃迁移假设，系统就把已有观测交给 target-only GP 继续剩余预算，不重启、不拼接独立轨迹。每条 held-out 路线的阈值只用另外十条路线选择。回放中 Gate 在 8/11 路线触发，平均 AUC 增益由 +1.753 提到 +2.036，负向路线由 3 降到 2。它改善了风险控制，但相对原 LLM 的 +0.283 增量区间跨 0，仍未稳定超过最强经典 baseline。</a:t>
+            </a:r>
+          </a:p>
+          <a:p xmlns:a="http://schemas.openxmlformats.org/drawingml/2006/main">
+            <a:r>
+              <a:t/>
+            </a:r>
+          </a:p>
+          <a:p xmlns:a="http://schemas.openxmlformats.org/drawingml/2006/main">
+            <a:r>
+              <a:t>[Sources]</a:t>
+            </a:r>
+          </a:p>
+          <a:p xmlns:a="http://schemas.openxmlformats.org/drawingml/2006/main">
+            <a:r>
+              <a:t>- experiments/care_replay/scripts/build_online_llm_calibration_gate_audit.py</a:t>
+            </a:r>
+          </a:p>
+          <a:p xmlns:a="http://schemas.openxmlformats.org/drawingml/2006/main">
+            <a:r>
+              <a:t>- experiments/care_replay/results/2026-08-24-online-llm-calibration-gate-audit-v1/aggregate.json</a:t>
+            </a:r>
+          </a:p>
+          <a:p xmlns:a="http://schemas.openxmlformats.org/drawingml/2006/main">
+            <a:r>
+              <a:t>- experiments/care_replay/results/2026-08-24-online-llm-calibration-gate-audit-v1/route_results.csv</a:t>
             </a:r>
           </a:p>
         </p:txBody>
@@ -1180,7 +1281,7 @@
           </a:p>
           <a:p xmlns:a="http://schemas.openxmlformats.org/drawingml/2006/main">
             <a:r>
-              <a:t>最新证据包含 11 条真实数据 source-target 路线。平均 best-so-far AUC 增益为 +1.01，6 条胜、2 条平、3 条负。</a:t>
+              <a:t>冻结 11 路线中，在线 LLM 相对同开局 target-only GP 的平均 best-so-far AUC 增益为 +1.753，6 胜、2 平、3 负；完整 17 路线盘点后均值降为 +0.762。</a:t>
             </a:r>
           </a:p>
           <a:p xmlns:a="http://schemas.openxmlformats.org/drawingml/2006/main">
@@ -1195,7 +1296,7 @@
           </a:p>
           <a:p xmlns:a="http://schemas.openxmlformats.org/drawingml/2006/main">
             <a:r>
-              <a:t>这里的 +1.01 是与“同样初始观测、同样预算、只用 target 数据的 GP-UCB”相比的平均搜索效率变化。LLM 在每条路线的 10 个在线轮次都参与了最终候选选择。需要同时强调证据边界：route-level bootstrap 95% 区间为 [-0.44, +2.78]，跨过 0；每条路线目前只有一条在线 LLM trajectory，所以这是描述性信号，不是统计确认。</a:t>
+              <a:t>11 路线的 route-bootstrap 区间为 [+0.415,+3.315]，但符号检验 p=0.5078，而且每条路线只有一条在线轨迹。纳入仓库中 6 条更早的负向或持平路线后，17 路线区间为 [-0.501,+2.091]，再次跨过 0。因此我们把“冻结子集上的平均正向信号”和“所有历史路线尚未确认普遍提升”同时展示，避免路线选择偏差。</a:t>
             </a:r>
           </a:p>
           <a:p xmlns:a="http://schemas.openxmlformats.org/drawingml/2006/main">
@@ -1210,12 +1311,12 @@
           </a:p>
           <a:p xmlns:a="http://schemas.openxmlformats.org/drawingml/2006/main">
             <a:r>
-              <a:t>- /Users/rentamac/Documents/Codex/2026-05-12/app-llm-a5labs-tools/care2-opus/experiments/care_replay/results/2026-08-22-submission-evidence-audit/submission_evidence.json</a:t>
-            </a:r>
-          </a:p>
-          <a:p xmlns:a="http://schemas.openxmlformats.org/drawingml/2006/main">
-            <a:r>
-              <a:t>- /Users/rentamac/Documents/Codex/2026-05-12/app-llm-a5labs-tools/care2-opus/experiments/care_replay/results/2026-08-22-submission-evidence-audit/route_evidence.csv</a:t>
+              <a:t>- experiments/care_replay/results/2026-08-24-online-llm-predeclared-baseline-portfolio-v1/aggregate.json</a:t>
+            </a:r>
+          </a:p>
+          <a:p xmlns:a="http://schemas.openxmlformats.org/drawingml/2006/main">
+            <a:r>
+              <a:t>- experiments/care_replay/results/2026-08-24-online-llm-predeclared-baseline-portfolio-v2/aggregate.json</a:t>
             </a:r>
           </a:p>
         </p:txBody>
@@ -1320,12 +1421,12 @@
           </a:p>
           <a:p xmlns:a="http://schemas.openxmlformats.org/drawingml/2006/main">
             <a:r>
-              <a:t>- /Users/rentamac/Documents/Codex/2026-05-12/app-llm-a5labs-tools/care2-opus/experiments/care_replay/CARE2_METHOD.md</a:t>
-            </a:r>
-          </a:p>
-          <a:p xmlns:a="http://schemas.openxmlformats.org/drawingml/2006/main">
-            <a:r>
-              <a:t>- /Users/rentamac/Documents/Codex/2026-05-12/app-llm-a5labs-tools/care2-opus/experiments/care_replay/replay.py</a:t>
+              <a:t>- experiments/care_replay/CARE2_METHOD.md</a:t>
+            </a:r>
+          </a:p>
+          <a:p xmlns:a="http://schemas.openxmlformats.org/drawingml/2006/main">
+            <a:r>
+              <a:t>- experiments/care_replay/replay.py</a:t>
             </a:r>
           </a:p>
         </p:txBody>
@@ -1430,12 +1531,12 @@
           </a:p>
           <a:p xmlns:a="http://schemas.openxmlformats.org/drawingml/2006/main">
             <a:r>
-              <a:t>- /Users/rentamac/Documents/Codex/2026-05-12/app-llm-a5labs-tools/care2-opus/experiments/care_replay/scripts/run_online_llm_scientist.py</a:t>
-            </a:r>
-          </a:p>
-          <a:p xmlns:a="http://schemas.openxmlformats.org/drawingml/2006/main">
-            <a:r>
-              <a:t>- /Users/rentamac/Documents/Codex/2026-05-12/app-llm-a5labs-tools/care2-opus/experiments/care_replay/tests/test_online_llm_scientist.py</a:t>
+              <a:t>- experiments/care_replay/scripts/run_online_llm_scientist.py</a:t>
+            </a:r>
+          </a:p>
+          <a:p xmlns:a="http://schemas.openxmlformats.org/drawingml/2006/main">
+            <a:r>
+              <a:t>- experiments/care_replay/tests/test_online_llm_scientist.py</a:t>
             </a:r>
           </a:p>
         </p:txBody>
@@ -1540,12 +1641,12 @@
           </a:p>
           <a:p xmlns:a="http://schemas.openxmlformats.org/drawingml/2006/main">
             <a:r>
-              <a:t>- /Users/rentamac/Documents/Codex/2026-05-12/app-llm-a5labs-tools/care2-opus/experiments/care_replay/replay.py</a:t>
-            </a:r>
-          </a:p>
-          <a:p xmlns:a="http://schemas.openxmlformats.org/drawingml/2006/main">
-            <a:r>
-              <a:t>- /Users/rentamac/Documents/Codex/2026-05-12/app-llm-a5labs-tools/care2-opus/experiments/care_replay/scripts/run_online_llm_scientist.py</a:t>
+              <a:t>- experiments/care_replay/replay.py</a:t>
+            </a:r>
+          </a:p>
+          <a:p xmlns:a="http://schemas.openxmlformats.org/drawingml/2006/main">
+            <a:r>
+              <a:t>- experiments/care_replay/scripts/run_online_llm_scientist.py</a:t>
             </a:r>
           </a:p>
         </p:txBody>
@@ -1650,12 +1751,12 @@
           </a:p>
           <a:p xmlns:a="http://schemas.openxmlformats.org/drawingml/2006/main">
             <a:r>
-              <a:t>- /Users/rentamac/Documents/Codex/2026-05-12/app-llm-a5labs-tools/care2-opus/experiments/care_replay/replay.py</a:t>
-            </a:r>
-          </a:p>
-          <a:p xmlns:a="http://schemas.openxmlformats.org/drawingml/2006/main">
-            <a:r>
-              <a:t>- /Users/rentamac/Documents/Codex/2026-05-12/app-llm-a5labs-tools/care2-opus/experiments/care_replay/scripts/run_online_llm_scientist.py</a:t>
+              <a:t>- experiments/care_replay/replay.py</a:t>
+            </a:r>
+          </a:p>
+          <a:p xmlns:a="http://schemas.openxmlformats.org/drawingml/2006/main">
+            <a:r>
+              <a:t>- experiments/care_replay/scripts/run_online_llm_scientist.py</a:t>
             </a:r>
           </a:p>
         </p:txBody>
@@ -1730,7 +1831,7 @@
           </a:p>
           <a:p xmlns:a="http://schemas.openxmlformats.org/drawingml/2006/main">
             <a:r>
-              <a:t>主比较用同开局 target-only GP 隔离在线 LLM 增量，并用 RGPE 与 multitask GP 做同条件压力测试。</a:t>
+              <a:t>主比较用同开局 target-only GP 隔离在线 LLM 增量，并把 RGPE 与 multitask GP 扩展到冻结的全部 11 条路线。</a:t>
             </a:r>
           </a:p>
           <a:p xmlns:a="http://schemas.openxmlformats.org/drawingml/2006/main">
@@ -1745,7 +1846,7 @@
           </a:p>
           <a:p xmlns:a="http://schemas.openxmlformats.org/drawingml/2006/main">
             <a:r>
-              <a:t>在线 LLM Scientist 和所有 baseline 使用完全相同的三个初始 target 观测、候选空间和 10 轮预算。重放程序首先要求 target-only GP 精确复现在线 runner 保存的 AUC 和 final，确认开局与预算一致。FreeSolv→Lipophilicity 的在线 LLM 比三者中最强的 target GP 高 +6.325 AUC；phonons→bulk modulus 比最强的 RGPE 高 +1.922；Suzuki 则比 multisource ICM-BMA 低 1.960。三条路线相对事后最强 baseline 的等权平均为 +2.096，2/3 路线获胜。这里的“最强”是看完结果后的 oracle stress test，不是预先 calibration 的确认性比较。</a:t>
+              <a:t>所有方法使用完全相同的三个初始 target 观测、候选空间和 10 轮预算。固定 comparator 规则为：单 source 用 RGPE，多 source 用 multisource RGPE。在线 LLM 相对 target GP 平均 +1.753，相对固定 RGPE 平均 +3.229，但后者区间跨 0。若在每条路线看完结果后选最强 baseline，LLM 平均为 -0.550，只取得 3 胜、1 平、7 负。这个 oracle 诊断不是公平的预先选型主结果，但它清楚说明当前 LLM 还不是多数路线上的最强优化器。</a:t>
             </a:r>
           </a:p>
           <a:p xmlns:a="http://schemas.openxmlformats.org/drawingml/2006/main">
@@ -1760,27 +1861,17 @@
           </a:p>
           <a:p xmlns:a="http://schemas.openxmlformats.org/drawingml/2006/main">
             <a:r>
-              <a:t>- /Users/rentamac/Documents/Codex/2026-05-12/app-llm-a5labs-tools/care2-opus/experiments/care_replay/configs/online_llm_matched_classical_audit_v1.json</a:t>
-            </a:r>
-          </a:p>
-          <a:p xmlns:a="http://schemas.openxmlformats.org/drawingml/2006/main">
-            <a:r>
-              <a:t>- /Users/rentamac/Documents/Codex/2026-05-12/app-llm-a5labs-tools/care2-opus/experiments/care_replay/results/2026-08-24-online-llm-matched-classical-audit-v1/aggregate.json</a:t>
-            </a:r>
-          </a:p>
-          <a:p xmlns:a="http://schemas.openxmlformats.org/drawingml/2006/main">
-            <a:r>
-              <a:t>- /Users/rentamac/Documents/Codex/2026-05-12/app-llm-a5labs-tools/care2-opus/experiments/care_replay/results/2026-08-24-online-llm-matched-classical-audit-v1/comparisons.csv</a:t>
-            </a:r>
-          </a:p>
-          <a:p xmlns:a="http://schemas.openxmlformats.org/drawingml/2006/main">
-            <a:r>
-              <a:t>- /Users/rentamac/Documents/Codex/2026-05-12/app-llm-a5labs-tools/care2-opus/experiments/care_replay/configs/classical_transfer_benchmark_v1.json</a:t>
-            </a:r>
-          </a:p>
-          <a:p xmlns:a="http://schemas.openxmlformats.org/drawingml/2006/main">
-            <a:r>
-              <a:t>- https://www.nature.com/articles/s41524-025-01851-8</a:t>
+              <a:t>- experiments/care_replay/configs/online_llm_predeclared_baseline_portfolio_v1.json</a:t>
+            </a:r>
+          </a:p>
+          <a:p xmlns:a="http://schemas.openxmlformats.org/drawingml/2006/main">
+            <a:r>
+              <a:t>- experiments/care_replay/results/2026-08-24-online-llm-predeclared-baseline-portfolio-v1/aggregate.json</a:t>
+            </a:r>
+          </a:p>
+          <a:p xmlns:a="http://schemas.openxmlformats.org/drawingml/2006/main">
+            <a:r>
+              <a:t>- experiments/care_replay/results/2026-08-24-online-llm-predeclared-baseline-portfolio-v1/route_comparisons.csv</a:t>
             </a:r>
           </a:p>
         </p:txBody>
@@ -1885,12 +1976,12 @@
           </a:p>
           <a:p xmlns:a="http://schemas.openxmlformats.org/drawingml/2006/main">
             <a:r>
-              <a:t>- /Users/rentamac/Documents/Codex/2026-05-12/app-llm-a5labs-tools/care2-opus/experiments/care_replay/scripts/run_online_llm_scientist.py</a:t>
-            </a:r>
-          </a:p>
-          <a:p xmlns:a="http://schemas.openxmlformats.org/drawingml/2006/main">
-            <a:r>
-              <a:t>- /Users/rentamac/Documents/Codex/2026-05-12/app-llm-a5labs-tools/care2-opus/experiments/care_replay/results/2026-08-16-opus48-bounded-ei-development-v2/molecular_freesolv_to_lipophilicity/llm_trace.jsonl</a:t>
+              <a:t>- experiments/care_replay/scripts/run_online_llm_scientist.py</a:t>
+            </a:r>
+          </a:p>
+          <a:p xmlns:a="http://schemas.openxmlformats.org/drawingml/2006/main">
+            <a:r>
+              <a:t>- experiments/care_replay/results/2026-08-16-opus48-bounded-ei-development-v2/molecular_freesolv_to_lipophilicity/llm_trace.jsonl</a:t>
             </a:r>
           </a:p>
         </p:txBody>
@@ -1995,12 +2086,12 @@
           </a:p>
           <a:p xmlns:a="http://schemas.openxmlformats.org/drawingml/2006/main">
             <a:r>
-              <a:t>- /Users/rentamac/Documents/Codex/2026-05-12/app-llm-a5labs-tools/care2-opus/experiments/care_replay/results/2026-08-16-opus48-bounded-ei-development-v2/molecular_freesolv_to_lipophilicity/llm_trace.jsonl</a:t>
-            </a:r>
-          </a:p>
-          <a:p xmlns:a="http://schemas.openxmlformats.org/drawingml/2006/main">
-            <a:r>
-              <a:t>- /Users/rentamac/Documents/Codex/2026-05-12/app-llm-a5labs-tools/care2-opus/experiments/care_replay/results/2026-08-16-opus48-bounded-ei-development-v2/molecular_freesolv_to_lipophilicity/summary.json</a:t>
+              <a:t>- experiments/care_replay/results/2026-08-16-opus48-bounded-ei-development-v2/molecular_freesolv_to_lipophilicity/llm_trace.jsonl</a:t>
+            </a:r>
+          </a:p>
+          <a:p xmlns:a="http://schemas.openxmlformats.org/drawingml/2006/main">
+            <a:r>
+              <a:t>- experiments/care_replay/results/2026-08-16-opus48-bounded-ei-development-v2/molecular_freesolv_to_lipophilicity/summary.json</a:t>
             </a:r>
           </a:p>
         </p:txBody>
@@ -2068,7 +2159,7 @@
   </p:cSld>
   <p:clrMap bg1="lt1" tx1="dk1" bg2="lt2" tx2="dk2" accent1="accent1" accent2="accent2" accent3="accent3" accent4="accent4" accent5="accent5" accent6="accent6" hlink="hlink" folHlink="folHlink"/>
   <p:sldLayoutIdLst>
-    <p:sldLayoutId xmlns:r="http://schemas.openxmlformats.org/officeDocument/2006/relationships" id="2147483649" r:id="Rc076f4bc98944c6d"/>
+    <p:sldLayoutId xmlns:r="http://schemas.openxmlformats.org/officeDocument/2006/relationships" id="2147483649" r:id="R747945f61a6243bf"/>
   </p:sldLayoutIdLst>
   <p:txStyles>
     <p:titleStyle>
@@ -3595,7 +3686,7 @@
                 <a:ea typeface="Arial Unicode MS"/>
                 <a:cs typeface="Arial Unicode MS"/>
               </a:rPr>
-              <a:t>6 条正向、2 条持平、3 条负向，迁移效果明显异质</a:t>
+              <a:t>同开局下：相对 target GP 为 6 胜 2 平 3 负；固定 RGPE 为 6 胜 1 平 4 负</a:t>
             </a:r>
           </a:p>
         </p:txBody>
@@ -3640,7 +3731,7 @@
           <p:nvPr/>
         </p:nvPicPr>
         <p:blipFill>
-          <a:blip xmlns:r="http://schemas.openxmlformats.org/officeDocument/2006/relationships" xmlns:a="http://schemas.openxmlformats.org/drawingml/2006/main" r:embed="R70bda5fc7ead4032"/>
+          <a:blip xmlns:r="http://schemas.openxmlformats.org/officeDocument/2006/relationships" xmlns:a="http://schemas.openxmlformats.org/drawingml/2006/main" r:embed="R12ed1cd0bb4540c2"/>
           <a:stretch xmlns:a="http://schemas.openxmlformats.org/drawingml/2006/main"/>
         </p:blipFill>
         <p:spPr>
@@ -3724,8 +3815,8 @@
           <p:nvPr/>
         </p:nvPicPr>
         <p:blipFill>
-          <a:blip xmlns:r="http://schemas.openxmlformats.org/officeDocument/2006/relationships" xmlns:a="http://schemas.openxmlformats.org/drawingml/2006/main" r:embed="R47dcf87f9b094a72"/>
-          <a:srcRect xmlns:a="http://schemas.openxmlformats.org/drawingml/2006/main" l="0" t="0" r="0" b="43396"/>
+          <a:blip xmlns:r="http://schemas.openxmlformats.org/officeDocument/2006/relationships" xmlns:a="http://schemas.openxmlformats.org/drawingml/2006/main" r:embed="R80542cd8f3164480"/>
+          <a:srcRect xmlns:a="http://schemas.openxmlformats.org/drawingml/2006/main" l="0" t="0" r="0" b="0"/>
           <a:stretch xmlns:a="http://schemas.openxmlformats.org/drawingml/2006/main"/>
         </p:blipFill>
         <p:spPr>
@@ -3993,7 +4084,7 @@
           <p:nvPr/>
         </p:nvPicPr>
         <p:blipFill>
-          <a:blip xmlns:r="http://schemas.openxmlformats.org/officeDocument/2006/relationships" xmlns:a="http://schemas.openxmlformats.org/drawingml/2006/main" r:embed="Re94e502aaaf24c3a"/>
+          <a:blip xmlns:r="http://schemas.openxmlformats.org/officeDocument/2006/relationships" xmlns:a="http://schemas.openxmlformats.org/drawingml/2006/main" r:embed="R581aa4a4d0954d1d"/>
           <a:stretch xmlns:a="http://schemas.openxmlformats.org/drawingml/2006/main"/>
         </p:blipFill>
         <p:spPr>
@@ -4077,7 +4168,7 @@
           <p:nvPr/>
         </p:nvPicPr>
         <p:blipFill>
-          <a:blip xmlns:r="http://schemas.openxmlformats.org/officeDocument/2006/relationships" xmlns:a="http://schemas.openxmlformats.org/drawingml/2006/main" r:embed="Race971ece4344f7b"/>
+          <a:blip xmlns:r="http://schemas.openxmlformats.org/officeDocument/2006/relationships" xmlns:a="http://schemas.openxmlformats.org/drawingml/2006/main" r:embed="R82a7b497d9824a34"/>
           <a:srcRect xmlns:a="http://schemas.openxmlformats.org/drawingml/2006/main" l="0" t="0" r="0" b="0"/>
           <a:stretch xmlns:a="http://schemas.openxmlformats.org/drawingml/2006/main"/>
         </p:blipFill>
@@ -4346,7 +4437,7 @@
           <p:nvPr/>
         </p:nvPicPr>
         <p:blipFill>
-          <a:blip xmlns:r="http://schemas.openxmlformats.org/officeDocument/2006/relationships" xmlns:a="http://schemas.openxmlformats.org/drawingml/2006/main" r:embed="Rcd633a3dcea948e5"/>
+          <a:blip xmlns:r="http://schemas.openxmlformats.org/officeDocument/2006/relationships" xmlns:a="http://schemas.openxmlformats.org/drawingml/2006/main" r:embed="R4f7a9b8b141548ad"/>
           <a:stretch xmlns:a="http://schemas.openxmlformats.org/drawingml/2006/main"/>
         </p:blipFill>
         <p:spPr>
@@ -4430,7 +4521,7 @@
           <p:nvPr/>
         </p:nvPicPr>
         <p:blipFill>
-          <a:blip xmlns:r="http://schemas.openxmlformats.org/officeDocument/2006/relationships" xmlns:a="http://schemas.openxmlformats.org/drawingml/2006/main" r:embed="Rb184f924b9ef40c2"/>
+          <a:blip xmlns:r="http://schemas.openxmlformats.org/officeDocument/2006/relationships" xmlns:a="http://schemas.openxmlformats.org/drawingml/2006/main" r:embed="R6d4f73fe570f4b0c"/>
           <a:srcRect xmlns:a="http://schemas.openxmlformats.org/drawingml/2006/main" l="0" t="12000" r="0" b="0"/>
           <a:stretch xmlns:a="http://schemas.openxmlformats.org/drawingml/2006/main"/>
         </p:blipFill>
@@ -4867,7 +4958,7 @@
                 <a:ea typeface="Arial Unicode MS"/>
                 <a:cs typeface="Arial Unicode MS"/>
               </a:rPr>
-              <a:t>• 覆盖化学、分子和材料任务</a:t>
+              <a:t>• 11 路线均值 +1.75；Gate 后 +2.04</a:t>
             </a:r>
           </a:p>
           <a:p xmlns:a="http://schemas.openxmlformats.org/drawingml/2006/main">
@@ -4894,7 +4985,7 @@
                 <a:ea typeface="Arial Unicode MS"/>
                 <a:cs typeface="Arial Unicode MS"/>
               </a:rPr>
-              <a:t>• 三条 context-robust 轨迹均正向</a:t>
+              <a:t>• 17 路线完整盘点均值 +0.76</a:t>
             </a:r>
           </a:p>
           <a:p xmlns:a="http://schemas.openxmlformats.org/drawingml/2006/main">
@@ -5486,7 +5577,7 @@
                 <a:ea typeface="Arial Unicode MS"/>
                 <a:cs typeface="Arial Unicode MS"/>
               </a:rPr>
-              <a:t>一句话：LLM 已能在三类真实 replay 中改变搜索并识别不可靠迁移；</a:t>
+              <a:t>一句话：LLM 在冻结子集上有平均正向信号，校准可降低负迁移风险；</a:t>
             </a:r>
           </a:p>
           <a:p xmlns:a="http://schemas.openxmlformats.org/drawingml/2006/main">
@@ -5513,7 +5604,7 @@
                 <a:ea typeface="Arial Unicode MS"/>
                 <a:cs typeface="Arial Unicode MS"/>
               </a:rPr>
-              <a:t>是否稳定泛化，仍必须靠冻结重复、强 baseline 和前瞻实验回答。</a:t>
+              <a:t>完整历史盘点和强 baseline 仍不支持“普遍优于现有方法”。</a:t>
             </a:r>
           </a:p>
         </p:txBody>
@@ -5945,7 +6036,7 @@
                 <a:ea typeface="Arial Unicode MS"/>
                 <a:cs typeface="Arial Unicode MS"/>
               </a:rPr>
-              <a:t>重复在线轨迹</a:t>
+              <a:t>前瞻确认 Gate</a:t>
             </a:r>
           </a:p>
         </p:txBody>
@@ -6007,7 +6098,7 @@
                 <a:ea typeface="Arial Unicode MS"/>
                 <a:cs typeface="Arial Unicode MS"/>
               </a:rPr>
-              <a:t>Opus 冻结 v1 为 11/330；另有 3 条 context-robust 轨迹；GLM 暂无完整轨迹。</a:t>
+              <a:t>在新调用前冻结 gate round、阈值网格、baseline 规则和主要指标。</a:t>
             </a:r>
           </a:p>
         </p:txBody>
@@ -6162,7 +6253,7 @@
                 <a:ea typeface="Arial Unicode MS"/>
                 <a:cs typeface="Arial Unicode MS"/>
               </a:rPr>
-              <a:t>强 transfer baseline</a:t>
+              <a:t>重复强 baseline</a:t>
             </a:r>
           </a:p>
         </p:txBody>
@@ -6224,7 +6315,7 @@
                 <a:ea typeface="Arial Unicode MS"/>
                 <a:cs typeface="Arial Unicode MS"/>
               </a:rPr>
-              <a:t>同开局审计已完成 3 条；下一步预先选型，并扩大到冻结重复协议。</a:t>
+              <a:t>并行重复 LLM、gated LLM、target GP、RGPE 与 multitask GP。</a:t>
             </a:r>
           </a:p>
         </p:txBody>
@@ -6977,6 +7068,359 @@
     <p:extLst>
       <p:ext uri="{BB962C8B-B14F-4D97-AF65-F5344CB8AC3E}">
         <p14:creationId xmlns:p14="http://schemas.microsoft.com/office/powerpoint/2010/main" val="2028502474"/>
+      </p:ext>
+    </p:extLst>
+  </p:cSld>
+</p:sld>
+</file>
+
+<file path=ppt/slides/slide15.xml><?xml version="1.0" encoding="utf-8"?>
+<p:sld xmlns:p="http://schemas.openxmlformats.org/presentationml/2006/main">
+  <p:cSld>
+    <p:bg>
+      <p:bgPr>
+        <a:solidFill xmlns:a="http://schemas.openxmlformats.org/drawingml/2006/main">
+          <a:srgbClr val="FFFFFF"/>
+        </a:solidFill>
+      </p:bgPr>
+    </p:bg>
+    <p:spTree>
+      <p:nvGrpSpPr>
+        <p:cNvPr id="1" name=""/>
+        <p:cNvGrpSpPr/>
+        <p:nvPr/>
+      </p:nvGrpSpPr>
+      <p:grpSpPr>
+        <a:xfrm xmlns:a="http://schemas.openxmlformats.org/drawingml/2006/main"/>
+      </p:grpSpPr>
+      <p:sp>
+        <p:nvSpPr>
+          <p:cNvPr id="7" name="">
+            <a:extLst xmlns:a="http://schemas.openxmlformats.org/drawingml/2006/main">
+              <a:ext uri="{FF2B5EF4-FFF2-40B4-BE49-F238E27FC236}">
+                <a16:creationId xmlns:a16="http://schemas.microsoft.com/office/drawing/2014/main" id="{6C311705-E0EB-402F-B1A7-C288385A231C}"/>
+              </a:ext>
+            </a:extLst>
+          </p:cNvPr>
+          <p:cNvSpPr>
+            <a:spLocks xmlns:a="http://schemas.openxmlformats.org/drawingml/2006/main" noGrp="1"/>
+          </p:cNvSpPr>
+          <p:nvPr/>
+        </p:nvSpPr>
+        <p:spPr>
+          <a:xfrm xmlns:a="http://schemas.openxmlformats.org/drawingml/2006/main">
+            <a:off x="647700" y="266700"/>
+            <a:ext cx="4191000" cy="190500"/>
+          </a:xfrm>
+          <a:prstGeom xmlns:a="http://schemas.openxmlformats.org/drawingml/2006/main" prst="rect">
+            <a:avLst/>
+          </a:prstGeom>
+          <a:noFill xmlns:a="http://schemas.openxmlformats.org/drawingml/2006/main"/>
+          <a:ln xmlns:a="http://schemas.openxmlformats.org/drawingml/2006/main" w="0">
+            <a:noFill/>
+            <a:prstDash val="solid"/>
+          </a:ln>
+        </p:spPr>
+        <p:txBody>
+          <a:bodyPr xmlns:a="http://schemas.openxmlformats.org/drawingml/2006/main" wrap="square" lIns="0" tIns="0" rIns="0" bIns="0" anchor="t">
+            <a:normAutofit fontScale="100000"/>
+          </a:bodyPr>
+          <a:lstStyle xmlns:a="http://schemas.openxmlformats.org/drawingml/2006/main"/>
+          <a:p xmlns:a="http://schemas.openxmlformats.org/drawingml/2006/main">
+            <a:pPr algn="l">
+              <a:lnSpc>
+                <a:spcPct val="106000"/>
+              </a:lnSpc>
+              <a:buNone/>
+              <a:defRPr sz="975" b="1">
+                <a:solidFill>
+                  <a:srgbClr val="2F6FB6"/>
+                </a:solidFill>
+                <a:latin typeface="Arial Unicode MS"/>
+                <a:ea typeface="Arial Unicode MS"/>
+                <a:cs typeface="Arial Unicode MS"/>
+              </a:defRPr>
+            </a:pPr>
+            <a:r>
+              <a:rPr sz="975" b="1">
+                <a:solidFill>
+                  <a:srgbClr val="2F6FB6"/>
+                </a:solidFill>
+                <a:latin typeface="Arial Unicode MS"/>
+                <a:ea typeface="Arial Unicode MS"/>
+                <a:cs typeface="Arial Unicode MS"/>
+              </a:rPr>
+              <a:t>校准 Gate</a:t>
+            </a:r>
+          </a:p>
+        </p:txBody>
+      </p:sp>
+      <p:sp>
+        <p:nvSpPr>
+          <p:cNvPr id="2" name="">
+            <a:extLst xmlns:a="http://schemas.openxmlformats.org/drawingml/2006/main">
+              <a:ext uri="{FF2B5EF4-FFF2-40B4-BE49-F238E27FC236}">
+                <a16:creationId xmlns:a16="http://schemas.microsoft.com/office/drawing/2014/main" id="{1543A56E-44FC-448E-B95A-42B22110256A}"/>
+              </a:ext>
+            </a:extLst>
+          </p:cNvPr>
+          <p:cNvSpPr>
+            <a:spLocks xmlns:a="http://schemas.openxmlformats.org/drawingml/2006/main" noGrp="1"/>
+          </p:cNvSpPr>
+          <p:nvPr/>
+        </p:nvSpPr>
+        <p:spPr>
+          <a:xfrm xmlns:a="http://schemas.openxmlformats.org/drawingml/2006/main">
+            <a:off x="11258550" y="266700"/>
+            <a:ext cx="285750" cy="171450"/>
+          </a:xfrm>
+          <a:prstGeom xmlns:a="http://schemas.openxmlformats.org/drawingml/2006/main" prst="rect">
+            <a:avLst/>
+          </a:prstGeom>
+          <a:noFill xmlns:a="http://schemas.openxmlformats.org/drawingml/2006/main"/>
+          <a:ln xmlns:a="http://schemas.openxmlformats.org/drawingml/2006/main" w="0">
+            <a:noFill/>
+            <a:prstDash val="solid"/>
+          </a:ln>
+        </p:spPr>
+        <p:txBody>
+          <a:bodyPr xmlns:a="http://schemas.openxmlformats.org/drawingml/2006/main" wrap="square" lIns="0" tIns="0" rIns="0" bIns="0" anchor="t">
+            <a:normAutofit fontScale="100000"/>
+          </a:bodyPr>
+          <a:lstStyle xmlns:a="http://schemas.openxmlformats.org/drawingml/2006/main"/>
+          <a:p xmlns:a="http://schemas.openxmlformats.org/drawingml/2006/main">
+            <a:pPr algn="r">
+              <a:lnSpc>
+                <a:spcPct val="106000"/>
+              </a:lnSpc>
+              <a:buNone/>
+              <a:defRPr sz="900" b="0">
+                <a:solidFill>
+                  <a:srgbClr val="687681"/>
+                </a:solidFill>
+                <a:latin typeface="Arial Unicode MS"/>
+                <a:ea typeface="Arial Unicode MS"/>
+                <a:cs typeface="Arial Unicode MS"/>
+              </a:defRPr>
+            </a:pPr>
+            <a:r>
+              <a:rPr sz="900" b="0">
+                <a:solidFill>
+                  <a:srgbClr val="687681"/>
+                </a:solidFill>
+                <a:latin typeface="Arial Unicode MS"/>
+                <a:ea typeface="Arial Unicode MS"/>
+                <a:cs typeface="Arial Unicode MS"/>
+              </a:rPr>
+              <a:t>15</a:t>
+            </a:r>
+          </a:p>
+        </p:txBody>
+      </p:sp>
+      <p:sp>
+        <p:nvSpPr>
+          <p:cNvPr id="3" name="">
+            <a:extLst xmlns:a="http://schemas.openxmlformats.org/drawingml/2006/main">
+              <a:ext uri="{FF2B5EF4-FFF2-40B4-BE49-F238E27FC236}">
+                <a16:creationId xmlns:a16="http://schemas.microsoft.com/office/drawing/2014/main" id="{91589F62-8A06-48D2-A906-6E23C1D2A667}"/>
+              </a:ext>
+            </a:extLst>
+          </p:cNvPr>
+          <p:cNvSpPr>
+            <a:spLocks xmlns:a="http://schemas.openxmlformats.org/drawingml/2006/main" noGrp="1"/>
+          </p:cNvSpPr>
+          <p:nvPr/>
+        </p:nvSpPr>
+        <p:spPr>
+          <a:xfrm xmlns:a="http://schemas.openxmlformats.org/drawingml/2006/main">
+            <a:off x="647700" y="552450"/>
+            <a:ext cx="10896600" cy="552450"/>
+          </a:xfrm>
+          <a:prstGeom xmlns:a="http://schemas.openxmlformats.org/drawingml/2006/main" prst="rect">
+            <a:avLst/>
+          </a:prstGeom>
+          <a:noFill xmlns:a="http://schemas.openxmlformats.org/drawingml/2006/main"/>
+          <a:ln xmlns:a="http://schemas.openxmlformats.org/drawingml/2006/main" w="0">
+            <a:noFill/>
+            <a:prstDash val="solid"/>
+          </a:ln>
+        </p:spPr>
+        <p:txBody>
+          <a:bodyPr xmlns:a="http://schemas.openxmlformats.org/drawingml/2006/main" wrap="square" lIns="0" tIns="0" rIns="0" bIns="0" anchor="t">
+            <a:normAutofit fontScale="100000"/>
+          </a:bodyPr>
+          <a:lstStyle xmlns:a="http://schemas.openxmlformats.org/drawingml/2006/main"/>
+          <a:p xmlns:a="http://schemas.openxmlformats.org/drawingml/2006/main">
+            <a:pPr algn="l">
+              <a:lnSpc>
+                <a:spcPct val="96000"/>
+              </a:lnSpc>
+              <a:buNone/>
+              <a:defRPr sz="2475" b="1">
+                <a:solidFill>
+                  <a:srgbClr val="17232E"/>
+                </a:solidFill>
+                <a:latin typeface="Arial Unicode MS"/>
+                <a:ea typeface="Arial Unicode MS"/>
+                <a:cs typeface="Arial Unicode MS"/>
+              </a:defRPr>
+            </a:pPr>
+            <a:r>
+              <a:rPr sz="2475" b="1">
+                <a:solidFill>
+                  <a:srgbClr val="17232E"/>
+                </a:solidFill>
+                <a:latin typeface="Arial Unicode MS"/>
+                <a:ea typeface="Arial Unicode MS"/>
+                <a:cs typeface="Arial Unicode MS"/>
+              </a:rPr>
+              <a:t>第三轮检查预测误差：平均增益 +1.75 → +2.04，负向路线 3 → 2</a:t>
+            </a:r>
+          </a:p>
+        </p:txBody>
+      </p:sp>
+      <p:sp>
+        <p:nvSpPr>
+          <p:cNvPr id="4" name="">
+            <a:extLst xmlns:a="http://schemas.openxmlformats.org/drawingml/2006/main">
+              <a:ext uri="{FF2B5EF4-FFF2-40B4-BE49-F238E27FC236}">
+                <a16:creationId xmlns:a16="http://schemas.microsoft.com/office/drawing/2014/main" id="{77ECEF1D-351C-443E-8CF8-6F33B746330A}"/>
+              </a:ext>
+            </a:extLst>
+          </p:cNvPr>
+          <p:cNvSpPr>
+            <a:spLocks xmlns:a="http://schemas.openxmlformats.org/drawingml/2006/main" noGrp="1"/>
+          </p:cNvSpPr>
+          <p:nvPr/>
+        </p:nvSpPr>
+        <p:spPr>
+          <a:xfrm xmlns:a="http://schemas.openxmlformats.org/drawingml/2006/main">
+            <a:off x="647700" y="1200150"/>
+            <a:ext cx="400050" cy="28575"/>
+          </a:xfrm>
+          <a:prstGeom xmlns:a="http://schemas.openxmlformats.org/drawingml/2006/main" prst="rect">
+            <a:avLst/>
+          </a:prstGeom>
+          <a:solidFill xmlns:a="http://schemas.openxmlformats.org/drawingml/2006/main">
+            <a:srgbClr val="17232E"/>
+          </a:solidFill>
+          <a:ln xmlns:a="http://schemas.openxmlformats.org/drawingml/2006/main" w="0">
+            <a:noFill/>
+            <a:prstDash val="solid"/>
+          </a:ln>
+        </p:spPr>
+      </p:sp>
+      <p:pic>
+        <p:nvPicPr>
+          <p:cNvPr id="14" name=""/>
+          <p:cNvPicPr>
+            <a:picLocks xmlns:a="http://schemas.openxmlformats.org/drawingml/2006/main" noChangeAspect="1"/>
+          </p:cNvPicPr>
+          <p:nvPr/>
+        </p:nvPicPr>
+        <p:blipFill>
+          <a:blip xmlns:r="http://schemas.openxmlformats.org/officeDocument/2006/relationships" xmlns:a="http://schemas.openxmlformats.org/drawingml/2006/main" r:embed="R63f1ed912341426f"/>
+          <a:stretch xmlns:a="http://schemas.openxmlformats.org/drawingml/2006/main"/>
+        </p:blipFill>
+        <p:spPr>
+          <a:xfrm xmlns:a="http://schemas.openxmlformats.org/drawingml/2006/main">
+            <a:off x="1462686" y="1257300"/>
+            <a:ext cx="9266627" cy="5105400"/>
+          </a:xfrm>
+          <a:prstGeom xmlns:a="http://schemas.openxmlformats.org/drawingml/2006/main" prst="rect">
+            <a:avLst/>
+          </a:prstGeom>
+        </p:spPr>
+      </p:pic>
+      <p:sp>
+        <p:nvSpPr>
+          <p:cNvPr id="6" name="">
+            <a:extLst xmlns:a="http://schemas.openxmlformats.org/drawingml/2006/main">
+              <a:ext uri="{FF2B5EF4-FFF2-40B4-BE49-F238E27FC236}">
+                <a16:creationId xmlns:a16="http://schemas.microsoft.com/office/drawing/2014/main" id="{D1B4F285-B5EF-4E37-9F30-02CAC87F6E8F}"/>
+              </a:ext>
+            </a:extLst>
+          </p:cNvPr>
+          <p:cNvSpPr>
+            <a:spLocks xmlns:a="http://schemas.openxmlformats.org/drawingml/2006/main" noGrp="1"/>
+          </p:cNvSpPr>
+          <p:nvPr/>
+        </p:nvSpPr>
+        <p:spPr>
+          <a:xfrm xmlns:a="http://schemas.openxmlformats.org/drawingml/2006/main">
+            <a:off x="647700" y="6600825"/>
+            <a:ext cx="10896600" cy="133350"/>
+          </a:xfrm>
+          <a:prstGeom xmlns:a="http://schemas.openxmlformats.org/drawingml/2006/main" prst="rect">
+            <a:avLst/>
+          </a:prstGeom>
+          <a:noFill xmlns:a="http://schemas.openxmlformats.org/drawingml/2006/main"/>
+          <a:ln xmlns:a="http://schemas.openxmlformats.org/drawingml/2006/main" w="0">
+            <a:noFill/>
+            <a:prstDash val="solid"/>
+          </a:ln>
+        </p:spPr>
+        <p:txBody>
+          <a:bodyPr xmlns:a="http://schemas.openxmlformats.org/drawingml/2006/main" wrap="square" lIns="0" tIns="0" rIns="0" bIns="0" anchor="t">
+            <a:normAutofit fontScale="100000"/>
+          </a:bodyPr>
+          <a:lstStyle xmlns:a="http://schemas.openxmlformats.org/drawingml/2006/main"/>
+          <a:p xmlns:a="http://schemas.openxmlformats.org/drawingml/2006/main">
+            <a:pPr algn="r">
+              <a:lnSpc>
+                <a:spcPct val="106000"/>
+              </a:lnSpc>
+              <a:buNone/>
+              <a:defRPr sz="750" b="0">
+                <a:solidFill>
+                  <a:srgbClr val="8B959D"/>
+                </a:solidFill>
+                <a:latin typeface="Arial Unicode MS"/>
+                <a:ea typeface="Arial Unicode MS"/>
+                <a:cs typeface="Arial Unicode MS"/>
+              </a:defRPr>
+            </a:pPr>
+            <a:r>
+              <a:rPr sz="750" b="0">
+                <a:solidFill>
+                  <a:srgbClr val="8B959D"/>
+                </a:solidFill>
+                <a:latin typeface="Arial Unicode MS"/>
+                <a:ea typeface="Arial Unicode MS"/>
+                <a:cs typeface="Arial Unicode MS"/>
+              </a:rPr>
+              <a:t>CARE 2.0 · online LLM evidence update · 2026-08-24</a:t>
+            </a:r>
+          </a:p>
+        </p:txBody>
+      </p:sp>
+      <p:pic>
+        <p:nvPicPr>
+          <p:cNvPr id="16" name=""/>
+          <p:cNvPicPr>
+            <a:picLocks xmlns:a="http://schemas.openxmlformats.org/drawingml/2006/main" noChangeAspect="1"/>
+          </p:cNvPicPr>
+          <p:nvPr/>
+        </p:nvPicPr>
+        <p:blipFill>
+          <a:blip xmlns:r="http://schemas.openxmlformats.org/officeDocument/2006/relationships" xmlns:a="http://schemas.openxmlformats.org/drawingml/2006/main" r:embed="R607c24d505714d42"/>
+          <a:srcRect xmlns:a="http://schemas.openxmlformats.org/drawingml/2006/main" l="0" t="0" r="0" b="0"/>
+          <a:stretch xmlns:a="http://schemas.openxmlformats.org/drawingml/2006/main"/>
+        </p:blipFill>
+        <p:spPr>
+          <a:xfrm xmlns:a="http://schemas.openxmlformats.org/drawingml/2006/main" flipH="0" flipV="0">
+            <a:off x="1462686" y="1257300"/>
+            <a:ext cx="9266627" cy="5105400"/>
+          </a:xfrm>
+          <a:prstGeom xmlns:a="http://schemas.openxmlformats.org/drawingml/2006/main" prst="rect">
+            <a:avLst/>
+          </a:prstGeom>
+        </p:spPr>
+      </p:pic>
+    </p:spTree>
+    <p:extLst>
+      <p:ext uri="{BB962C8B-B14F-4D97-AF65-F5344CB8AC3E}">
+        <p14:creationId xmlns:p14="http://schemas.microsoft.com/office/powerpoint/2010/main" val="248175514"/>
       </p:ext>
     </p:extLst>
   </p:cSld>
@@ -7183,7 +7627,7 @@
                 <a:ea typeface="Arial Unicode MS"/>
                 <a:cs typeface="Arial Unicode MS"/>
               </a:rPr>
-              <a:t>LLM 全程参与 11 条真实路线，跨模型独立重复已经启动</a:t>
+              <a:t>冻结 11 路线有平均正向信号；完整 17 路线仍未确认普遍提升</a:t>
             </a:r>
           </a:p>
         </p:txBody>
@@ -7276,7 +7720,7 @@
                 <a:ea typeface="Arial Unicode MS"/>
                 <a:cs typeface="Arial Unicode MS"/>
               </a:rPr>
-              <a:t>+1.01</a:t>
+              <a:t>+1.75</a:t>
             </a:r>
           </a:p>
         </p:txBody>
@@ -7896,7 +8340,7 @@
                 <a:ea typeface="Arial Unicode MS"/>
                 <a:cs typeface="Arial Unicode MS"/>
               </a:rPr>
-              <a:t>[-0.44, +2.78]</a:t>
+              <a:t>[+0.41, +3.31]</a:t>
             </a:r>
           </a:p>
         </p:txBody>
@@ -7958,7 +8402,7 @@
                 <a:ea typeface="Arial Unicode MS"/>
                 <a:cs typeface="Arial Unicode MS"/>
               </a:rPr>
-              <a:t>区间仍跨过 0</a:t>
+              <a:t>符号检验不显著</a:t>
             </a:r>
           </a:p>
         </p:txBody>
@@ -8113,7 +8557,7 @@
                 <a:ea typeface="Arial Unicode MS"/>
                 <a:cs typeface="Arial Unicode MS"/>
               </a:rPr>
-              <a:t>结果总体偏正，但具有明显路线差异；每条路线目前只有一条在线轨迹。</a:t>
+              <a:t>完整历史盘点扩到 17 条路线后，平均增益降为 +0.76，区间 [-0.50,+2.09]。</a:t>
             </a:r>
           </a:p>
           <a:p xmlns:a="http://schemas.openxmlformats.org/drawingml/2006/main">
@@ -8140,7 +8584,7 @@
                 <a:ea typeface="Arial Unicode MS"/>
                 <a:cs typeface="Arial Unicode MS"/>
               </a:rPr>
-              <a:t>95% 区间跨过 0，因此不能称为统计确认或普遍跨领域提升。</a:t>
+              <a:t>因此当前结论是路线特异的正向信号，而不是普遍跨领域提升。</a:t>
             </a:r>
           </a:p>
         </p:txBody>
@@ -16542,7 +16986,7 @@
                 <a:ea typeface="Arial Unicode MS"/>
                 <a:cs typeface="Arial Unicode MS"/>
               </a:rPr>
-              <a:t>同开局压力测试：分子、材料路线超过全部 baseline；Suzuki 的 ICM-BMA 更强。</a:t>
+              <a:t>11 路线审计：相对 target GP 平均 +1.75；面对每条路线事后最强 baseline 为 3 胜、1 平、7 负。</a:t>
             </a:r>
           </a:p>
         </p:txBody>
@@ -20330,7 +20774,7 @@
                 <a:ea typeface="Arial Unicode MS"/>
                 <a:cs typeface="Arial Unicode MS"/>
               </a:rPr>
-              <a:t>100.000</a:t>
+              <a:t>86.875</a:t>
             </a:r>
           </a:p>
         </p:txBody>

</xml_diff>